<commit_message>
ai agent working in side pannel
</commit_message>
<xml_diff>
--- a/deck/03. Immobweb - Deployment.pptx
+++ b/deck/03. Immobweb - Deployment.pptx
@@ -5,18 +5,20 @@
     <p:sldMasterId id="2147483648" r:id="rId4"/>
   </p:sldMasterIdLst>
   <p:notesMasterIdLst>
-    <p:notesMasterId r:id="rId11"/>
+    <p:notesMasterId r:id="rId13"/>
   </p:notesMasterIdLst>
   <p:handoutMasterIdLst>
-    <p:handoutMasterId r:id="rId12"/>
+    <p:handoutMasterId r:id="rId14"/>
   </p:handoutMasterIdLst>
   <p:sldIdLst>
     <p:sldId id="257" r:id="rId5"/>
-    <p:sldId id="410" r:id="rId6"/>
+    <p:sldId id="413" r:id="rId6"/>
     <p:sldId id="412" r:id="rId7"/>
     <p:sldId id="411" r:id="rId8"/>
     <p:sldId id="408" r:id="rId9"/>
     <p:sldId id="409" r:id="rId10"/>
+    <p:sldId id="414" r:id="rId11"/>
+    <p:sldId id="410" r:id="rId12"/>
   </p:sldIdLst>
   <p:sldSz cx="12192000" cy="6858000"/>
   <p:notesSz cx="6858000" cy="9144000"/>
@@ -221,7 +223,7 @@
             <a:pPr rtl="0"/>
             <a:fld id="{023DB037-710F-4A44-BDF0-28DC42F2FAE9}" type="datetime1">
               <a:rPr lang="fr-FR" smtClean="0"/>
-              <a:t>09/07/2025</a:t>
+              <a:t>10/07/2025</a:t>
             </a:fld>
             <a:endParaRPr lang="fr-FR" dirty="0"/>
           </a:p>
@@ -391,7 +393,7 @@
             <a:fld id="{284718FD-5C33-42D8-BCA9-0B83DD06AC51}" type="datetime1">
               <a:rPr lang="fr-FR" smtClean="0"/>
               <a:pPr/>
-              <a:t>09/07/2025</a:t>
+              <a:t>10/07/2025</a:t>
             </a:fld>
             <a:endParaRPr lang="fr-FR" dirty="0"/>
           </a:p>
@@ -1905,6 +1907,327 @@
     <p:extLst>
       <p:ext uri="{BB962C8B-B14F-4D97-AF65-F5344CB8AC3E}">
         <p14:creationId xmlns:p14="http://schemas.microsoft.com/office/powerpoint/2010/main" val="3828286326"/>
+      </p:ext>
+    </p:extLst>
+  </p:cSld>
+  <p:clrMapOvr>
+    <a:masterClrMapping/>
+  </p:clrMapOvr>
+</p:notes>
+</file>
+
+<file path=ppt/notesSlides/notesSlide6.xml><?xml version="1.0" encoding="utf-8"?>
+<p:notes xmlns:a="http://schemas.openxmlformats.org/drawingml/2006/main" xmlns:r="http://schemas.openxmlformats.org/officeDocument/2006/relationships" xmlns:p="http://schemas.openxmlformats.org/presentationml/2006/main">
+  <p:cSld>
+    <p:spTree>
+      <p:nvGrpSpPr>
+        <p:cNvPr id="1" name="">
+          <a:extLst>
+            <a:ext uri="{FF2B5EF4-FFF2-40B4-BE49-F238E27FC236}">
+              <a16:creationId xmlns:a16="http://schemas.microsoft.com/office/drawing/2014/main" id="{35237EB7-82ED-461E-092B-1C4B46751905}"/>
+            </a:ext>
+          </a:extLst>
+        </p:cNvPr>
+        <p:cNvGrpSpPr/>
+        <p:nvPr/>
+      </p:nvGrpSpPr>
+      <p:grpSpPr>
+        <a:xfrm>
+          <a:off x="0" y="0"/>
+          <a:ext cx="0" cy="0"/>
+          <a:chOff x="0" y="0"/>
+          <a:chExt cx="0" cy="0"/>
+        </a:xfrm>
+      </p:grpSpPr>
+      <p:sp>
+        <p:nvSpPr>
+          <p:cNvPr id="2" name="Slide Image Placeholder 1">
+            <a:extLst>
+              <a:ext uri="{FF2B5EF4-FFF2-40B4-BE49-F238E27FC236}">
+                <a16:creationId xmlns:a16="http://schemas.microsoft.com/office/drawing/2014/main" id="{D620906A-1723-FA26-1162-E9E0443B421E}"/>
+              </a:ext>
+            </a:extLst>
+          </p:cNvPr>
+          <p:cNvSpPr>
+            <a:spLocks noGrp="1" noRot="1" noChangeAspect="1"/>
+          </p:cNvSpPr>
+          <p:nvPr>
+            <p:ph type="sldImg"/>
+          </p:nvPr>
+        </p:nvSpPr>
+        <p:spPr/>
+      </p:sp>
+      <p:sp>
+        <p:nvSpPr>
+          <p:cNvPr id="3" name="Notes Placeholder 2">
+            <a:extLst>
+              <a:ext uri="{FF2B5EF4-FFF2-40B4-BE49-F238E27FC236}">
+                <a16:creationId xmlns:a16="http://schemas.microsoft.com/office/drawing/2014/main" id="{9E668E71-A821-DC96-C5FB-1D67F4F5BDE7}"/>
+              </a:ext>
+            </a:extLst>
+          </p:cNvPr>
+          <p:cNvSpPr>
+            <a:spLocks noGrp="1"/>
+          </p:cNvSpPr>
+          <p:nvPr>
+            <p:ph type="body" idx="1"/>
+          </p:nvPr>
+        </p:nvSpPr>
+        <p:spPr/>
+        <p:txBody>
+          <a:bodyPr/>
+          <a:lstStyle/>
+          <a:p>
+            <a:r>
+              <a:rPr lang="en-US" b="1" dirty="0"/>
+              <a:t>Slide – Deployment Strategy (Short Talk)</a:t>
+            </a:r>
+          </a:p>
+          <a:p>
+            <a:endParaRPr lang="en-US" b="1" dirty="0"/>
+          </a:p>
+          <a:p>
+            <a:pPr marL="171450" indent="-171450">
+              <a:buFont typeface="Arial" panose="020B0604020202020204" pitchFamily="34" charset="0"/>
+              <a:buChar char="•"/>
+            </a:pPr>
+            <a:r>
+              <a:rPr lang="en-US" dirty="0"/>
+              <a:t>We adopted a </a:t>
+            </a:r>
+            <a:r>
+              <a:rPr lang="en-US" b="1" dirty="0"/>
+              <a:t>modular two-layer design</a:t>
+            </a:r>
+            <a:r>
+              <a:rPr lang="en-US" dirty="0"/>
+              <a:t>:</a:t>
+            </a:r>
+          </a:p>
+          <a:p>
+            <a:pPr marL="171450" indent="-171450">
+              <a:buFont typeface="Arial" panose="020B0604020202020204" pitchFamily="34" charset="0"/>
+              <a:buChar char="•"/>
+            </a:pPr>
+            <a:r>
+              <a:rPr lang="en-US" dirty="0"/>
+              <a:t>A </a:t>
+            </a:r>
+            <a:r>
+              <a:rPr lang="en-US" dirty="0" err="1"/>
+              <a:t>FastAPI</a:t>
+            </a:r>
+            <a:r>
+              <a:rPr lang="en-US" dirty="0"/>
+              <a:t> backend serving two prediction endpoints.</a:t>
+            </a:r>
+          </a:p>
+          <a:p>
+            <a:pPr marL="171450" indent="-171450">
+              <a:buFont typeface="Arial" panose="020B0604020202020204" pitchFamily="34" charset="0"/>
+              <a:buChar char="•"/>
+            </a:pPr>
+            <a:r>
+              <a:rPr lang="en-US" dirty="0"/>
+              <a:t>A </a:t>
+            </a:r>
+            <a:r>
+              <a:rPr lang="en-US" dirty="0" err="1"/>
+              <a:t>Streamlit</a:t>
+            </a:r>
+            <a:r>
+              <a:rPr lang="en-US" dirty="0"/>
+              <a:t>-based frontend for user interaction.</a:t>
+            </a:r>
+          </a:p>
+          <a:p>
+            <a:pPr marL="171450" indent="-171450">
+              <a:buFont typeface="Arial" panose="020B0604020202020204" pitchFamily="34" charset="0"/>
+              <a:buChar char="•"/>
+            </a:pPr>
+            <a:r>
+              <a:rPr lang="en-US" dirty="0"/>
+              <a:t>This allowed </a:t>
+            </a:r>
+            <a:r>
+              <a:rPr lang="en-US" b="1" dirty="0"/>
+              <a:t>independent development and testing</a:t>
+            </a:r>
+            <a:r>
+              <a:rPr lang="en-US" dirty="0"/>
+              <a:t>, e.g., with Postman.</a:t>
+            </a:r>
+          </a:p>
+          <a:p>
+            <a:pPr marL="171450" indent="-171450">
+              <a:buFont typeface="Arial" panose="020B0604020202020204" pitchFamily="34" charset="0"/>
+              <a:buChar char="•"/>
+            </a:pPr>
+            <a:endParaRPr lang="en-US" dirty="0"/>
+          </a:p>
+          <a:p>
+            <a:pPr marL="171450" indent="-171450">
+              <a:buFont typeface="Arial" panose="020B0604020202020204" pitchFamily="34" charset="0"/>
+              <a:buChar char="•"/>
+            </a:pPr>
+            <a:r>
+              <a:rPr lang="en-US" dirty="0"/>
+              <a:t>We containerized both services with Docker, deployed them separately, and ensured consistent builds across environments. This helped with </a:t>
+            </a:r>
+            <a:r>
+              <a:rPr lang="en-US" b="1" dirty="0"/>
+              <a:t>versioning, testing</a:t>
+            </a:r>
+            <a:r>
+              <a:rPr lang="en-US" dirty="0"/>
+              <a:t>, and </a:t>
+            </a:r>
+            <a:r>
+              <a:rPr lang="en-US" b="1" dirty="0"/>
+              <a:t>parity</a:t>
+            </a:r>
+            <a:r>
+              <a:rPr lang="en-US" dirty="0"/>
+              <a:t> between dev, staging, and production.</a:t>
+            </a:r>
+          </a:p>
+          <a:p>
+            <a:pPr marL="171450" indent="-171450">
+              <a:buFont typeface="Arial" panose="020B0604020202020204" pitchFamily="34" charset="0"/>
+              <a:buChar char="•"/>
+            </a:pPr>
+            <a:endParaRPr lang="en-US" dirty="0"/>
+          </a:p>
+          <a:p>
+            <a:pPr marL="171450" indent="-171450">
+              <a:buFont typeface="Arial" panose="020B0604020202020204" pitchFamily="34" charset="0"/>
+              <a:buChar char="•"/>
+            </a:pPr>
+            <a:r>
+              <a:rPr lang="en-US" dirty="0"/>
+              <a:t>For deployment, we chose </a:t>
+            </a:r>
+            <a:r>
+              <a:rPr lang="en-US" b="1" dirty="0"/>
+              <a:t>Azure</a:t>
+            </a:r>
+            <a:r>
+              <a:rPr lang="en-US" dirty="0"/>
+              <a:t> for its enterprise-grade flexibility:</a:t>
+            </a:r>
+          </a:p>
+          <a:p>
+            <a:pPr marL="628650" lvl="1" indent="-171450">
+              <a:buFont typeface="Arial" panose="020B0604020202020204" pitchFamily="34" charset="0"/>
+              <a:buChar char="•"/>
+            </a:pPr>
+            <a:r>
+              <a:rPr lang="en-US" dirty="0"/>
+              <a:t>We used Azure App Service for both frontend and backend,</a:t>
+            </a:r>
+          </a:p>
+          <a:p>
+            <a:pPr marL="628650" lvl="1" indent="-171450">
+              <a:buFont typeface="Arial" panose="020B0604020202020204" pitchFamily="34" charset="0"/>
+              <a:buChar char="•"/>
+            </a:pPr>
+            <a:r>
+              <a:rPr lang="en-US" dirty="0"/>
+              <a:t>and ACR to securely host Docker images.</a:t>
+            </a:r>
+          </a:p>
+          <a:p>
+            <a:pPr marL="628650" lvl="1" indent="-171450">
+              <a:buFont typeface="Arial" panose="020B0604020202020204" pitchFamily="34" charset="0"/>
+              <a:buChar char="•"/>
+            </a:pPr>
+            <a:endParaRPr lang="en-US" dirty="0"/>
+          </a:p>
+          <a:p>
+            <a:pPr marL="171450" indent="-171450">
+              <a:buFont typeface="Arial" panose="020B0604020202020204" pitchFamily="34" charset="0"/>
+              <a:buChar char="•"/>
+            </a:pPr>
+            <a:r>
+              <a:rPr lang="en-US" dirty="0"/>
+              <a:t>Compared to Render, Azure gives us better control over </a:t>
+            </a:r>
+            <a:r>
+              <a:rPr lang="en-US" b="1" dirty="0"/>
+              <a:t>startup behavior</a:t>
+            </a:r>
+            <a:r>
+              <a:rPr lang="en-US" dirty="0"/>
+              <a:t>, </a:t>
+            </a:r>
+            <a:r>
+              <a:rPr lang="en-US" b="1" dirty="0"/>
+              <a:t>environment variables</a:t>
+            </a:r>
+            <a:r>
+              <a:rPr lang="en-US" dirty="0"/>
+              <a:t>, and </a:t>
+            </a:r>
+            <a:r>
+              <a:rPr lang="en-US" b="1" dirty="0"/>
+              <a:t>logs</a:t>
+            </a:r>
+            <a:r>
+              <a:rPr lang="en-US" dirty="0"/>
+              <a:t>, along with built-in </a:t>
+            </a:r>
+            <a:r>
+              <a:rPr lang="en-US" b="1" dirty="0"/>
+              <a:t>monitoring tools</a:t>
+            </a:r>
+            <a:r>
+              <a:rPr lang="en-US" dirty="0"/>
+              <a:t> and scalable infrastructure.</a:t>
+            </a:r>
+          </a:p>
+          <a:p>
+            <a:pPr marL="171450" indent="-171450">
+              <a:buFont typeface="Arial" panose="020B0604020202020204" pitchFamily="34" charset="0"/>
+              <a:buChar char="•"/>
+            </a:pPr>
+            <a:endParaRPr lang="en-US" dirty="0"/>
+          </a:p>
+        </p:txBody>
+      </p:sp>
+      <p:sp>
+        <p:nvSpPr>
+          <p:cNvPr id="4" name="Slide Number Placeholder 3">
+            <a:extLst>
+              <a:ext uri="{FF2B5EF4-FFF2-40B4-BE49-F238E27FC236}">
+                <a16:creationId xmlns:a16="http://schemas.microsoft.com/office/drawing/2014/main" id="{488FD9D9-44A1-B1C8-984C-541E4300FFDC}"/>
+              </a:ext>
+            </a:extLst>
+          </p:cNvPr>
+          <p:cNvSpPr>
+            <a:spLocks noGrp="1"/>
+          </p:cNvSpPr>
+          <p:nvPr>
+            <p:ph type="sldNum" sz="quarter" idx="5"/>
+          </p:nvPr>
+        </p:nvSpPr>
+        <p:spPr/>
+        <p:txBody>
+          <a:bodyPr/>
+          <a:lstStyle/>
+          <a:p>
+            <a:pPr rtl="0"/>
+            <a:fld id="{6336304E-FDE3-4B4F-A3B7-EBE87F3FA5E2}" type="slidenum">
+              <a:rPr lang="fr-FR" noProof="0" smtClean="0"/>
+              <a:t>8</a:t>
+            </a:fld>
+            <a:endParaRPr lang="fr-FR" noProof="0" dirty="0"/>
+          </a:p>
+        </p:txBody>
+      </p:sp>
+    </p:spTree>
+    <p:extLst>
+      <p:ext uri="{BB962C8B-B14F-4D97-AF65-F5344CB8AC3E}">
+        <p14:creationId xmlns:p14="http://schemas.microsoft.com/office/powerpoint/2010/main" val="1806721230"/>
       </p:ext>
     </p:extLst>
   </p:cSld>
@@ -14386,7 +14709,7 @@
             <a:pPr rtl="0"/>
             <a:fld id="{D4EC748F-88DB-4BA1-B6AB-BE1A47757B27}" type="datetime1">
               <a:rPr lang="fr-FR" noProof="0" smtClean="0"/>
-              <a:t>09/07/2025</a:t>
+              <a:t>10/07/2025</a:t>
             </a:fld>
             <a:endParaRPr lang="fr-FR" noProof="0" dirty="0"/>
           </a:p>
@@ -15056,7 +15379,7 @@
         <p:spPr>
           <a:xfrm>
             <a:off x="515938" y="920090"/>
-            <a:ext cx="4873480" cy="2949703"/>
+            <a:ext cx="5400000" cy="2700000"/>
           </a:xfrm>
           <a:prstGeom prst="roundRect">
             <a:avLst>
@@ -15232,8 +15555,8 @@
         </p:nvSpPr>
         <p:spPr>
           <a:xfrm>
-            <a:off x="5551747" y="920090"/>
-            <a:ext cx="6114792" cy="2949005"/>
+            <a:off x="6195527" y="920090"/>
+            <a:ext cx="5400000" cy="2700000"/>
           </a:xfrm>
           <a:prstGeom prst="roundRect">
             <a:avLst>
@@ -15409,8 +15732,8 @@
         </p:nvSpPr>
         <p:spPr>
           <a:xfrm>
-            <a:off x="515938" y="1024585"/>
-            <a:ext cx="5168582" cy="377910"/>
+            <a:off x="515938" y="1015254"/>
+            <a:ext cx="5400000" cy="377910"/>
           </a:xfrm>
           <a:prstGeom prst="rect">
             <a:avLst/>
@@ -15564,8 +15887,8 @@
         </p:nvSpPr>
         <p:spPr>
           <a:xfrm>
-            <a:off x="6029326" y="1031697"/>
-            <a:ext cx="5168581" cy="377910"/>
+            <a:off x="6195528" y="1022366"/>
+            <a:ext cx="5400000" cy="377910"/>
           </a:xfrm>
           <a:prstGeom prst="rect">
             <a:avLst/>
@@ -15719,8 +16042,8 @@
         </p:nvSpPr>
         <p:spPr>
           <a:xfrm>
-            <a:off x="515938" y="1438456"/>
-            <a:ext cx="4873480" cy="0"/>
+            <a:off x="515938" y="1475780"/>
+            <a:ext cx="5400000" cy="0"/>
           </a:xfrm>
           <a:prstGeom prst="line">
             <a:avLst/>
@@ -15887,8 +16210,8 @@
         </p:nvSpPr>
         <p:spPr>
           <a:xfrm>
-            <a:off x="678266" y="1609248"/>
-            <a:ext cx="4531043" cy="1974672"/>
+            <a:off x="695938" y="1659535"/>
+            <a:ext cx="5040000" cy="1974672"/>
           </a:xfrm>
           <a:prstGeom prst="rect">
             <a:avLst/>
@@ -16016,7 +16339,7 @@
                 </a:solidFill>
                 <a:cs typeface="Segoe UI Light" panose="020B0502040204020203" pitchFamily="34" charset="0"/>
               </a:rPr>
-              <a:t>We adopted a modular </a:t>
+              <a:t>Modular </a:t>
             </a:r>
             <a:r>
               <a:rPr lang="en-US" sz="1500" b="1" dirty="0">
@@ -16218,8 +16541,8 @@
         </p:nvSpPr>
         <p:spPr>
           <a:xfrm>
-            <a:off x="5791199" y="1632242"/>
-            <a:ext cx="5696269" cy="872332"/>
+            <a:off x="6375527" y="1602078"/>
+            <a:ext cx="5040000" cy="2082777"/>
           </a:xfrm>
           <a:prstGeom prst="rect">
             <a:avLst/>
@@ -16351,10 +16674,7 @@
             </a:r>
           </a:p>
           <a:p>
-            <a:pPr marL="539750" indent="-193675">
-              <a:buFont typeface="Arial" panose="020B0604020202020204" pitchFamily="34" charset="0"/>
-              <a:buChar char="•"/>
-            </a:pPr>
+            <a:pPr marL="346075"/>
             <a:r>
               <a:rPr lang="en-US" sz="1500" dirty="0">
                 <a:solidFill>
@@ -16362,14 +16682,11 @@
                 </a:solidFill>
                 <a:cs typeface="Segoe UI Light" panose="020B0502040204020203" pitchFamily="34" charset="0"/>
               </a:rPr>
-              <a:t>fully containerized using Docker</a:t>
-            </a:r>
-          </a:p>
-          <a:p>
-            <a:pPr marL="539750" indent="-193675">
-              <a:buFont typeface="Arial" panose="020B0604020202020204" pitchFamily="34" charset="0"/>
-              <a:buChar char="•"/>
-            </a:pPr>
+              <a:t>-  fully containerized using Docker</a:t>
+            </a:r>
+          </a:p>
+          <a:p>
+            <a:pPr marL="346075"/>
             <a:r>
               <a:rPr lang="en-US" sz="1500" dirty="0">
                 <a:solidFill>
@@ -16377,7 +16694,7 @@
                 </a:solidFill>
                 <a:cs typeface="Segoe UI Light" panose="020B0502040204020203" pitchFamily="34" charset="0"/>
               </a:rPr>
-              <a:t>deployed as isolated services</a:t>
+              <a:t>-  deployed as isolated services</a:t>
             </a:r>
           </a:p>
           <a:p>
@@ -16419,7 +16736,7 @@
                 </a:solidFill>
                 <a:cs typeface="Segoe UI Light" panose="020B0502040204020203" pitchFamily="34" charset="0"/>
               </a:rPr>
-              <a:t>Standardize builds across environments (local and cloud).</a:t>
+              <a:t>Standardize builds across environments (local and cloud)</a:t>
             </a:r>
           </a:p>
           <a:p>
@@ -16434,34 +16751,7 @@
                 </a:solidFill>
                 <a:cs typeface="Segoe UI Light" panose="020B0502040204020203" pitchFamily="34" charset="0"/>
               </a:rPr>
-              <a:t>Simplify testing and versioning.</a:t>
-            </a:r>
-          </a:p>
-          <a:p>
-            <a:pPr marL="193675" indent="-193675">
-              <a:buFont typeface="Arial" panose="020B0604020202020204" pitchFamily="34" charset="0"/>
-              <a:buChar char="•"/>
-            </a:pPr>
-            <a:endParaRPr lang="en-US" sz="1500" dirty="0">
-              <a:solidFill>
-                <a:schemeClr val="accent1"/>
-              </a:solidFill>
-              <a:cs typeface="Segoe UI Light" panose="020B0502040204020203" pitchFamily="34" charset="0"/>
-            </a:endParaRPr>
-          </a:p>
-          <a:p>
-            <a:pPr marL="193675" indent="-193675">
-              <a:buFont typeface="Arial" panose="020B0604020202020204" pitchFamily="34" charset="0"/>
-              <a:buChar char="•"/>
-            </a:pPr>
-            <a:r>
-              <a:rPr lang="en-US" sz="1500" dirty="0">
-                <a:solidFill>
-                  <a:schemeClr val="accent1"/>
-                </a:solidFill>
-                <a:cs typeface="Segoe UI Light" panose="020B0502040204020203" pitchFamily="34" charset="0"/>
-              </a:rPr>
-              <a:t>Ensure parity between dev, staging, and production.</a:t>
+              <a:t>Simplify testing and versioning</a:t>
             </a:r>
           </a:p>
         </p:txBody>
@@ -16480,8 +16770,8 @@
         </p:nvSpPr>
         <p:spPr>
           <a:xfrm>
-            <a:off x="5551747" y="1438456"/>
-            <a:ext cx="6114791" cy="0"/>
+            <a:off x="6195527" y="1475780"/>
+            <a:ext cx="5400000" cy="0"/>
           </a:xfrm>
           <a:prstGeom prst="line">
             <a:avLst/>
@@ -16648,8 +16938,8 @@
         </p:nvSpPr>
         <p:spPr>
           <a:xfrm>
-            <a:off x="515938" y="4040584"/>
-            <a:ext cx="4884740" cy="2303063"/>
+            <a:off x="515938" y="3844631"/>
+            <a:ext cx="5400000" cy="2700000"/>
           </a:xfrm>
           <a:prstGeom prst="roundRect">
             <a:avLst>
@@ -16825,7 +17115,7 @@
         </p:nvSpPr>
         <p:spPr>
           <a:xfrm>
-            <a:off x="515937" y="4167612"/>
+            <a:off x="515937" y="3943668"/>
             <a:ext cx="5376861" cy="377910"/>
           </a:xfrm>
           <a:prstGeom prst="rect">
@@ -16961,242 +17251,8 @@
                 </a:solidFill>
                 <a:cs typeface="Segoe UI Light" panose="020B0502040204020203" pitchFamily="34" charset="0"/>
               </a:rPr>
-              <a:t>Deployment on Azure</a:t>
-            </a:r>
-          </a:p>
-        </p:txBody>
-      </p:sp>
-      <p:sp>
-        <p:nvSpPr>
-          <p:cNvPr id="32" name="Mobilisation &amp; Inputs Gathering">
-            <a:extLst>
-              <a:ext uri="{FF2B5EF4-FFF2-40B4-BE49-F238E27FC236}">
-                <a16:creationId xmlns:a16="http://schemas.microsoft.com/office/drawing/2014/main" id="{0E4337C1-044D-1EF6-D36A-59FD7DE9BE1D}"/>
-              </a:ext>
-            </a:extLst>
-          </p:cNvPr>
-          <p:cNvSpPr txBox="1"/>
-          <p:nvPr/>
-        </p:nvSpPr>
-        <p:spPr>
-          <a:xfrm>
-            <a:off x="805498" y="4717895"/>
-            <a:ext cx="4186757" cy="1141621"/>
-          </a:xfrm>
-          <a:prstGeom prst="rect">
-            <a:avLst/>
-          </a:prstGeom>
-          <a:noFill/>
-          <a:ln w="12700" cap="flat">
-            <a:noFill/>
-            <a:miter lim="400000"/>
-          </a:ln>
-          <a:effectLst/>
-          <a:extLst>
-            <a:ext uri="{C572A759-6A51-4108-AA02-DFA0A04FC94B}">
-              <ma14:wrappingTextBoxFlag xmlns="" xmlns:m="http://schemas.openxmlformats.org/officeDocument/2006/math" xmlns:a14="http://schemas.microsoft.com/office/drawing/2010/main" xmlns:ma14="http://schemas.microsoft.com/office/mac/drawingml/2011/main" xmlns:lc="http://schemas.openxmlformats.org/drawingml/2006/lockedCanvas" val="1"/>
-            </a:ext>
-          </a:extLst>
-        </p:spPr>
-        <p:txBody>
-          <a:bodyPr wrap="square" lIns="35719" tIns="35719" rIns="35719" bIns="35719" numCol="1" anchor="t">
-            <a:noAutofit/>
-          </a:bodyPr>
-          <a:lstStyle>
-            <a:defPPr>
-              <a:defRPr lang="en-US"/>
-            </a:defPPr>
-            <a:lvl1pPr marL="0" algn="l" defTabSz="914400" rtl="0" eaLnBrk="1" latinLnBrk="0" hangingPunct="1">
-              <a:defRPr sz="1800" kern="1200">
-                <a:solidFill>
-                  <a:schemeClr val="tx1"/>
-                </a:solidFill>
-                <a:latin typeface="+mn-lt"/>
-                <a:ea typeface="+mn-ea"/>
-                <a:cs typeface="+mn-cs"/>
-              </a:defRPr>
-            </a:lvl1pPr>
-            <a:lvl2pPr marL="457200" algn="l" defTabSz="914400" rtl="0" eaLnBrk="1" latinLnBrk="0" hangingPunct="1">
-              <a:defRPr sz="1800" kern="1200">
-                <a:solidFill>
-                  <a:schemeClr val="tx1"/>
-                </a:solidFill>
-                <a:latin typeface="+mn-lt"/>
-                <a:ea typeface="+mn-ea"/>
-                <a:cs typeface="+mn-cs"/>
-              </a:defRPr>
-            </a:lvl2pPr>
-            <a:lvl3pPr marL="914400" algn="l" defTabSz="914400" rtl="0" eaLnBrk="1" latinLnBrk="0" hangingPunct="1">
-              <a:defRPr sz="1800" kern="1200">
-                <a:solidFill>
-                  <a:schemeClr val="tx1"/>
-                </a:solidFill>
-                <a:latin typeface="+mn-lt"/>
-                <a:ea typeface="+mn-ea"/>
-                <a:cs typeface="+mn-cs"/>
-              </a:defRPr>
-            </a:lvl3pPr>
-            <a:lvl4pPr marL="1371600" algn="l" defTabSz="914400" rtl="0" eaLnBrk="1" latinLnBrk="0" hangingPunct="1">
-              <a:defRPr sz="1800" kern="1200">
-                <a:solidFill>
-                  <a:schemeClr val="tx1"/>
-                </a:solidFill>
-                <a:latin typeface="+mn-lt"/>
-                <a:ea typeface="+mn-ea"/>
-                <a:cs typeface="+mn-cs"/>
-              </a:defRPr>
-            </a:lvl4pPr>
-            <a:lvl5pPr marL="1828800" algn="l" defTabSz="914400" rtl="0" eaLnBrk="1" latinLnBrk="0" hangingPunct="1">
-              <a:defRPr sz="1800" kern="1200">
-                <a:solidFill>
-                  <a:schemeClr val="tx1"/>
-                </a:solidFill>
-                <a:latin typeface="+mn-lt"/>
-                <a:ea typeface="+mn-ea"/>
-                <a:cs typeface="+mn-cs"/>
-              </a:defRPr>
-            </a:lvl5pPr>
-            <a:lvl6pPr marL="2286000" algn="l" defTabSz="914400" rtl="0" eaLnBrk="1" latinLnBrk="0" hangingPunct="1">
-              <a:defRPr sz="1800" kern="1200">
-                <a:solidFill>
-                  <a:schemeClr val="tx1"/>
-                </a:solidFill>
-                <a:latin typeface="+mn-lt"/>
-                <a:ea typeface="+mn-ea"/>
-                <a:cs typeface="+mn-cs"/>
-              </a:defRPr>
-            </a:lvl6pPr>
-            <a:lvl7pPr marL="2743200" algn="l" defTabSz="914400" rtl="0" eaLnBrk="1" latinLnBrk="0" hangingPunct="1">
-              <a:defRPr sz="1800" kern="1200">
-                <a:solidFill>
-                  <a:schemeClr val="tx1"/>
-                </a:solidFill>
-                <a:latin typeface="+mn-lt"/>
-                <a:ea typeface="+mn-ea"/>
-                <a:cs typeface="+mn-cs"/>
-              </a:defRPr>
-            </a:lvl7pPr>
-            <a:lvl8pPr marL="3200400" algn="l" defTabSz="914400" rtl="0" eaLnBrk="1" latinLnBrk="0" hangingPunct="1">
-              <a:defRPr sz="1800" kern="1200">
-                <a:solidFill>
-                  <a:schemeClr val="tx1"/>
-                </a:solidFill>
-                <a:latin typeface="+mn-lt"/>
-                <a:ea typeface="+mn-ea"/>
-                <a:cs typeface="+mn-cs"/>
-              </a:defRPr>
-            </a:lvl8pPr>
-            <a:lvl9pPr marL="3657600" algn="l" defTabSz="914400" rtl="0" eaLnBrk="1" latinLnBrk="0" hangingPunct="1">
-              <a:defRPr sz="1800" kern="1200">
-                <a:solidFill>
-                  <a:schemeClr val="tx1"/>
-                </a:solidFill>
-                <a:latin typeface="+mn-lt"/>
-                <a:ea typeface="+mn-ea"/>
-                <a:cs typeface="+mn-cs"/>
-              </a:defRPr>
-            </a:lvl9pPr>
-          </a:lstStyle>
-          <a:p>
-            <a:r>
-              <a:rPr lang="en-US" sz="1500" dirty="0">
-                <a:solidFill>
-                  <a:schemeClr val="accent1"/>
-                </a:solidFill>
-                <a:cs typeface="Segoe UI Light" panose="020B0502040204020203" pitchFamily="34" charset="0"/>
-              </a:rPr>
-              <a:t>We chose Azure for its enterprise-grade deployment capabilities and flexibility:</a:t>
-            </a:r>
-          </a:p>
-          <a:p>
-            <a:pPr marL="285750" indent="-285750">
-              <a:buFont typeface="Arial" panose="020B0604020202020204" pitchFamily="34" charset="0"/>
-              <a:buChar char="•"/>
-            </a:pPr>
-            <a:r>
-              <a:rPr lang="en-US" sz="1500" b="1" dirty="0">
-                <a:solidFill>
-                  <a:schemeClr val="accent1"/>
-                </a:solidFill>
-                <a:cs typeface="Segoe UI Light" panose="020B0502040204020203" pitchFamily="34" charset="0"/>
-              </a:rPr>
-              <a:t>Azure App Service </a:t>
-            </a:r>
-            <a:r>
-              <a:rPr lang="en-US" sz="1500" dirty="0">
-                <a:solidFill>
-                  <a:schemeClr val="accent1"/>
-                </a:solidFill>
-                <a:cs typeface="Segoe UI Light" panose="020B0502040204020203" pitchFamily="34" charset="0"/>
-              </a:rPr>
-              <a:t>for both frontend (</a:t>
-            </a:r>
-            <a:r>
-              <a:rPr lang="en-US" sz="1500" dirty="0" err="1">
-                <a:solidFill>
-                  <a:schemeClr val="accent1"/>
-                </a:solidFill>
-                <a:cs typeface="Segoe UI Light" panose="020B0502040204020203" pitchFamily="34" charset="0"/>
-              </a:rPr>
-              <a:t>Streamlit</a:t>
-            </a:r>
-            <a:r>
-              <a:rPr lang="en-US" sz="1500" dirty="0">
-                <a:solidFill>
-                  <a:schemeClr val="accent1"/>
-                </a:solidFill>
-                <a:cs typeface="Segoe UI Light" panose="020B0502040204020203" pitchFamily="34" charset="0"/>
-              </a:rPr>
-              <a:t>) and backend (</a:t>
-            </a:r>
-            <a:r>
-              <a:rPr lang="en-US" sz="1500" dirty="0" err="1">
-                <a:solidFill>
-                  <a:schemeClr val="accent1"/>
-                </a:solidFill>
-                <a:cs typeface="Segoe UI Light" panose="020B0502040204020203" pitchFamily="34" charset="0"/>
-              </a:rPr>
-              <a:t>FastAPI</a:t>
-            </a:r>
-            <a:r>
-              <a:rPr lang="en-US" sz="1500" dirty="0">
-                <a:solidFill>
-                  <a:schemeClr val="accent1"/>
-                </a:solidFill>
-                <a:cs typeface="Segoe UI Light" panose="020B0502040204020203" pitchFamily="34" charset="0"/>
-              </a:rPr>
-              <a:t>).</a:t>
-            </a:r>
-          </a:p>
-          <a:p>
-            <a:pPr marL="285750" indent="-285750">
-              <a:buFont typeface="Arial" panose="020B0604020202020204" pitchFamily="34" charset="0"/>
-              <a:buChar char="•"/>
-            </a:pPr>
-            <a:r>
-              <a:rPr lang="en-US" sz="1500" b="1" dirty="0">
-                <a:solidFill>
-                  <a:schemeClr val="accent1"/>
-                </a:solidFill>
-                <a:cs typeface="Segoe UI Light" panose="020B0502040204020203" pitchFamily="34" charset="0"/>
-              </a:rPr>
-              <a:t>Azure Container Registry (ACR)</a:t>
-            </a:r>
-            <a:r>
-              <a:rPr lang="en-US" sz="1500" dirty="0">
-                <a:solidFill>
-                  <a:schemeClr val="accent1"/>
-                </a:solidFill>
-                <a:cs typeface="Segoe UI Light" panose="020B0502040204020203" pitchFamily="34" charset="0"/>
-              </a:rPr>
-              <a:t> to host Docker images securely.</a:t>
-            </a:r>
-            <a:endParaRPr lang="fr-BE" sz="1500" dirty="0">
-              <a:solidFill>
-                <a:schemeClr val="accent1"/>
-              </a:solidFill>
-              <a:cs typeface="Segoe UI Light" panose="020B0502040204020203" pitchFamily="34" charset="0"/>
-            </a:endParaRPr>
+              <a:t>Deployment on Render</a:t>
+            </a:r>
           </a:p>
         </p:txBody>
       </p:sp>
@@ -17214,8 +17270,8 @@
         </p:nvSpPr>
         <p:spPr>
           <a:xfrm>
-            <a:off x="515938" y="4592513"/>
-            <a:ext cx="4873480" cy="0"/>
+            <a:off x="515938" y="4410725"/>
+            <a:ext cx="5400000" cy="0"/>
           </a:xfrm>
           <a:prstGeom prst="line">
             <a:avLst/>
@@ -17382,8 +17438,8 @@
         </p:nvSpPr>
         <p:spPr>
           <a:xfrm>
-            <a:off x="5551747" y="4038756"/>
-            <a:ext cx="6148762" cy="2304891"/>
+            <a:off x="6195527" y="3842804"/>
+            <a:ext cx="5400000" cy="2700000"/>
           </a:xfrm>
           <a:prstGeom prst="roundRect">
             <a:avLst>
@@ -17559,8 +17615,8 @@
         </p:nvSpPr>
         <p:spPr>
           <a:xfrm>
-            <a:off x="5551746" y="4169655"/>
-            <a:ext cx="6148761" cy="377910"/>
+            <a:off x="6195527" y="3943668"/>
+            <a:ext cx="5400000" cy="377910"/>
           </a:xfrm>
           <a:prstGeom prst="rect">
             <a:avLst/>
@@ -17714,8 +17770,8 @@
         </p:nvSpPr>
         <p:spPr>
           <a:xfrm>
-            <a:off x="5735782" y="4717226"/>
-            <a:ext cx="5964725" cy="1141621"/>
+            <a:off x="6375527" y="4521275"/>
+            <a:ext cx="5040000" cy="1141621"/>
           </a:xfrm>
           <a:prstGeom prst="rect">
             <a:avLst/>
@@ -17890,21 +17946,6 @@
               </a:rPr>
               <a:t>startup behavior</a:t>
             </a:r>
-            <a:r>
-              <a:rPr lang="en-US" sz="1500" dirty="0">
-                <a:solidFill>
-                  <a:schemeClr val="accent1"/>
-                </a:solidFill>
-                <a:cs typeface="Segoe UI Light" panose="020B0502040204020203" pitchFamily="34" charset="0"/>
-              </a:rPr>
-              <a:t>.</a:t>
-            </a:r>
-          </a:p>
-          <a:p>
-            <a:pPr marL="285750" indent="-285750">
-              <a:buFont typeface="Arial" panose="020B0604020202020204" pitchFamily="34" charset="0"/>
-              <a:buChar char="•"/>
-            </a:pPr>
             <a:endParaRPr lang="en-US" sz="1500" dirty="0">
               <a:solidFill>
                 <a:schemeClr val="accent1"/>
@@ -17941,12 +17982,15 @@
               <a:buFont typeface="Arial" panose="020B0604020202020204" pitchFamily="34" charset="0"/>
               <a:buChar char="•"/>
             </a:pPr>
-            <a:endParaRPr lang="en-US" sz="1500" dirty="0">
-              <a:solidFill>
-                <a:schemeClr val="accent1"/>
-              </a:solidFill>
-              <a:cs typeface="Segoe UI Light" panose="020B0502040204020203" pitchFamily="34" charset="0"/>
-            </a:endParaRPr>
+            <a:r>
+              <a:rPr lang="en-US" sz="1500" dirty="0">
+                <a:solidFill>
+                  <a:schemeClr val="accent1"/>
+                </a:solidFill>
+                <a:cs typeface="Segoe UI Light" panose="020B0502040204020203" pitchFamily="34" charset="0"/>
+              </a:rPr>
+              <a:t>Stable and scalable infrastructure, with support for production-grade workloads</a:t>
+            </a:r>
           </a:p>
           <a:p>
             <a:pPr marL="285750" indent="-285750">
@@ -17960,7 +18004,7 @@
                 </a:solidFill>
                 <a:cs typeface="Segoe UI Light" panose="020B0502040204020203" pitchFamily="34" charset="0"/>
               </a:rPr>
-              <a:t>Stable and scalable infrastructure, with support for production-grade workloads.</a:t>
+              <a:t>Azure Container Registry (ACR) to host Docker images securely.</a:t>
             </a:r>
             <a:endParaRPr lang="fr-BE" sz="1500" dirty="0">
               <a:solidFill>
@@ -17969,6 +18013,18 @@
               <a:cs typeface="Segoe UI Light" panose="020B0502040204020203" pitchFamily="34" charset="0"/>
             </a:endParaRPr>
           </a:p>
+          <a:p>
+            <a:pPr marL="285750" indent="-285750">
+              <a:buFont typeface="Arial" panose="020B0604020202020204" pitchFamily="34" charset="0"/>
+              <a:buChar char="•"/>
+            </a:pPr>
+            <a:endParaRPr lang="fr-BE" sz="1500" dirty="0">
+              <a:solidFill>
+                <a:schemeClr val="accent1"/>
+              </a:solidFill>
+              <a:cs typeface="Segoe UI Light" panose="020B0502040204020203" pitchFamily="34" charset="0"/>
+            </a:endParaRPr>
+          </a:p>
         </p:txBody>
       </p:sp>
       <p:sp>
@@ -17985,8 +18041,8 @@
         </p:nvSpPr>
         <p:spPr>
           <a:xfrm>
-            <a:off x="5551747" y="4606676"/>
-            <a:ext cx="6148762" cy="0"/>
+            <a:off x="6195527" y="4410725"/>
+            <a:ext cx="5400000" cy="0"/>
           </a:xfrm>
           <a:prstGeom prst="line">
             <a:avLst/>
@@ -18139,10 +18195,227 @@
           </a:p>
         </p:txBody>
       </p:sp>
+      <p:sp>
+        <p:nvSpPr>
+          <p:cNvPr id="7" name="Mobilisation &amp; Inputs Gathering">
+            <a:extLst>
+              <a:ext uri="{FF2B5EF4-FFF2-40B4-BE49-F238E27FC236}">
+                <a16:creationId xmlns:a16="http://schemas.microsoft.com/office/drawing/2014/main" id="{22916452-DF64-277E-15A0-FA40F805A03F}"/>
+              </a:ext>
+            </a:extLst>
+          </p:cNvPr>
+          <p:cNvSpPr txBox="1"/>
+          <p:nvPr/>
+        </p:nvSpPr>
+        <p:spPr>
+          <a:xfrm>
+            <a:off x="695938" y="4521275"/>
+            <a:ext cx="5040000" cy="1141621"/>
+          </a:xfrm>
+          <a:prstGeom prst="rect">
+            <a:avLst/>
+          </a:prstGeom>
+          <a:noFill/>
+          <a:ln w="12700" cap="flat">
+            <a:noFill/>
+            <a:miter lim="400000"/>
+          </a:ln>
+          <a:effectLst/>
+          <a:extLst>
+            <a:ext uri="{C572A759-6A51-4108-AA02-DFA0A04FC94B}">
+              <ma14:wrappingTextBoxFlag xmlns="" xmlns:m="http://schemas.openxmlformats.org/officeDocument/2006/math" xmlns:a14="http://schemas.microsoft.com/office/drawing/2010/main" xmlns:ma14="http://schemas.microsoft.com/office/mac/drawingml/2011/main" xmlns:lc="http://schemas.openxmlformats.org/drawingml/2006/lockedCanvas" val="1"/>
+            </a:ext>
+          </a:extLst>
+        </p:spPr>
+        <p:txBody>
+          <a:bodyPr wrap="square" lIns="35719" tIns="35719" rIns="35719" bIns="35719" numCol="1" anchor="t">
+            <a:noAutofit/>
+          </a:bodyPr>
+          <a:lstStyle>
+            <a:defPPr>
+              <a:defRPr lang="en-US"/>
+            </a:defPPr>
+            <a:lvl1pPr marL="0" algn="l" defTabSz="914400" rtl="0" eaLnBrk="1" latinLnBrk="0" hangingPunct="1">
+              <a:defRPr sz="1800" kern="1200">
+                <a:solidFill>
+                  <a:schemeClr val="tx1"/>
+                </a:solidFill>
+                <a:latin typeface="+mn-lt"/>
+                <a:ea typeface="+mn-ea"/>
+                <a:cs typeface="+mn-cs"/>
+              </a:defRPr>
+            </a:lvl1pPr>
+            <a:lvl2pPr marL="457200" algn="l" defTabSz="914400" rtl="0" eaLnBrk="1" latinLnBrk="0" hangingPunct="1">
+              <a:defRPr sz="1800" kern="1200">
+                <a:solidFill>
+                  <a:schemeClr val="tx1"/>
+                </a:solidFill>
+                <a:latin typeface="+mn-lt"/>
+                <a:ea typeface="+mn-ea"/>
+                <a:cs typeface="+mn-cs"/>
+              </a:defRPr>
+            </a:lvl2pPr>
+            <a:lvl3pPr marL="914400" algn="l" defTabSz="914400" rtl="0" eaLnBrk="1" latinLnBrk="0" hangingPunct="1">
+              <a:defRPr sz="1800" kern="1200">
+                <a:solidFill>
+                  <a:schemeClr val="tx1"/>
+                </a:solidFill>
+                <a:latin typeface="+mn-lt"/>
+                <a:ea typeface="+mn-ea"/>
+                <a:cs typeface="+mn-cs"/>
+              </a:defRPr>
+            </a:lvl3pPr>
+            <a:lvl4pPr marL="1371600" algn="l" defTabSz="914400" rtl="0" eaLnBrk="1" latinLnBrk="0" hangingPunct="1">
+              <a:defRPr sz="1800" kern="1200">
+                <a:solidFill>
+                  <a:schemeClr val="tx1"/>
+                </a:solidFill>
+                <a:latin typeface="+mn-lt"/>
+                <a:ea typeface="+mn-ea"/>
+                <a:cs typeface="+mn-cs"/>
+              </a:defRPr>
+            </a:lvl4pPr>
+            <a:lvl5pPr marL="1828800" algn="l" defTabSz="914400" rtl="0" eaLnBrk="1" latinLnBrk="0" hangingPunct="1">
+              <a:defRPr sz="1800" kern="1200">
+                <a:solidFill>
+                  <a:schemeClr val="tx1"/>
+                </a:solidFill>
+                <a:latin typeface="+mn-lt"/>
+                <a:ea typeface="+mn-ea"/>
+                <a:cs typeface="+mn-cs"/>
+              </a:defRPr>
+            </a:lvl5pPr>
+            <a:lvl6pPr marL="2286000" algn="l" defTabSz="914400" rtl="0" eaLnBrk="1" latinLnBrk="0" hangingPunct="1">
+              <a:defRPr sz="1800" kern="1200">
+                <a:solidFill>
+                  <a:schemeClr val="tx1"/>
+                </a:solidFill>
+                <a:latin typeface="+mn-lt"/>
+                <a:ea typeface="+mn-ea"/>
+                <a:cs typeface="+mn-cs"/>
+              </a:defRPr>
+            </a:lvl6pPr>
+            <a:lvl7pPr marL="2743200" algn="l" defTabSz="914400" rtl="0" eaLnBrk="1" latinLnBrk="0" hangingPunct="1">
+              <a:defRPr sz="1800" kern="1200">
+                <a:solidFill>
+                  <a:schemeClr val="tx1"/>
+                </a:solidFill>
+                <a:latin typeface="+mn-lt"/>
+                <a:ea typeface="+mn-ea"/>
+                <a:cs typeface="+mn-cs"/>
+              </a:defRPr>
+            </a:lvl7pPr>
+            <a:lvl8pPr marL="3200400" algn="l" defTabSz="914400" rtl="0" eaLnBrk="1" latinLnBrk="0" hangingPunct="1">
+              <a:defRPr sz="1800" kern="1200">
+                <a:solidFill>
+                  <a:schemeClr val="tx1"/>
+                </a:solidFill>
+                <a:latin typeface="+mn-lt"/>
+                <a:ea typeface="+mn-ea"/>
+                <a:cs typeface="+mn-cs"/>
+              </a:defRPr>
+            </a:lvl8pPr>
+            <a:lvl9pPr marL="3657600" algn="l" defTabSz="914400" rtl="0" eaLnBrk="1" latinLnBrk="0" hangingPunct="1">
+              <a:defRPr sz="1800" kern="1200">
+                <a:solidFill>
+                  <a:schemeClr val="tx1"/>
+                </a:solidFill>
+                <a:latin typeface="+mn-lt"/>
+                <a:ea typeface="+mn-ea"/>
+                <a:cs typeface="+mn-cs"/>
+              </a:defRPr>
+            </a:lvl9pPr>
+          </a:lstStyle>
+          <a:p>
+            <a:pPr marL="285750" indent="-285750">
+              <a:buFont typeface="Arial" panose="020B0604020202020204" pitchFamily="34" charset="0"/>
+              <a:buChar char="•"/>
+            </a:pPr>
+            <a:r>
+              <a:rPr lang="en-US" sz="1500" dirty="0">
+                <a:solidFill>
+                  <a:schemeClr val="accent1"/>
+                </a:solidFill>
+                <a:cs typeface="Segoe UI Light" panose="020B0502040204020203" pitchFamily="34" charset="0"/>
+              </a:rPr>
+              <a:t>2 Web services deployed using Render:</a:t>
+            </a:r>
+          </a:p>
+          <a:p>
+            <a:pPr marL="742950" lvl="1" indent="-285750">
+              <a:buFontTx/>
+              <a:buChar char="-"/>
+            </a:pPr>
+            <a:r>
+              <a:rPr lang="en-US" sz="1500" dirty="0">
+                <a:solidFill>
+                  <a:schemeClr val="accent1"/>
+                </a:solidFill>
+                <a:cs typeface="Segoe UI Light" panose="020B0502040204020203" pitchFamily="34" charset="0"/>
+              </a:rPr>
+              <a:t>API</a:t>
+            </a:r>
+          </a:p>
+          <a:p>
+            <a:pPr marL="742950" lvl="1" indent="-285750">
+              <a:buFontTx/>
+              <a:buChar char="-"/>
+            </a:pPr>
+            <a:r>
+              <a:rPr lang="en-US" sz="1500" dirty="0">
+                <a:solidFill>
+                  <a:schemeClr val="accent1"/>
+                </a:solidFill>
+                <a:cs typeface="Segoe UI Light" panose="020B0502040204020203" pitchFamily="34" charset="0"/>
+              </a:rPr>
+              <a:t>Streamlit – UI</a:t>
+            </a:r>
+          </a:p>
+          <a:p>
+            <a:pPr marL="742950" lvl="1" indent="-285750">
+              <a:buFontTx/>
+              <a:buChar char="-"/>
+            </a:pPr>
+            <a:endParaRPr lang="en-US" sz="1500" dirty="0">
+              <a:solidFill>
+                <a:schemeClr val="accent1"/>
+              </a:solidFill>
+              <a:cs typeface="Segoe UI Light" panose="020B0502040204020203" pitchFamily="34" charset="0"/>
+            </a:endParaRPr>
+          </a:p>
+          <a:p>
+            <a:pPr marL="285750" indent="-285750">
+              <a:buFont typeface="Arial" panose="020B0604020202020204" pitchFamily="34" charset="0"/>
+              <a:buChar char="•"/>
+            </a:pPr>
+            <a:r>
+              <a:rPr lang="en-US" sz="1500" dirty="0">
+                <a:solidFill>
+                  <a:schemeClr val="accent1"/>
+                </a:solidFill>
+                <a:cs typeface="Segoe UI Light" panose="020B0502040204020203" pitchFamily="34" charset="0"/>
+              </a:rPr>
+              <a:t>Limited functionality on free version (API error 429 Too Many requests)</a:t>
+            </a:r>
+          </a:p>
+          <a:p>
+            <a:pPr marL="285750" indent="-285750">
+              <a:buFont typeface="Arial" panose="020B0604020202020204" pitchFamily="34" charset="0"/>
+              <a:buChar char="•"/>
+            </a:pPr>
+            <a:endParaRPr lang="fr-BE" sz="1500" dirty="0">
+              <a:solidFill>
+                <a:schemeClr val="accent1"/>
+              </a:solidFill>
+              <a:cs typeface="Segoe UI Light" panose="020B0502040204020203" pitchFamily="34" charset="0"/>
+            </a:endParaRPr>
+          </a:p>
+        </p:txBody>
+      </p:sp>
     </p:spTree>
     <p:extLst>
       <p:ext uri="{BB962C8B-B14F-4D97-AF65-F5344CB8AC3E}">
-        <p14:creationId xmlns:p14="http://schemas.microsoft.com/office/powerpoint/2010/main" val="2741167990"/>
+        <p14:creationId xmlns:p14="http://schemas.microsoft.com/office/powerpoint/2010/main" val="2601598037"/>
       </p:ext>
     </p:extLst>
   </p:cSld>
@@ -18569,7 +18842,7 @@
           <a:effectLst/>
           <a:extLst>
             <a:ext uri="{C572A759-6A51-4108-AA02-DFA0A04FC94B}">
-              <ma14:wrappingTextBoxFlag xmlns="" xmlns:m="http://schemas.openxmlformats.org/officeDocument/2006/math" xmlns:a14="http://schemas.microsoft.com/office/drawing/2010/main" xmlns:ma14="http://schemas.microsoft.com/office/mac/drawingml/2011/main" xmlns:lc="http://schemas.openxmlformats.org/drawingml/2006/lockedCanvas" val="1"/>
+              <ma14:wrappingTextBoxFlag xmlns:lc="http://schemas.openxmlformats.org/drawingml/2006/lockedCanvas" xmlns:ma14="http://schemas.microsoft.com/office/mac/drawingml/2011/main" xmlns:a14="http://schemas.microsoft.com/office/drawing/2010/main" xmlns:m="http://schemas.openxmlformats.org/officeDocument/2006/math" xmlns="" val="1"/>
             </a:ext>
           </a:extLst>
         </p:spPr>
@@ -18898,7 +19171,7 @@
           <a:effectLst/>
           <a:extLst>
             <a:ext uri="{C572A759-6A51-4108-AA02-DFA0A04FC94B}">
-              <ma14:wrappingTextBoxFlag xmlns="" xmlns:m="http://schemas.openxmlformats.org/officeDocument/2006/math" xmlns:a14="http://schemas.microsoft.com/office/drawing/2010/main" xmlns:ma14="http://schemas.microsoft.com/office/mac/drawingml/2011/main" xmlns:lc="http://schemas.openxmlformats.org/drawingml/2006/lockedCanvas" val="1"/>
+              <ma14:wrappingTextBoxFlag xmlns:lc="http://schemas.openxmlformats.org/drawingml/2006/lockedCanvas" xmlns:ma14="http://schemas.microsoft.com/office/mac/drawingml/2011/main" xmlns:a14="http://schemas.microsoft.com/office/drawing/2010/main" xmlns:m="http://schemas.openxmlformats.org/officeDocument/2006/math" xmlns="" val="1"/>
             </a:ext>
           </a:extLst>
         </p:spPr>
@@ -19280,7 +19553,7 @@
           <a:effectLst/>
           <a:extLst>
             <a:ext uri="{C572A759-6A51-4108-AA02-DFA0A04FC94B}">
-              <ma14:wrappingTextBoxFlag xmlns="" xmlns:m="http://schemas.openxmlformats.org/officeDocument/2006/math" xmlns:a14="http://schemas.microsoft.com/office/drawing/2010/main" xmlns:ma14="http://schemas.microsoft.com/office/mac/drawingml/2011/main" xmlns:lc="http://schemas.openxmlformats.org/drawingml/2006/lockedCanvas" val="1"/>
+              <ma14:wrappingTextBoxFlag xmlns:lc="http://schemas.openxmlformats.org/drawingml/2006/lockedCanvas" xmlns:ma14="http://schemas.microsoft.com/office/mac/drawingml/2011/main" xmlns:a14="http://schemas.microsoft.com/office/drawing/2010/main" xmlns:m="http://schemas.openxmlformats.org/officeDocument/2006/math" xmlns="" val="1"/>
             </a:ext>
           </a:extLst>
         </p:spPr>
@@ -19441,7 +19714,7 @@
           <a:effectLst/>
           <a:extLst>
             <a:ext uri="{C572A759-6A51-4108-AA02-DFA0A04FC94B}">
-              <ma14:wrappingTextBoxFlag xmlns="" xmlns:m="http://schemas.openxmlformats.org/officeDocument/2006/math" xmlns:a14="http://schemas.microsoft.com/office/drawing/2010/main" xmlns:ma14="http://schemas.microsoft.com/office/mac/drawingml/2011/main" xmlns:lc="http://schemas.openxmlformats.org/drawingml/2006/lockedCanvas" val="1"/>
+              <ma14:wrappingTextBoxFlag xmlns:lc="http://schemas.openxmlformats.org/drawingml/2006/lockedCanvas" xmlns:ma14="http://schemas.microsoft.com/office/mac/drawingml/2011/main" xmlns:a14="http://schemas.microsoft.com/office/drawing/2010/main" xmlns:m="http://schemas.openxmlformats.org/officeDocument/2006/math" xmlns="" val="1"/>
             </a:ext>
           </a:extLst>
         </p:spPr>
@@ -21632,6 +21905,3242 @@
     <p:extLst>
       <p:ext uri="{BB962C8B-B14F-4D97-AF65-F5344CB8AC3E}">
         <p14:creationId xmlns:p14="http://schemas.microsoft.com/office/powerpoint/2010/main" val="298102414"/>
+      </p:ext>
+    </p:extLst>
+  </p:cSld>
+  <p:clrMapOvr>
+    <a:masterClrMapping/>
+  </p:clrMapOvr>
+</p:sld>
+</file>
+
+<file path=ppt/slides/slide7.xml><?xml version="1.0" encoding="utf-8"?>
+<p:sld xmlns:a="http://schemas.openxmlformats.org/drawingml/2006/main" xmlns:r="http://schemas.openxmlformats.org/officeDocument/2006/relationships" xmlns:p="http://schemas.openxmlformats.org/presentationml/2006/main">
+  <p:cSld>
+    <p:spTree>
+      <p:nvGrpSpPr>
+        <p:cNvPr id="1" name=""/>
+        <p:cNvGrpSpPr/>
+        <p:nvPr/>
+      </p:nvGrpSpPr>
+      <p:grpSpPr>
+        <a:xfrm>
+          <a:off x="0" y="0"/>
+          <a:ext cx="0" cy="0"/>
+          <a:chOff x="0" y="0"/>
+          <a:chExt cx="0" cy="0"/>
+        </a:xfrm>
+      </p:grpSpPr>
+      <p:sp>
+        <p:nvSpPr>
+          <p:cNvPr id="2" name="Title 1">
+            <a:extLst>
+              <a:ext uri="{FF2B5EF4-FFF2-40B4-BE49-F238E27FC236}">
+                <a16:creationId xmlns:a16="http://schemas.microsoft.com/office/drawing/2014/main" id="{89E133CB-3CFD-82E3-86E9-0CB6D81F6A9B}"/>
+              </a:ext>
+            </a:extLst>
+          </p:cNvPr>
+          <p:cNvSpPr>
+            <a:spLocks noGrp="1"/>
+          </p:cNvSpPr>
+          <p:nvPr>
+            <p:ph type="title"/>
+          </p:nvPr>
+        </p:nvSpPr>
+        <p:spPr>
+          <a:xfrm>
+            <a:off x="409614" y="2628590"/>
+            <a:ext cx="11150600" cy="920336"/>
+          </a:xfrm>
+        </p:spPr>
+        <p:txBody>
+          <a:bodyPr/>
+          <a:lstStyle/>
+          <a:p>
+            <a:pPr algn="ctr"/>
+            <a:r>
+              <a:rPr lang="en-US" dirty="0"/>
+              <a:t>Backup slide</a:t>
+            </a:r>
+            <a:endParaRPr lang="fr-BE" dirty="0"/>
+          </a:p>
+        </p:txBody>
+      </p:sp>
+    </p:spTree>
+    <p:extLst>
+      <p:ext uri="{BB962C8B-B14F-4D97-AF65-F5344CB8AC3E}">
+        <p14:creationId xmlns:p14="http://schemas.microsoft.com/office/powerpoint/2010/main" val="2038718713"/>
+      </p:ext>
+    </p:extLst>
+  </p:cSld>
+  <p:clrMapOvr>
+    <a:masterClrMapping/>
+  </p:clrMapOvr>
+</p:sld>
+</file>
+
+<file path=ppt/slides/slide8.xml><?xml version="1.0" encoding="utf-8"?>
+<p:sld xmlns:a="http://schemas.openxmlformats.org/drawingml/2006/main" xmlns:r="http://schemas.openxmlformats.org/officeDocument/2006/relationships" xmlns:p="http://schemas.openxmlformats.org/presentationml/2006/main">
+  <p:cSld>
+    <p:spTree>
+      <p:nvGrpSpPr>
+        <p:cNvPr id="1" name="">
+          <a:extLst>
+            <a:ext uri="{FF2B5EF4-FFF2-40B4-BE49-F238E27FC236}">
+              <a16:creationId xmlns:a16="http://schemas.microsoft.com/office/drawing/2014/main" id="{915A0369-0A78-FEF2-B79D-76AB899AB17C}"/>
+            </a:ext>
+          </a:extLst>
+        </p:cNvPr>
+        <p:cNvGrpSpPr/>
+        <p:nvPr/>
+      </p:nvGrpSpPr>
+      <p:grpSpPr>
+        <a:xfrm>
+          <a:off x="0" y="0"/>
+          <a:ext cx="0" cy="0"/>
+          <a:chOff x="0" y="0"/>
+          <a:chExt cx="0" cy="0"/>
+        </a:xfrm>
+      </p:grpSpPr>
+      <p:sp>
+        <p:nvSpPr>
+          <p:cNvPr id="2" name="Title 1">
+            <a:extLst>
+              <a:ext uri="{FF2B5EF4-FFF2-40B4-BE49-F238E27FC236}">
+                <a16:creationId xmlns:a16="http://schemas.microsoft.com/office/drawing/2014/main" id="{A2E98117-0824-1B3E-C227-AEC2FE18B2DF}"/>
+              </a:ext>
+            </a:extLst>
+          </p:cNvPr>
+          <p:cNvSpPr>
+            <a:spLocks noGrp="1"/>
+          </p:cNvSpPr>
+          <p:nvPr>
+            <p:ph type="title"/>
+          </p:nvPr>
+        </p:nvSpPr>
+        <p:spPr>
+          <a:xfrm>
+            <a:off x="515938" y="246621"/>
+            <a:ext cx="11150600" cy="479684"/>
+          </a:xfrm>
+        </p:spPr>
+        <p:txBody>
+          <a:bodyPr/>
+          <a:lstStyle/>
+          <a:p>
+            <a:r>
+              <a:rPr lang="en-US" noProof="0" dirty="0">
+                <a:solidFill>
+                  <a:schemeClr val="accent2"/>
+                </a:solidFill>
+              </a:rPr>
+              <a:t>Deployment strategy</a:t>
+            </a:r>
+          </a:p>
+        </p:txBody>
+      </p:sp>
+      <p:sp>
+        <p:nvSpPr>
+          <p:cNvPr id="4" name="Rounded Rectangle">
+            <a:extLst>
+              <a:ext uri="{FF2B5EF4-FFF2-40B4-BE49-F238E27FC236}">
+                <a16:creationId xmlns:a16="http://schemas.microsoft.com/office/drawing/2014/main" id="{4D164BD0-FBD9-B1B3-22AD-88BCD18EAE6E}"/>
+              </a:ext>
+            </a:extLst>
+          </p:cNvPr>
+          <p:cNvSpPr/>
+          <p:nvPr/>
+        </p:nvSpPr>
+        <p:spPr>
+          <a:xfrm>
+            <a:off x="515938" y="920090"/>
+            <a:ext cx="4873480" cy="2949703"/>
+          </a:xfrm>
+          <a:prstGeom prst="roundRect">
+            <a:avLst>
+              <a:gd name="adj" fmla="val 3067"/>
+            </a:avLst>
+          </a:prstGeom>
+          <a:solidFill>
+            <a:schemeClr val="bg1">
+              <a:alpha val="87000"/>
+            </a:schemeClr>
+          </a:solidFill>
+          <a:ln w="12700" cap="flat">
+            <a:noFill/>
+            <a:miter lim="400000"/>
+          </a:ln>
+          <a:effectLst>
+            <a:outerShdw blurRad="952500" dist="444500" dir="5400000" rotWithShape="0">
+              <a:srgbClr val="000000">
+                <a:alpha val="15000"/>
+              </a:srgbClr>
+            </a:outerShdw>
+          </a:effectLst>
+        </p:spPr>
+        <p:txBody>
+          <a:bodyPr wrap="square" lIns="0" tIns="0" rIns="0" bIns="0" numCol="1" anchor="ctr">
+            <a:noAutofit/>
+          </a:bodyPr>
+          <a:lstStyle>
+            <a:defPPr>
+              <a:defRPr lang="en-US"/>
+            </a:defPPr>
+            <a:lvl1pPr marL="0" algn="l" defTabSz="914400" rtl="0" eaLnBrk="1" latinLnBrk="0" hangingPunct="1">
+              <a:defRPr sz="1800" kern="1200">
+                <a:solidFill>
+                  <a:schemeClr val="tx1"/>
+                </a:solidFill>
+                <a:latin typeface="+mn-lt"/>
+                <a:ea typeface="+mn-ea"/>
+                <a:cs typeface="+mn-cs"/>
+              </a:defRPr>
+            </a:lvl1pPr>
+            <a:lvl2pPr marL="457200" algn="l" defTabSz="914400" rtl="0" eaLnBrk="1" latinLnBrk="0" hangingPunct="1">
+              <a:defRPr sz="1800" kern="1200">
+                <a:solidFill>
+                  <a:schemeClr val="tx1"/>
+                </a:solidFill>
+                <a:latin typeface="+mn-lt"/>
+                <a:ea typeface="+mn-ea"/>
+                <a:cs typeface="+mn-cs"/>
+              </a:defRPr>
+            </a:lvl2pPr>
+            <a:lvl3pPr marL="914400" algn="l" defTabSz="914400" rtl="0" eaLnBrk="1" latinLnBrk="0" hangingPunct="1">
+              <a:defRPr sz="1800" kern="1200">
+                <a:solidFill>
+                  <a:schemeClr val="tx1"/>
+                </a:solidFill>
+                <a:latin typeface="+mn-lt"/>
+                <a:ea typeface="+mn-ea"/>
+                <a:cs typeface="+mn-cs"/>
+              </a:defRPr>
+            </a:lvl3pPr>
+            <a:lvl4pPr marL="1371600" algn="l" defTabSz="914400" rtl="0" eaLnBrk="1" latinLnBrk="0" hangingPunct="1">
+              <a:defRPr sz="1800" kern="1200">
+                <a:solidFill>
+                  <a:schemeClr val="tx1"/>
+                </a:solidFill>
+                <a:latin typeface="+mn-lt"/>
+                <a:ea typeface="+mn-ea"/>
+                <a:cs typeface="+mn-cs"/>
+              </a:defRPr>
+            </a:lvl4pPr>
+            <a:lvl5pPr marL="1828800" algn="l" defTabSz="914400" rtl="0" eaLnBrk="1" latinLnBrk="0" hangingPunct="1">
+              <a:defRPr sz="1800" kern="1200">
+                <a:solidFill>
+                  <a:schemeClr val="tx1"/>
+                </a:solidFill>
+                <a:latin typeface="+mn-lt"/>
+                <a:ea typeface="+mn-ea"/>
+                <a:cs typeface="+mn-cs"/>
+              </a:defRPr>
+            </a:lvl5pPr>
+            <a:lvl6pPr marL="2286000" algn="l" defTabSz="914400" rtl="0" eaLnBrk="1" latinLnBrk="0" hangingPunct="1">
+              <a:defRPr sz="1800" kern="1200">
+                <a:solidFill>
+                  <a:schemeClr val="tx1"/>
+                </a:solidFill>
+                <a:latin typeface="+mn-lt"/>
+                <a:ea typeface="+mn-ea"/>
+                <a:cs typeface="+mn-cs"/>
+              </a:defRPr>
+            </a:lvl6pPr>
+            <a:lvl7pPr marL="2743200" algn="l" defTabSz="914400" rtl="0" eaLnBrk="1" latinLnBrk="0" hangingPunct="1">
+              <a:defRPr sz="1800" kern="1200">
+                <a:solidFill>
+                  <a:schemeClr val="tx1"/>
+                </a:solidFill>
+                <a:latin typeface="+mn-lt"/>
+                <a:ea typeface="+mn-ea"/>
+                <a:cs typeface="+mn-cs"/>
+              </a:defRPr>
+            </a:lvl7pPr>
+            <a:lvl8pPr marL="3200400" algn="l" defTabSz="914400" rtl="0" eaLnBrk="1" latinLnBrk="0" hangingPunct="1">
+              <a:defRPr sz="1800" kern="1200">
+                <a:solidFill>
+                  <a:schemeClr val="tx1"/>
+                </a:solidFill>
+                <a:latin typeface="+mn-lt"/>
+                <a:ea typeface="+mn-ea"/>
+                <a:cs typeface="+mn-cs"/>
+              </a:defRPr>
+            </a:lvl8pPr>
+            <a:lvl9pPr marL="3657600" algn="l" defTabSz="914400" rtl="0" eaLnBrk="1" latinLnBrk="0" hangingPunct="1">
+              <a:defRPr sz="1800" kern="1200">
+                <a:solidFill>
+                  <a:schemeClr val="tx1"/>
+                </a:solidFill>
+                <a:latin typeface="+mn-lt"/>
+                <a:ea typeface="+mn-ea"/>
+                <a:cs typeface="+mn-cs"/>
+              </a:defRPr>
+            </a:lvl9pPr>
+          </a:lstStyle>
+          <a:p>
+            <a:pPr marL="0" marR="0" lvl="0" indent="0" algn="ctr" defTabSz="410766" rtl="0" eaLnBrk="1" fontAlgn="auto" latinLnBrk="0" hangingPunct="0">
+              <a:lnSpc>
+                <a:spcPct val="100000"/>
+              </a:lnSpc>
+              <a:spcBef>
+                <a:spcPts val="0"/>
+              </a:spcBef>
+              <a:spcAft>
+                <a:spcPts val="0"/>
+              </a:spcAft>
+              <a:buClrTx/>
+              <a:buSzTx/>
+              <a:buFontTx/>
+              <a:buNone/>
+              <a:tabLst/>
+              <a:defRPr sz="3000" b="1">
+                <a:solidFill>
+                  <a:srgbClr val="FFFFFF"/>
+                </a:solidFill>
+              </a:defRPr>
+            </a:pPr>
+            <a:endParaRPr kumimoji="0" lang="fr-BE" sz="1500" b="1" i="0" u="none" strike="noStrike" kern="0" cap="none" spc="0" normalizeH="0" baseline="0" noProof="0" dirty="0">
+              <a:ln>
+                <a:noFill/>
+              </a:ln>
+              <a:solidFill>
+                <a:srgbClr val="44546A"/>
+              </a:solidFill>
+              <a:effectLst/>
+              <a:uLnTx/>
+              <a:uFillTx/>
+              <a:ea typeface="+mn-ea"/>
+              <a:cs typeface="Segoe UI"/>
+              <a:sym typeface="Segoe UI"/>
+            </a:endParaRPr>
+          </a:p>
+        </p:txBody>
+      </p:sp>
+      <p:sp>
+        <p:nvSpPr>
+          <p:cNvPr id="5" name="Rounded Rectangle">
+            <a:extLst>
+              <a:ext uri="{FF2B5EF4-FFF2-40B4-BE49-F238E27FC236}">
+                <a16:creationId xmlns:a16="http://schemas.microsoft.com/office/drawing/2014/main" id="{874F27A9-623F-7A2B-AC6E-C45DA02568D7}"/>
+              </a:ext>
+            </a:extLst>
+          </p:cNvPr>
+          <p:cNvSpPr/>
+          <p:nvPr/>
+        </p:nvSpPr>
+        <p:spPr>
+          <a:xfrm>
+            <a:off x="5551747" y="920090"/>
+            <a:ext cx="6114792" cy="2949005"/>
+          </a:xfrm>
+          <a:prstGeom prst="roundRect">
+            <a:avLst>
+              <a:gd name="adj" fmla="val 3067"/>
+            </a:avLst>
+          </a:prstGeom>
+          <a:solidFill>
+            <a:schemeClr val="bg1">
+              <a:alpha val="87000"/>
+            </a:schemeClr>
+          </a:solidFill>
+          <a:ln w="12700" cap="flat">
+            <a:noFill/>
+            <a:miter lim="400000"/>
+          </a:ln>
+          <a:effectLst>
+            <a:outerShdw blurRad="952500" dist="444500" dir="5400000" rotWithShape="0">
+              <a:srgbClr val="000000">
+                <a:alpha val="15000"/>
+              </a:srgbClr>
+            </a:outerShdw>
+          </a:effectLst>
+        </p:spPr>
+        <p:txBody>
+          <a:bodyPr wrap="square" lIns="0" tIns="0" rIns="0" bIns="0" numCol="1" anchor="ctr">
+            <a:noAutofit/>
+          </a:bodyPr>
+          <a:lstStyle>
+            <a:defPPr>
+              <a:defRPr lang="en-US"/>
+            </a:defPPr>
+            <a:lvl1pPr marL="0" algn="l" defTabSz="914400" rtl="0" eaLnBrk="1" latinLnBrk="0" hangingPunct="1">
+              <a:defRPr sz="1800" kern="1200">
+                <a:solidFill>
+                  <a:schemeClr val="tx1"/>
+                </a:solidFill>
+                <a:latin typeface="+mn-lt"/>
+                <a:ea typeface="+mn-ea"/>
+                <a:cs typeface="+mn-cs"/>
+              </a:defRPr>
+            </a:lvl1pPr>
+            <a:lvl2pPr marL="457200" algn="l" defTabSz="914400" rtl="0" eaLnBrk="1" latinLnBrk="0" hangingPunct="1">
+              <a:defRPr sz="1800" kern="1200">
+                <a:solidFill>
+                  <a:schemeClr val="tx1"/>
+                </a:solidFill>
+                <a:latin typeface="+mn-lt"/>
+                <a:ea typeface="+mn-ea"/>
+                <a:cs typeface="+mn-cs"/>
+              </a:defRPr>
+            </a:lvl2pPr>
+            <a:lvl3pPr marL="914400" algn="l" defTabSz="914400" rtl="0" eaLnBrk="1" latinLnBrk="0" hangingPunct="1">
+              <a:defRPr sz="1800" kern="1200">
+                <a:solidFill>
+                  <a:schemeClr val="tx1"/>
+                </a:solidFill>
+                <a:latin typeface="+mn-lt"/>
+                <a:ea typeface="+mn-ea"/>
+                <a:cs typeface="+mn-cs"/>
+              </a:defRPr>
+            </a:lvl3pPr>
+            <a:lvl4pPr marL="1371600" algn="l" defTabSz="914400" rtl="0" eaLnBrk="1" latinLnBrk="0" hangingPunct="1">
+              <a:defRPr sz="1800" kern="1200">
+                <a:solidFill>
+                  <a:schemeClr val="tx1"/>
+                </a:solidFill>
+                <a:latin typeface="+mn-lt"/>
+                <a:ea typeface="+mn-ea"/>
+                <a:cs typeface="+mn-cs"/>
+              </a:defRPr>
+            </a:lvl4pPr>
+            <a:lvl5pPr marL="1828800" algn="l" defTabSz="914400" rtl="0" eaLnBrk="1" latinLnBrk="0" hangingPunct="1">
+              <a:defRPr sz="1800" kern="1200">
+                <a:solidFill>
+                  <a:schemeClr val="tx1"/>
+                </a:solidFill>
+                <a:latin typeface="+mn-lt"/>
+                <a:ea typeface="+mn-ea"/>
+                <a:cs typeface="+mn-cs"/>
+              </a:defRPr>
+            </a:lvl5pPr>
+            <a:lvl6pPr marL="2286000" algn="l" defTabSz="914400" rtl="0" eaLnBrk="1" latinLnBrk="0" hangingPunct="1">
+              <a:defRPr sz="1800" kern="1200">
+                <a:solidFill>
+                  <a:schemeClr val="tx1"/>
+                </a:solidFill>
+                <a:latin typeface="+mn-lt"/>
+                <a:ea typeface="+mn-ea"/>
+                <a:cs typeface="+mn-cs"/>
+              </a:defRPr>
+            </a:lvl6pPr>
+            <a:lvl7pPr marL="2743200" algn="l" defTabSz="914400" rtl="0" eaLnBrk="1" latinLnBrk="0" hangingPunct="1">
+              <a:defRPr sz="1800" kern="1200">
+                <a:solidFill>
+                  <a:schemeClr val="tx1"/>
+                </a:solidFill>
+                <a:latin typeface="+mn-lt"/>
+                <a:ea typeface="+mn-ea"/>
+                <a:cs typeface="+mn-cs"/>
+              </a:defRPr>
+            </a:lvl7pPr>
+            <a:lvl8pPr marL="3200400" algn="l" defTabSz="914400" rtl="0" eaLnBrk="1" latinLnBrk="0" hangingPunct="1">
+              <a:defRPr sz="1800" kern="1200">
+                <a:solidFill>
+                  <a:schemeClr val="tx1"/>
+                </a:solidFill>
+                <a:latin typeface="+mn-lt"/>
+                <a:ea typeface="+mn-ea"/>
+                <a:cs typeface="+mn-cs"/>
+              </a:defRPr>
+            </a:lvl8pPr>
+            <a:lvl9pPr marL="3657600" algn="l" defTabSz="914400" rtl="0" eaLnBrk="1" latinLnBrk="0" hangingPunct="1">
+              <a:defRPr sz="1800" kern="1200">
+                <a:solidFill>
+                  <a:schemeClr val="tx1"/>
+                </a:solidFill>
+                <a:latin typeface="+mn-lt"/>
+                <a:ea typeface="+mn-ea"/>
+                <a:cs typeface="+mn-cs"/>
+              </a:defRPr>
+            </a:lvl9pPr>
+          </a:lstStyle>
+          <a:p>
+            <a:pPr marL="0" marR="0" lvl="0" indent="0" algn="ctr" defTabSz="410766" rtl="0" eaLnBrk="1" fontAlgn="auto" latinLnBrk="0" hangingPunct="0">
+              <a:lnSpc>
+                <a:spcPct val="100000"/>
+              </a:lnSpc>
+              <a:spcBef>
+                <a:spcPts val="0"/>
+              </a:spcBef>
+              <a:spcAft>
+                <a:spcPts val="0"/>
+              </a:spcAft>
+              <a:buClrTx/>
+              <a:buSzTx/>
+              <a:buFontTx/>
+              <a:buNone/>
+              <a:tabLst/>
+              <a:defRPr sz="3000" b="1">
+                <a:solidFill>
+                  <a:srgbClr val="FFFFFF"/>
+                </a:solidFill>
+              </a:defRPr>
+            </a:pPr>
+            <a:endParaRPr kumimoji="0" sz="1500" b="1" i="0" u="none" strike="noStrike" kern="0" cap="none" spc="0" normalizeH="0" baseline="0" noProof="0" dirty="0">
+              <a:ln>
+                <a:noFill/>
+              </a:ln>
+              <a:solidFill>
+                <a:srgbClr val="44546A"/>
+              </a:solidFill>
+              <a:effectLst/>
+              <a:uLnTx/>
+              <a:uFillTx/>
+              <a:ea typeface="+mn-ea"/>
+              <a:cs typeface="Segoe UI"/>
+              <a:sym typeface="Segoe UI"/>
+            </a:endParaRPr>
+          </a:p>
+        </p:txBody>
+      </p:sp>
+      <p:sp>
+        <p:nvSpPr>
+          <p:cNvPr id="8" name="Mobilisation &amp; Inputs Gathering">
+            <a:extLst>
+              <a:ext uri="{FF2B5EF4-FFF2-40B4-BE49-F238E27FC236}">
+                <a16:creationId xmlns:a16="http://schemas.microsoft.com/office/drawing/2014/main" id="{6D04A847-6196-9784-F2E4-87671394D025}"/>
+              </a:ext>
+            </a:extLst>
+          </p:cNvPr>
+          <p:cNvSpPr txBox="1"/>
+          <p:nvPr/>
+        </p:nvSpPr>
+        <p:spPr>
+          <a:xfrm>
+            <a:off x="515938" y="1024585"/>
+            <a:ext cx="5168582" cy="377910"/>
+          </a:xfrm>
+          <a:prstGeom prst="rect">
+            <a:avLst/>
+          </a:prstGeom>
+          <a:noFill/>
+          <a:ln w="12700" cap="flat">
+            <a:noFill/>
+            <a:miter lim="400000"/>
+          </a:ln>
+          <a:effectLst/>
+          <a:extLst>
+            <a:ext uri="{C572A759-6A51-4108-AA02-DFA0A04FC94B}">
+              <ma14:wrappingTextBoxFlag xmlns:lc="http://schemas.openxmlformats.org/drawingml/2006/lockedCanvas" xmlns:ma14="http://schemas.microsoft.com/office/mac/drawingml/2011/main" xmlns:a14="http://schemas.microsoft.com/office/drawing/2010/main" xmlns:m="http://schemas.openxmlformats.org/officeDocument/2006/math" xmlns="" val="1"/>
+            </a:ext>
+          </a:extLst>
+        </p:spPr>
+        <p:txBody>
+          <a:bodyPr wrap="square" lIns="35719" tIns="35719" rIns="35719" bIns="35719" numCol="1" anchor="t">
+            <a:noAutofit/>
+          </a:bodyPr>
+          <a:lstStyle>
+            <a:defPPr>
+              <a:defRPr lang="en-US"/>
+            </a:defPPr>
+            <a:lvl1pPr marL="0" algn="l" defTabSz="914400" rtl="0" eaLnBrk="1" latinLnBrk="0" hangingPunct="1">
+              <a:defRPr sz="1800" kern="1200">
+                <a:solidFill>
+                  <a:schemeClr val="tx1"/>
+                </a:solidFill>
+                <a:latin typeface="+mn-lt"/>
+                <a:ea typeface="+mn-ea"/>
+                <a:cs typeface="+mn-cs"/>
+              </a:defRPr>
+            </a:lvl1pPr>
+            <a:lvl2pPr marL="457200" algn="l" defTabSz="914400" rtl="0" eaLnBrk="1" latinLnBrk="0" hangingPunct="1">
+              <a:defRPr sz="1800" kern="1200">
+                <a:solidFill>
+                  <a:schemeClr val="tx1"/>
+                </a:solidFill>
+                <a:latin typeface="+mn-lt"/>
+                <a:ea typeface="+mn-ea"/>
+                <a:cs typeface="+mn-cs"/>
+              </a:defRPr>
+            </a:lvl2pPr>
+            <a:lvl3pPr marL="914400" algn="l" defTabSz="914400" rtl="0" eaLnBrk="1" latinLnBrk="0" hangingPunct="1">
+              <a:defRPr sz="1800" kern="1200">
+                <a:solidFill>
+                  <a:schemeClr val="tx1"/>
+                </a:solidFill>
+                <a:latin typeface="+mn-lt"/>
+                <a:ea typeface="+mn-ea"/>
+                <a:cs typeface="+mn-cs"/>
+              </a:defRPr>
+            </a:lvl3pPr>
+            <a:lvl4pPr marL="1371600" algn="l" defTabSz="914400" rtl="0" eaLnBrk="1" latinLnBrk="0" hangingPunct="1">
+              <a:defRPr sz="1800" kern="1200">
+                <a:solidFill>
+                  <a:schemeClr val="tx1"/>
+                </a:solidFill>
+                <a:latin typeface="+mn-lt"/>
+                <a:ea typeface="+mn-ea"/>
+                <a:cs typeface="+mn-cs"/>
+              </a:defRPr>
+            </a:lvl4pPr>
+            <a:lvl5pPr marL="1828800" algn="l" defTabSz="914400" rtl="0" eaLnBrk="1" latinLnBrk="0" hangingPunct="1">
+              <a:defRPr sz="1800" kern="1200">
+                <a:solidFill>
+                  <a:schemeClr val="tx1"/>
+                </a:solidFill>
+                <a:latin typeface="+mn-lt"/>
+                <a:ea typeface="+mn-ea"/>
+                <a:cs typeface="+mn-cs"/>
+              </a:defRPr>
+            </a:lvl5pPr>
+            <a:lvl6pPr marL="2286000" algn="l" defTabSz="914400" rtl="0" eaLnBrk="1" latinLnBrk="0" hangingPunct="1">
+              <a:defRPr sz="1800" kern="1200">
+                <a:solidFill>
+                  <a:schemeClr val="tx1"/>
+                </a:solidFill>
+                <a:latin typeface="+mn-lt"/>
+                <a:ea typeface="+mn-ea"/>
+                <a:cs typeface="+mn-cs"/>
+              </a:defRPr>
+            </a:lvl6pPr>
+            <a:lvl7pPr marL="2743200" algn="l" defTabSz="914400" rtl="0" eaLnBrk="1" latinLnBrk="0" hangingPunct="1">
+              <a:defRPr sz="1800" kern="1200">
+                <a:solidFill>
+                  <a:schemeClr val="tx1"/>
+                </a:solidFill>
+                <a:latin typeface="+mn-lt"/>
+                <a:ea typeface="+mn-ea"/>
+                <a:cs typeface="+mn-cs"/>
+              </a:defRPr>
+            </a:lvl7pPr>
+            <a:lvl8pPr marL="3200400" algn="l" defTabSz="914400" rtl="0" eaLnBrk="1" latinLnBrk="0" hangingPunct="1">
+              <a:defRPr sz="1800" kern="1200">
+                <a:solidFill>
+                  <a:schemeClr val="tx1"/>
+                </a:solidFill>
+                <a:latin typeface="+mn-lt"/>
+                <a:ea typeface="+mn-ea"/>
+                <a:cs typeface="+mn-cs"/>
+              </a:defRPr>
+            </a:lvl8pPr>
+            <a:lvl9pPr marL="3657600" algn="l" defTabSz="914400" rtl="0" eaLnBrk="1" latinLnBrk="0" hangingPunct="1">
+              <a:defRPr sz="1800" kern="1200">
+                <a:solidFill>
+                  <a:schemeClr val="tx1"/>
+                </a:solidFill>
+                <a:latin typeface="+mn-lt"/>
+                <a:ea typeface="+mn-ea"/>
+                <a:cs typeface="+mn-cs"/>
+              </a:defRPr>
+            </a:lvl9pPr>
+          </a:lstStyle>
+          <a:p>
+            <a:pPr algn="ctr" defTabSz="533400">
+              <a:lnSpc>
+                <a:spcPct val="90000"/>
+              </a:lnSpc>
+              <a:spcBef>
+                <a:spcPct val="0"/>
+              </a:spcBef>
+              <a:spcAft>
+                <a:spcPct val="35000"/>
+              </a:spcAft>
+            </a:pPr>
+            <a:r>
+              <a:rPr lang="en-US" b="1" noProof="0" dirty="0">
+                <a:solidFill>
+                  <a:srgbClr val="44546A"/>
+                </a:solidFill>
+                <a:cs typeface="Segoe UI Light" panose="020B0502040204020203" pitchFamily="34" charset="0"/>
+              </a:rPr>
+              <a:t>Modular Architecture</a:t>
+            </a:r>
+          </a:p>
+        </p:txBody>
+      </p:sp>
+      <p:sp>
+        <p:nvSpPr>
+          <p:cNvPr id="10" name="Mobilisation &amp; Inputs Gathering">
+            <a:extLst>
+              <a:ext uri="{FF2B5EF4-FFF2-40B4-BE49-F238E27FC236}">
+                <a16:creationId xmlns:a16="http://schemas.microsoft.com/office/drawing/2014/main" id="{D7651270-AF33-89A2-188F-B1650B49DF07}"/>
+              </a:ext>
+            </a:extLst>
+          </p:cNvPr>
+          <p:cNvSpPr txBox="1"/>
+          <p:nvPr/>
+        </p:nvSpPr>
+        <p:spPr>
+          <a:xfrm>
+            <a:off x="6029326" y="1031697"/>
+            <a:ext cx="5168581" cy="377910"/>
+          </a:xfrm>
+          <a:prstGeom prst="rect">
+            <a:avLst/>
+          </a:prstGeom>
+          <a:noFill/>
+          <a:ln w="12700" cap="flat">
+            <a:noFill/>
+            <a:miter lim="400000"/>
+          </a:ln>
+          <a:effectLst/>
+          <a:extLst>
+            <a:ext uri="{C572A759-6A51-4108-AA02-DFA0A04FC94B}">
+              <ma14:wrappingTextBoxFlag xmlns:lc="http://schemas.openxmlformats.org/drawingml/2006/lockedCanvas" xmlns:ma14="http://schemas.microsoft.com/office/mac/drawingml/2011/main" xmlns:a14="http://schemas.microsoft.com/office/drawing/2010/main" xmlns:m="http://schemas.openxmlformats.org/officeDocument/2006/math" xmlns="" val="1"/>
+            </a:ext>
+          </a:extLst>
+        </p:spPr>
+        <p:txBody>
+          <a:bodyPr wrap="square" lIns="35719" tIns="35719" rIns="35719" bIns="35719" numCol="1" anchor="t">
+            <a:noAutofit/>
+          </a:bodyPr>
+          <a:lstStyle>
+            <a:defPPr>
+              <a:defRPr lang="en-US"/>
+            </a:defPPr>
+            <a:lvl1pPr marL="0" algn="l" defTabSz="914400" rtl="0" eaLnBrk="1" latinLnBrk="0" hangingPunct="1">
+              <a:defRPr sz="1800" kern="1200">
+                <a:solidFill>
+                  <a:schemeClr val="tx1"/>
+                </a:solidFill>
+                <a:latin typeface="+mn-lt"/>
+                <a:ea typeface="+mn-ea"/>
+                <a:cs typeface="+mn-cs"/>
+              </a:defRPr>
+            </a:lvl1pPr>
+            <a:lvl2pPr marL="457200" algn="l" defTabSz="914400" rtl="0" eaLnBrk="1" latinLnBrk="0" hangingPunct="1">
+              <a:defRPr sz="1800" kern="1200">
+                <a:solidFill>
+                  <a:schemeClr val="tx1"/>
+                </a:solidFill>
+                <a:latin typeface="+mn-lt"/>
+                <a:ea typeface="+mn-ea"/>
+                <a:cs typeface="+mn-cs"/>
+              </a:defRPr>
+            </a:lvl2pPr>
+            <a:lvl3pPr marL="914400" algn="l" defTabSz="914400" rtl="0" eaLnBrk="1" latinLnBrk="0" hangingPunct="1">
+              <a:defRPr sz="1800" kern="1200">
+                <a:solidFill>
+                  <a:schemeClr val="tx1"/>
+                </a:solidFill>
+                <a:latin typeface="+mn-lt"/>
+                <a:ea typeface="+mn-ea"/>
+                <a:cs typeface="+mn-cs"/>
+              </a:defRPr>
+            </a:lvl3pPr>
+            <a:lvl4pPr marL="1371600" algn="l" defTabSz="914400" rtl="0" eaLnBrk="1" latinLnBrk="0" hangingPunct="1">
+              <a:defRPr sz="1800" kern="1200">
+                <a:solidFill>
+                  <a:schemeClr val="tx1"/>
+                </a:solidFill>
+                <a:latin typeface="+mn-lt"/>
+                <a:ea typeface="+mn-ea"/>
+                <a:cs typeface="+mn-cs"/>
+              </a:defRPr>
+            </a:lvl4pPr>
+            <a:lvl5pPr marL="1828800" algn="l" defTabSz="914400" rtl="0" eaLnBrk="1" latinLnBrk="0" hangingPunct="1">
+              <a:defRPr sz="1800" kern="1200">
+                <a:solidFill>
+                  <a:schemeClr val="tx1"/>
+                </a:solidFill>
+                <a:latin typeface="+mn-lt"/>
+                <a:ea typeface="+mn-ea"/>
+                <a:cs typeface="+mn-cs"/>
+              </a:defRPr>
+            </a:lvl5pPr>
+            <a:lvl6pPr marL="2286000" algn="l" defTabSz="914400" rtl="0" eaLnBrk="1" latinLnBrk="0" hangingPunct="1">
+              <a:defRPr sz="1800" kern="1200">
+                <a:solidFill>
+                  <a:schemeClr val="tx1"/>
+                </a:solidFill>
+                <a:latin typeface="+mn-lt"/>
+                <a:ea typeface="+mn-ea"/>
+                <a:cs typeface="+mn-cs"/>
+              </a:defRPr>
+            </a:lvl6pPr>
+            <a:lvl7pPr marL="2743200" algn="l" defTabSz="914400" rtl="0" eaLnBrk="1" latinLnBrk="0" hangingPunct="1">
+              <a:defRPr sz="1800" kern="1200">
+                <a:solidFill>
+                  <a:schemeClr val="tx1"/>
+                </a:solidFill>
+                <a:latin typeface="+mn-lt"/>
+                <a:ea typeface="+mn-ea"/>
+                <a:cs typeface="+mn-cs"/>
+              </a:defRPr>
+            </a:lvl7pPr>
+            <a:lvl8pPr marL="3200400" algn="l" defTabSz="914400" rtl="0" eaLnBrk="1" latinLnBrk="0" hangingPunct="1">
+              <a:defRPr sz="1800" kern="1200">
+                <a:solidFill>
+                  <a:schemeClr val="tx1"/>
+                </a:solidFill>
+                <a:latin typeface="+mn-lt"/>
+                <a:ea typeface="+mn-ea"/>
+                <a:cs typeface="+mn-cs"/>
+              </a:defRPr>
+            </a:lvl8pPr>
+            <a:lvl9pPr marL="3657600" algn="l" defTabSz="914400" rtl="0" eaLnBrk="1" latinLnBrk="0" hangingPunct="1">
+              <a:defRPr sz="1800" kern="1200">
+                <a:solidFill>
+                  <a:schemeClr val="tx1"/>
+                </a:solidFill>
+                <a:latin typeface="+mn-lt"/>
+                <a:ea typeface="+mn-ea"/>
+                <a:cs typeface="+mn-cs"/>
+              </a:defRPr>
+            </a:lvl9pPr>
+          </a:lstStyle>
+          <a:p>
+            <a:pPr algn="ctr" defTabSz="533400">
+              <a:lnSpc>
+                <a:spcPct val="90000"/>
+              </a:lnSpc>
+              <a:spcBef>
+                <a:spcPct val="0"/>
+              </a:spcBef>
+              <a:spcAft>
+                <a:spcPct val="35000"/>
+              </a:spcAft>
+            </a:pPr>
+            <a:r>
+              <a:rPr lang="en-US" b="1" noProof="0" dirty="0">
+                <a:solidFill>
+                  <a:srgbClr val="44546A"/>
+                </a:solidFill>
+                <a:cs typeface="Segoe UI Light" panose="020B0502040204020203" pitchFamily="34" charset="0"/>
+              </a:rPr>
+              <a:t>Containerization</a:t>
+            </a:r>
+          </a:p>
+        </p:txBody>
+      </p:sp>
+      <p:sp>
+        <p:nvSpPr>
+          <p:cNvPr id="11" name="Line">
+            <a:extLst>
+              <a:ext uri="{FF2B5EF4-FFF2-40B4-BE49-F238E27FC236}">
+                <a16:creationId xmlns:a16="http://schemas.microsoft.com/office/drawing/2014/main" id="{54429448-F15C-7F03-8F94-BF2F5D968256}"/>
+              </a:ext>
+            </a:extLst>
+          </p:cNvPr>
+          <p:cNvSpPr/>
+          <p:nvPr/>
+        </p:nvSpPr>
+        <p:spPr>
+          <a:xfrm>
+            <a:off x="515938" y="1438456"/>
+            <a:ext cx="4873480" cy="0"/>
+          </a:xfrm>
+          <a:prstGeom prst="line">
+            <a:avLst/>
+          </a:prstGeom>
+          <a:noFill/>
+          <a:ln w="50800" cap="flat">
+            <a:solidFill>
+              <a:srgbClr val="F94F00"/>
+            </a:solidFill>
+            <a:prstDash val="solid"/>
+            <a:miter lim="400000"/>
+          </a:ln>
+          <a:effectLst/>
+        </p:spPr>
+        <p:txBody>
+          <a:bodyPr wrap="square" lIns="0" tIns="0" rIns="0" bIns="0" numCol="1" anchor="ctr">
+            <a:noAutofit/>
+          </a:bodyPr>
+          <a:lstStyle>
+            <a:defPPr>
+              <a:defRPr lang="en-US"/>
+            </a:defPPr>
+            <a:lvl1pPr marL="0" algn="l" defTabSz="914400" rtl="0" eaLnBrk="1" latinLnBrk="0" hangingPunct="1">
+              <a:defRPr sz="1800" kern="1200">
+                <a:solidFill>
+                  <a:schemeClr val="tx1"/>
+                </a:solidFill>
+                <a:latin typeface="+mn-lt"/>
+                <a:ea typeface="+mn-ea"/>
+                <a:cs typeface="+mn-cs"/>
+              </a:defRPr>
+            </a:lvl1pPr>
+            <a:lvl2pPr marL="457200" algn="l" defTabSz="914400" rtl="0" eaLnBrk="1" latinLnBrk="0" hangingPunct="1">
+              <a:defRPr sz="1800" kern="1200">
+                <a:solidFill>
+                  <a:schemeClr val="tx1"/>
+                </a:solidFill>
+                <a:latin typeface="+mn-lt"/>
+                <a:ea typeface="+mn-ea"/>
+                <a:cs typeface="+mn-cs"/>
+              </a:defRPr>
+            </a:lvl2pPr>
+            <a:lvl3pPr marL="914400" algn="l" defTabSz="914400" rtl="0" eaLnBrk="1" latinLnBrk="0" hangingPunct="1">
+              <a:defRPr sz="1800" kern="1200">
+                <a:solidFill>
+                  <a:schemeClr val="tx1"/>
+                </a:solidFill>
+                <a:latin typeface="+mn-lt"/>
+                <a:ea typeface="+mn-ea"/>
+                <a:cs typeface="+mn-cs"/>
+              </a:defRPr>
+            </a:lvl3pPr>
+            <a:lvl4pPr marL="1371600" algn="l" defTabSz="914400" rtl="0" eaLnBrk="1" latinLnBrk="0" hangingPunct="1">
+              <a:defRPr sz="1800" kern="1200">
+                <a:solidFill>
+                  <a:schemeClr val="tx1"/>
+                </a:solidFill>
+                <a:latin typeface="+mn-lt"/>
+                <a:ea typeface="+mn-ea"/>
+                <a:cs typeface="+mn-cs"/>
+              </a:defRPr>
+            </a:lvl4pPr>
+            <a:lvl5pPr marL="1828800" algn="l" defTabSz="914400" rtl="0" eaLnBrk="1" latinLnBrk="0" hangingPunct="1">
+              <a:defRPr sz="1800" kern="1200">
+                <a:solidFill>
+                  <a:schemeClr val="tx1"/>
+                </a:solidFill>
+                <a:latin typeface="+mn-lt"/>
+                <a:ea typeface="+mn-ea"/>
+                <a:cs typeface="+mn-cs"/>
+              </a:defRPr>
+            </a:lvl5pPr>
+            <a:lvl6pPr marL="2286000" algn="l" defTabSz="914400" rtl="0" eaLnBrk="1" latinLnBrk="0" hangingPunct="1">
+              <a:defRPr sz="1800" kern="1200">
+                <a:solidFill>
+                  <a:schemeClr val="tx1"/>
+                </a:solidFill>
+                <a:latin typeface="+mn-lt"/>
+                <a:ea typeface="+mn-ea"/>
+                <a:cs typeface="+mn-cs"/>
+              </a:defRPr>
+            </a:lvl6pPr>
+            <a:lvl7pPr marL="2743200" algn="l" defTabSz="914400" rtl="0" eaLnBrk="1" latinLnBrk="0" hangingPunct="1">
+              <a:defRPr sz="1800" kern="1200">
+                <a:solidFill>
+                  <a:schemeClr val="tx1"/>
+                </a:solidFill>
+                <a:latin typeface="+mn-lt"/>
+                <a:ea typeface="+mn-ea"/>
+                <a:cs typeface="+mn-cs"/>
+              </a:defRPr>
+            </a:lvl7pPr>
+            <a:lvl8pPr marL="3200400" algn="l" defTabSz="914400" rtl="0" eaLnBrk="1" latinLnBrk="0" hangingPunct="1">
+              <a:defRPr sz="1800" kern="1200">
+                <a:solidFill>
+                  <a:schemeClr val="tx1"/>
+                </a:solidFill>
+                <a:latin typeface="+mn-lt"/>
+                <a:ea typeface="+mn-ea"/>
+                <a:cs typeface="+mn-cs"/>
+              </a:defRPr>
+            </a:lvl8pPr>
+            <a:lvl9pPr marL="3657600" algn="l" defTabSz="914400" rtl="0" eaLnBrk="1" latinLnBrk="0" hangingPunct="1">
+              <a:defRPr sz="1800" kern="1200">
+                <a:solidFill>
+                  <a:schemeClr val="tx1"/>
+                </a:solidFill>
+                <a:latin typeface="+mn-lt"/>
+                <a:ea typeface="+mn-ea"/>
+                <a:cs typeface="+mn-cs"/>
+              </a:defRPr>
+            </a:lvl9pPr>
+          </a:lstStyle>
+          <a:p>
+            <a:pPr marL="0" marR="0" lvl="0" indent="0" algn="ctr" defTabSz="410766" rtl="0" eaLnBrk="1" fontAlgn="auto" latinLnBrk="0" hangingPunct="0">
+              <a:lnSpc>
+                <a:spcPct val="100000"/>
+              </a:lnSpc>
+              <a:spcBef>
+                <a:spcPts val="0"/>
+              </a:spcBef>
+              <a:spcAft>
+                <a:spcPts val="0"/>
+              </a:spcAft>
+              <a:buClrTx/>
+              <a:buSzTx/>
+              <a:buFontTx/>
+              <a:buNone/>
+              <a:tabLst/>
+              <a:defRPr sz="3000" b="1">
+                <a:solidFill>
+                  <a:srgbClr val="FFFFFF"/>
+                </a:solidFill>
+              </a:defRPr>
+            </a:pPr>
+            <a:endParaRPr kumimoji="0" lang="en-US" sz="1200" b="1" i="0" u="none" strike="noStrike" kern="0" cap="none" spc="0" normalizeH="0" baseline="0" noProof="0" dirty="0">
+              <a:ln>
+                <a:noFill/>
+              </a:ln>
+              <a:solidFill>
+                <a:schemeClr val="accent1"/>
+              </a:solidFill>
+              <a:effectLst/>
+              <a:uLnTx/>
+              <a:uFillTx/>
+              <a:ea typeface="+mn-ea"/>
+              <a:cs typeface="Segoe UI"/>
+              <a:sym typeface="Segoe UI"/>
+            </a:endParaRPr>
+          </a:p>
+        </p:txBody>
+      </p:sp>
+      <p:sp>
+        <p:nvSpPr>
+          <p:cNvPr id="12" name="Mobilisation &amp; Inputs Gathering">
+            <a:extLst>
+              <a:ext uri="{FF2B5EF4-FFF2-40B4-BE49-F238E27FC236}">
+                <a16:creationId xmlns:a16="http://schemas.microsoft.com/office/drawing/2014/main" id="{87E5A148-D42D-4A8A-4A7B-227FC670E55C}"/>
+              </a:ext>
+            </a:extLst>
+          </p:cNvPr>
+          <p:cNvSpPr txBox="1"/>
+          <p:nvPr/>
+        </p:nvSpPr>
+        <p:spPr>
+          <a:xfrm>
+            <a:off x="678266" y="1609248"/>
+            <a:ext cx="4531043" cy="1974672"/>
+          </a:xfrm>
+          <a:prstGeom prst="rect">
+            <a:avLst/>
+          </a:prstGeom>
+          <a:noFill/>
+          <a:ln w="12700" cap="flat">
+            <a:noFill/>
+            <a:miter lim="400000"/>
+          </a:ln>
+          <a:effectLst/>
+          <a:extLst>
+            <a:ext uri="{C572A759-6A51-4108-AA02-DFA0A04FC94B}">
+              <ma14:wrappingTextBoxFlag xmlns:lc="http://schemas.openxmlformats.org/drawingml/2006/lockedCanvas" xmlns:ma14="http://schemas.microsoft.com/office/mac/drawingml/2011/main" xmlns:a14="http://schemas.microsoft.com/office/drawing/2010/main" xmlns:m="http://schemas.openxmlformats.org/officeDocument/2006/math" xmlns="" val="1"/>
+            </a:ext>
+          </a:extLst>
+        </p:spPr>
+        <p:txBody>
+          <a:bodyPr wrap="square" lIns="35719" tIns="35719" rIns="35719" bIns="35719" numCol="1" anchor="t">
+            <a:noAutofit/>
+          </a:bodyPr>
+          <a:lstStyle>
+            <a:defPPr>
+              <a:defRPr lang="en-US"/>
+            </a:defPPr>
+            <a:lvl1pPr marL="0" algn="l" defTabSz="914400" rtl="0" eaLnBrk="1" latinLnBrk="0" hangingPunct="1">
+              <a:defRPr sz="1800" kern="1200">
+                <a:solidFill>
+                  <a:schemeClr val="tx1"/>
+                </a:solidFill>
+                <a:latin typeface="+mn-lt"/>
+                <a:ea typeface="+mn-ea"/>
+                <a:cs typeface="+mn-cs"/>
+              </a:defRPr>
+            </a:lvl1pPr>
+            <a:lvl2pPr marL="457200" algn="l" defTabSz="914400" rtl="0" eaLnBrk="1" latinLnBrk="0" hangingPunct="1">
+              <a:defRPr sz="1800" kern="1200">
+                <a:solidFill>
+                  <a:schemeClr val="tx1"/>
+                </a:solidFill>
+                <a:latin typeface="+mn-lt"/>
+                <a:ea typeface="+mn-ea"/>
+                <a:cs typeface="+mn-cs"/>
+              </a:defRPr>
+            </a:lvl2pPr>
+            <a:lvl3pPr marL="914400" algn="l" defTabSz="914400" rtl="0" eaLnBrk="1" latinLnBrk="0" hangingPunct="1">
+              <a:defRPr sz="1800" kern="1200">
+                <a:solidFill>
+                  <a:schemeClr val="tx1"/>
+                </a:solidFill>
+                <a:latin typeface="+mn-lt"/>
+                <a:ea typeface="+mn-ea"/>
+                <a:cs typeface="+mn-cs"/>
+              </a:defRPr>
+            </a:lvl3pPr>
+            <a:lvl4pPr marL="1371600" algn="l" defTabSz="914400" rtl="0" eaLnBrk="1" latinLnBrk="0" hangingPunct="1">
+              <a:defRPr sz="1800" kern="1200">
+                <a:solidFill>
+                  <a:schemeClr val="tx1"/>
+                </a:solidFill>
+                <a:latin typeface="+mn-lt"/>
+                <a:ea typeface="+mn-ea"/>
+                <a:cs typeface="+mn-cs"/>
+              </a:defRPr>
+            </a:lvl4pPr>
+            <a:lvl5pPr marL="1828800" algn="l" defTabSz="914400" rtl="0" eaLnBrk="1" latinLnBrk="0" hangingPunct="1">
+              <a:defRPr sz="1800" kern="1200">
+                <a:solidFill>
+                  <a:schemeClr val="tx1"/>
+                </a:solidFill>
+                <a:latin typeface="+mn-lt"/>
+                <a:ea typeface="+mn-ea"/>
+                <a:cs typeface="+mn-cs"/>
+              </a:defRPr>
+            </a:lvl5pPr>
+            <a:lvl6pPr marL="2286000" algn="l" defTabSz="914400" rtl="0" eaLnBrk="1" latinLnBrk="0" hangingPunct="1">
+              <a:defRPr sz="1800" kern="1200">
+                <a:solidFill>
+                  <a:schemeClr val="tx1"/>
+                </a:solidFill>
+                <a:latin typeface="+mn-lt"/>
+                <a:ea typeface="+mn-ea"/>
+                <a:cs typeface="+mn-cs"/>
+              </a:defRPr>
+            </a:lvl6pPr>
+            <a:lvl7pPr marL="2743200" algn="l" defTabSz="914400" rtl="0" eaLnBrk="1" latinLnBrk="0" hangingPunct="1">
+              <a:defRPr sz="1800" kern="1200">
+                <a:solidFill>
+                  <a:schemeClr val="tx1"/>
+                </a:solidFill>
+                <a:latin typeface="+mn-lt"/>
+                <a:ea typeface="+mn-ea"/>
+                <a:cs typeface="+mn-cs"/>
+              </a:defRPr>
+            </a:lvl7pPr>
+            <a:lvl8pPr marL="3200400" algn="l" defTabSz="914400" rtl="0" eaLnBrk="1" latinLnBrk="0" hangingPunct="1">
+              <a:defRPr sz="1800" kern="1200">
+                <a:solidFill>
+                  <a:schemeClr val="tx1"/>
+                </a:solidFill>
+                <a:latin typeface="+mn-lt"/>
+                <a:ea typeface="+mn-ea"/>
+                <a:cs typeface="+mn-cs"/>
+              </a:defRPr>
+            </a:lvl8pPr>
+            <a:lvl9pPr marL="3657600" algn="l" defTabSz="914400" rtl="0" eaLnBrk="1" latinLnBrk="0" hangingPunct="1">
+              <a:defRPr sz="1800" kern="1200">
+                <a:solidFill>
+                  <a:schemeClr val="tx1"/>
+                </a:solidFill>
+                <a:latin typeface="+mn-lt"/>
+                <a:ea typeface="+mn-ea"/>
+                <a:cs typeface="+mn-cs"/>
+              </a:defRPr>
+            </a:lvl9pPr>
+          </a:lstStyle>
+          <a:p>
+            <a:pPr marL="285750" indent="-285750">
+              <a:buFont typeface="Arial" panose="020B0604020202020204" pitchFamily="34" charset="0"/>
+              <a:buChar char="•"/>
+            </a:pPr>
+            <a:r>
+              <a:rPr lang="en-US" sz="1500" dirty="0">
+                <a:solidFill>
+                  <a:schemeClr val="accent1"/>
+                </a:solidFill>
+                <a:cs typeface="Segoe UI Light" panose="020B0502040204020203" pitchFamily="34" charset="0"/>
+              </a:rPr>
+              <a:t>We adopted a modular </a:t>
+            </a:r>
+            <a:r>
+              <a:rPr lang="en-US" sz="1500" b="1" dirty="0">
+                <a:solidFill>
+                  <a:schemeClr val="accent1"/>
+                </a:solidFill>
+                <a:cs typeface="Segoe UI Light" panose="020B0502040204020203" pitchFamily="34" charset="0"/>
+              </a:rPr>
+              <a:t>two-layer design</a:t>
+            </a:r>
+            <a:r>
+              <a:rPr lang="en-US" sz="1500" dirty="0">
+                <a:solidFill>
+                  <a:schemeClr val="accent1"/>
+                </a:solidFill>
+                <a:cs typeface="Segoe UI Light" panose="020B0502040204020203" pitchFamily="34" charset="0"/>
+              </a:rPr>
+              <a:t>:</a:t>
+            </a:r>
+          </a:p>
+          <a:p>
+            <a:pPr marL="628650" indent="-285750">
+              <a:buFont typeface="Arial" panose="020B0604020202020204" pitchFamily="34" charset="0"/>
+              <a:buChar char="•"/>
+            </a:pPr>
+            <a:r>
+              <a:rPr lang="en-US" sz="1500" b="1" dirty="0">
+                <a:solidFill>
+                  <a:schemeClr val="accent1"/>
+                </a:solidFill>
+                <a:cs typeface="Segoe UI Light" panose="020B0502040204020203" pitchFamily="34" charset="0"/>
+              </a:rPr>
+              <a:t>Backend: </a:t>
+            </a:r>
+            <a:r>
+              <a:rPr lang="en-US" sz="1500" b="1" dirty="0" err="1">
+                <a:solidFill>
+                  <a:schemeClr val="accent1"/>
+                </a:solidFill>
+                <a:cs typeface="Segoe UI Light" panose="020B0502040204020203" pitchFamily="34" charset="0"/>
+              </a:rPr>
+              <a:t>FastAPI</a:t>
+            </a:r>
+            <a:r>
+              <a:rPr lang="en-US" sz="1500" b="1" dirty="0">
+                <a:solidFill>
+                  <a:schemeClr val="accent1"/>
+                </a:solidFill>
+                <a:cs typeface="Segoe UI Light" panose="020B0502040204020203" pitchFamily="34" charset="0"/>
+              </a:rPr>
+              <a:t> REST API </a:t>
+            </a:r>
+            <a:r>
+              <a:rPr lang="en-US" sz="1500" dirty="0">
+                <a:solidFill>
+                  <a:schemeClr val="accent1"/>
+                </a:solidFill>
+                <a:cs typeface="Segoe UI Light" panose="020B0502040204020203" pitchFamily="34" charset="0"/>
+              </a:rPr>
+              <a:t>serving </a:t>
+            </a:r>
+            <a:r>
+              <a:rPr lang="en-US" sz="1500" b="1" dirty="0">
+                <a:solidFill>
+                  <a:schemeClr val="accent1"/>
+                </a:solidFill>
+                <a:cs typeface="Segoe UI Light" panose="020B0502040204020203" pitchFamily="34" charset="0"/>
+              </a:rPr>
+              <a:t>ML predictions </a:t>
+            </a:r>
+            <a:r>
+              <a:rPr lang="en-US" sz="1500" dirty="0">
+                <a:solidFill>
+                  <a:schemeClr val="accent1"/>
+                </a:solidFill>
+                <a:cs typeface="Segoe UI Light" panose="020B0502040204020203" pitchFamily="34" charset="0"/>
+              </a:rPr>
+              <a:t>(two endpoints: full features / top 30).</a:t>
+            </a:r>
+          </a:p>
+          <a:p>
+            <a:pPr marL="628650" indent="-285750">
+              <a:buFont typeface="Arial" panose="020B0604020202020204" pitchFamily="34" charset="0"/>
+              <a:buChar char="•"/>
+            </a:pPr>
+            <a:r>
+              <a:rPr lang="en-US" sz="1500" b="1" dirty="0">
+                <a:solidFill>
+                  <a:schemeClr val="accent1"/>
+                </a:solidFill>
+                <a:cs typeface="Segoe UI Light" panose="020B0502040204020203" pitchFamily="34" charset="0"/>
+              </a:rPr>
+              <a:t>Frontend: </a:t>
+            </a:r>
+            <a:r>
+              <a:rPr lang="en-US" sz="1500" b="1" dirty="0" err="1">
+                <a:solidFill>
+                  <a:schemeClr val="accent1"/>
+                </a:solidFill>
+                <a:cs typeface="Segoe UI Light" panose="020B0502040204020203" pitchFamily="34" charset="0"/>
+              </a:rPr>
+              <a:t>Streamlit</a:t>
+            </a:r>
+            <a:r>
+              <a:rPr lang="en-US" sz="1500" b="1" dirty="0">
+                <a:solidFill>
+                  <a:schemeClr val="accent1"/>
+                </a:solidFill>
+                <a:cs typeface="Segoe UI Light" panose="020B0502040204020203" pitchFamily="34" charset="0"/>
+              </a:rPr>
+              <a:t>-based UI </a:t>
+            </a:r>
+            <a:r>
+              <a:rPr lang="en-US" sz="1500" dirty="0">
+                <a:solidFill>
+                  <a:schemeClr val="accent1"/>
+                </a:solidFill>
+                <a:cs typeface="Segoe UI Light" panose="020B0502040204020203" pitchFamily="34" charset="0"/>
+              </a:rPr>
+              <a:t>enabling user interaction</a:t>
+            </a:r>
+          </a:p>
+          <a:p>
+            <a:pPr marL="285750" indent="-285750">
+              <a:buFont typeface="Arial" panose="020B0604020202020204" pitchFamily="34" charset="0"/>
+              <a:buChar char="•"/>
+            </a:pPr>
+            <a:endParaRPr lang="en-US" sz="1500" dirty="0">
+              <a:solidFill>
+                <a:schemeClr val="accent1"/>
+              </a:solidFill>
+              <a:cs typeface="Segoe UI Light" panose="020B0502040204020203" pitchFamily="34" charset="0"/>
+            </a:endParaRPr>
+          </a:p>
+          <a:p>
+            <a:pPr marL="285750" indent="-285750">
+              <a:buFont typeface="Arial" panose="020B0604020202020204" pitchFamily="34" charset="0"/>
+              <a:buChar char="•"/>
+            </a:pPr>
+            <a:r>
+              <a:rPr lang="en-US" sz="1500" dirty="0">
+                <a:solidFill>
+                  <a:schemeClr val="accent1"/>
+                </a:solidFill>
+                <a:cs typeface="Segoe UI Light" panose="020B0502040204020203" pitchFamily="34" charset="0"/>
+              </a:rPr>
+              <a:t>This separation allowed </a:t>
+            </a:r>
+            <a:r>
+              <a:rPr lang="en-US" sz="1500" b="1" dirty="0">
+                <a:solidFill>
+                  <a:schemeClr val="accent1"/>
+                </a:solidFill>
+                <a:cs typeface="Segoe UI Light" panose="020B0502040204020203" pitchFamily="34" charset="0"/>
+              </a:rPr>
+              <a:t>independent development</a:t>
+            </a:r>
+            <a:r>
+              <a:rPr lang="en-US" sz="1500" dirty="0">
+                <a:solidFill>
+                  <a:schemeClr val="accent1"/>
+                </a:solidFill>
+                <a:cs typeface="Segoe UI Light" panose="020B0502040204020203" pitchFamily="34" charset="0"/>
+              </a:rPr>
+              <a:t>, </a:t>
+            </a:r>
+            <a:r>
+              <a:rPr lang="en-US" sz="1500" b="1" dirty="0">
+                <a:solidFill>
+                  <a:schemeClr val="accent1"/>
+                </a:solidFill>
+                <a:cs typeface="Segoe UI Light" panose="020B0502040204020203" pitchFamily="34" charset="0"/>
+              </a:rPr>
+              <a:t>testing</a:t>
+            </a:r>
+            <a:r>
+              <a:rPr lang="en-US" sz="1500" dirty="0">
+                <a:solidFill>
+                  <a:schemeClr val="accent1"/>
+                </a:solidFill>
+                <a:cs typeface="Segoe UI Light" panose="020B0502040204020203" pitchFamily="34" charset="0"/>
+              </a:rPr>
+              <a:t> (e.g., with Postman)</a:t>
+            </a:r>
+          </a:p>
+        </p:txBody>
+      </p:sp>
+      <p:sp>
+        <p:nvSpPr>
+          <p:cNvPr id="13" name="Mobilisation &amp; Inputs Gathering">
+            <a:extLst>
+              <a:ext uri="{FF2B5EF4-FFF2-40B4-BE49-F238E27FC236}">
+                <a16:creationId xmlns:a16="http://schemas.microsoft.com/office/drawing/2014/main" id="{70D8A9A1-47E4-ABC0-3E7F-BE5F36B4E6BB}"/>
+              </a:ext>
+            </a:extLst>
+          </p:cNvPr>
+          <p:cNvSpPr txBox="1"/>
+          <p:nvPr/>
+        </p:nvSpPr>
+        <p:spPr>
+          <a:xfrm>
+            <a:off x="5791199" y="1632242"/>
+            <a:ext cx="5696269" cy="872332"/>
+          </a:xfrm>
+          <a:prstGeom prst="rect">
+            <a:avLst/>
+          </a:prstGeom>
+          <a:noFill/>
+          <a:ln w="12700" cap="flat">
+            <a:noFill/>
+            <a:miter lim="400000"/>
+          </a:ln>
+          <a:effectLst/>
+          <a:extLst>
+            <a:ext uri="{C572A759-6A51-4108-AA02-DFA0A04FC94B}">
+              <ma14:wrappingTextBoxFlag xmlns:lc="http://schemas.openxmlformats.org/drawingml/2006/lockedCanvas" xmlns:ma14="http://schemas.microsoft.com/office/mac/drawingml/2011/main" xmlns:a14="http://schemas.microsoft.com/office/drawing/2010/main" xmlns:m="http://schemas.openxmlformats.org/officeDocument/2006/math" xmlns="" val="1"/>
+            </a:ext>
+          </a:extLst>
+        </p:spPr>
+        <p:txBody>
+          <a:bodyPr wrap="square" lIns="35719" tIns="35719" rIns="35719" bIns="35719" numCol="1" anchor="t">
+            <a:noAutofit/>
+          </a:bodyPr>
+          <a:lstStyle>
+            <a:defPPr>
+              <a:defRPr lang="en-US"/>
+            </a:defPPr>
+            <a:lvl1pPr marL="0" algn="l" defTabSz="914400" rtl="0" eaLnBrk="1" latinLnBrk="0" hangingPunct="1">
+              <a:defRPr sz="1800" kern="1200">
+                <a:solidFill>
+                  <a:schemeClr val="tx1"/>
+                </a:solidFill>
+                <a:latin typeface="+mn-lt"/>
+                <a:ea typeface="+mn-ea"/>
+                <a:cs typeface="+mn-cs"/>
+              </a:defRPr>
+            </a:lvl1pPr>
+            <a:lvl2pPr marL="457200" algn="l" defTabSz="914400" rtl="0" eaLnBrk="1" latinLnBrk="0" hangingPunct="1">
+              <a:defRPr sz="1800" kern="1200">
+                <a:solidFill>
+                  <a:schemeClr val="tx1"/>
+                </a:solidFill>
+                <a:latin typeface="+mn-lt"/>
+                <a:ea typeface="+mn-ea"/>
+                <a:cs typeface="+mn-cs"/>
+              </a:defRPr>
+            </a:lvl2pPr>
+            <a:lvl3pPr marL="914400" algn="l" defTabSz="914400" rtl="0" eaLnBrk="1" latinLnBrk="0" hangingPunct="1">
+              <a:defRPr sz="1800" kern="1200">
+                <a:solidFill>
+                  <a:schemeClr val="tx1"/>
+                </a:solidFill>
+                <a:latin typeface="+mn-lt"/>
+                <a:ea typeface="+mn-ea"/>
+                <a:cs typeface="+mn-cs"/>
+              </a:defRPr>
+            </a:lvl3pPr>
+            <a:lvl4pPr marL="1371600" algn="l" defTabSz="914400" rtl="0" eaLnBrk="1" latinLnBrk="0" hangingPunct="1">
+              <a:defRPr sz="1800" kern="1200">
+                <a:solidFill>
+                  <a:schemeClr val="tx1"/>
+                </a:solidFill>
+                <a:latin typeface="+mn-lt"/>
+                <a:ea typeface="+mn-ea"/>
+                <a:cs typeface="+mn-cs"/>
+              </a:defRPr>
+            </a:lvl4pPr>
+            <a:lvl5pPr marL="1828800" algn="l" defTabSz="914400" rtl="0" eaLnBrk="1" latinLnBrk="0" hangingPunct="1">
+              <a:defRPr sz="1800" kern="1200">
+                <a:solidFill>
+                  <a:schemeClr val="tx1"/>
+                </a:solidFill>
+                <a:latin typeface="+mn-lt"/>
+                <a:ea typeface="+mn-ea"/>
+                <a:cs typeface="+mn-cs"/>
+              </a:defRPr>
+            </a:lvl5pPr>
+            <a:lvl6pPr marL="2286000" algn="l" defTabSz="914400" rtl="0" eaLnBrk="1" latinLnBrk="0" hangingPunct="1">
+              <a:defRPr sz="1800" kern="1200">
+                <a:solidFill>
+                  <a:schemeClr val="tx1"/>
+                </a:solidFill>
+                <a:latin typeface="+mn-lt"/>
+                <a:ea typeface="+mn-ea"/>
+                <a:cs typeface="+mn-cs"/>
+              </a:defRPr>
+            </a:lvl6pPr>
+            <a:lvl7pPr marL="2743200" algn="l" defTabSz="914400" rtl="0" eaLnBrk="1" latinLnBrk="0" hangingPunct="1">
+              <a:defRPr sz="1800" kern="1200">
+                <a:solidFill>
+                  <a:schemeClr val="tx1"/>
+                </a:solidFill>
+                <a:latin typeface="+mn-lt"/>
+                <a:ea typeface="+mn-ea"/>
+                <a:cs typeface="+mn-cs"/>
+              </a:defRPr>
+            </a:lvl7pPr>
+            <a:lvl8pPr marL="3200400" algn="l" defTabSz="914400" rtl="0" eaLnBrk="1" latinLnBrk="0" hangingPunct="1">
+              <a:defRPr sz="1800" kern="1200">
+                <a:solidFill>
+                  <a:schemeClr val="tx1"/>
+                </a:solidFill>
+                <a:latin typeface="+mn-lt"/>
+                <a:ea typeface="+mn-ea"/>
+                <a:cs typeface="+mn-cs"/>
+              </a:defRPr>
+            </a:lvl8pPr>
+            <a:lvl9pPr marL="3657600" algn="l" defTabSz="914400" rtl="0" eaLnBrk="1" latinLnBrk="0" hangingPunct="1">
+              <a:defRPr sz="1800" kern="1200">
+                <a:solidFill>
+                  <a:schemeClr val="tx1"/>
+                </a:solidFill>
+                <a:latin typeface="+mn-lt"/>
+                <a:ea typeface="+mn-ea"/>
+                <a:cs typeface="+mn-cs"/>
+              </a:defRPr>
+            </a:lvl9pPr>
+          </a:lstStyle>
+          <a:p>
+            <a:pPr marL="193675" indent="-193675">
+              <a:buFont typeface="Arial" panose="020B0604020202020204" pitchFamily="34" charset="0"/>
+              <a:buChar char="•"/>
+            </a:pPr>
+            <a:r>
+              <a:rPr lang="en-US" sz="1500" dirty="0">
+                <a:solidFill>
+                  <a:schemeClr val="accent1"/>
+                </a:solidFill>
+                <a:cs typeface="Segoe UI Light" panose="020B0502040204020203" pitchFamily="34" charset="0"/>
+              </a:rPr>
+              <a:t>Both the frontend and backend were </a:t>
+            </a:r>
+          </a:p>
+          <a:p>
+            <a:pPr marL="539750" indent="-193675">
+              <a:buFont typeface="Arial" panose="020B0604020202020204" pitchFamily="34" charset="0"/>
+              <a:buChar char="•"/>
+            </a:pPr>
+            <a:r>
+              <a:rPr lang="en-US" sz="1500" dirty="0">
+                <a:solidFill>
+                  <a:schemeClr val="accent1"/>
+                </a:solidFill>
+                <a:cs typeface="Segoe UI Light" panose="020B0502040204020203" pitchFamily="34" charset="0"/>
+              </a:rPr>
+              <a:t>fully containerized using Docker</a:t>
+            </a:r>
+          </a:p>
+          <a:p>
+            <a:pPr marL="539750" indent="-193675">
+              <a:buFont typeface="Arial" panose="020B0604020202020204" pitchFamily="34" charset="0"/>
+              <a:buChar char="•"/>
+            </a:pPr>
+            <a:r>
+              <a:rPr lang="en-US" sz="1500" dirty="0">
+                <a:solidFill>
+                  <a:schemeClr val="accent1"/>
+                </a:solidFill>
+                <a:cs typeface="Segoe UI Light" panose="020B0502040204020203" pitchFamily="34" charset="0"/>
+              </a:rPr>
+              <a:t>deployed as isolated services</a:t>
+            </a:r>
+          </a:p>
+          <a:p>
+            <a:pPr marL="193675" indent="-193675">
+              <a:buFont typeface="Arial" panose="020B0604020202020204" pitchFamily="34" charset="0"/>
+              <a:buChar char="•"/>
+            </a:pPr>
+            <a:endParaRPr lang="en-US" sz="1500" dirty="0">
+              <a:solidFill>
+                <a:schemeClr val="accent1"/>
+              </a:solidFill>
+              <a:cs typeface="Segoe UI Light" panose="020B0502040204020203" pitchFamily="34" charset="0"/>
+            </a:endParaRPr>
+          </a:p>
+          <a:p>
+            <a:pPr marL="193675" indent="-193675">
+              <a:buFont typeface="Arial" panose="020B0604020202020204" pitchFamily="34" charset="0"/>
+              <a:buChar char="•"/>
+            </a:pPr>
+            <a:r>
+              <a:rPr lang="en-US" sz="1500" dirty="0">
+                <a:solidFill>
+                  <a:schemeClr val="accent1"/>
+                </a:solidFill>
+                <a:cs typeface="Segoe UI Light" panose="020B0502040204020203" pitchFamily="34" charset="0"/>
+              </a:rPr>
+              <a:t>This enabled us to:</a:t>
+            </a:r>
+          </a:p>
+          <a:p>
+            <a:pPr marL="650875" lvl="1" indent="-193675">
+              <a:buFont typeface="Arial" panose="020B0604020202020204" pitchFamily="34" charset="0"/>
+              <a:buChar char="•"/>
+            </a:pPr>
+            <a:r>
+              <a:rPr lang="en-US" sz="1500" dirty="0">
+                <a:solidFill>
+                  <a:schemeClr val="accent1"/>
+                </a:solidFill>
+                <a:cs typeface="Segoe UI Light" panose="020B0502040204020203" pitchFamily="34" charset="0"/>
+              </a:rPr>
+              <a:t>Standardize builds across environments (local and cloud).</a:t>
+            </a:r>
+          </a:p>
+          <a:p>
+            <a:pPr marL="650875" lvl="1" indent="-193675">
+              <a:buFont typeface="Arial" panose="020B0604020202020204" pitchFamily="34" charset="0"/>
+              <a:buChar char="•"/>
+            </a:pPr>
+            <a:r>
+              <a:rPr lang="en-US" sz="1500" dirty="0">
+                <a:solidFill>
+                  <a:schemeClr val="accent1"/>
+                </a:solidFill>
+                <a:cs typeface="Segoe UI Light" panose="020B0502040204020203" pitchFamily="34" charset="0"/>
+              </a:rPr>
+              <a:t>Simplify testing and versioning.</a:t>
+            </a:r>
+          </a:p>
+          <a:p>
+            <a:pPr marL="193675" indent="-193675">
+              <a:buFont typeface="Arial" panose="020B0604020202020204" pitchFamily="34" charset="0"/>
+              <a:buChar char="•"/>
+            </a:pPr>
+            <a:endParaRPr lang="en-US" sz="1500" dirty="0">
+              <a:solidFill>
+                <a:schemeClr val="accent1"/>
+              </a:solidFill>
+              <a:cs typeface="Segoe UI Light" panose="020B0502040204020203" pitchFamily="34" charset="0"/>
+            </a:endParaRPr>
+          </a:p>
+          <a:p>
+            <a:pPr marL="193675" indent="-193675">
+              <a:buFont typeface="Arial" panose="020B0604020202020204" pitchFamily="34" charset="0"/>
+              <a:buChar char="•"/>
+            </a:pPr>
+            <a:r>
+              <a:rPr lang="en-US" sz="1500" dirty="0">
+                <a:solidFill>
+                  <a:schemeClr val="accent1"/>
+                </a:solidFill>
+                <a:cs typeface="Segoe UI Light" panose="020B0502040204020203" pitchFamily="34" charset="0"/>
+              </a:rPr>
+              <a:t>Ensure parity between dev, staging, and production.</a:t>
+            </a:r>
+          </a:p>
+        </p:txBody>
+      </p:sp>
+      <p:sp>
+        <p:nvSpPr>
+          <p:cNvPr id="15" name="Line">
+            <a:extLst>
+              <a:ext uri="{FF2B5EF4-FFF2-40B4-BE49-F238E27FC236}">
+                <a16:creationId xmlns:a16="http://schemas.microsoft.com/office/drawing/2014/main" id="{0CCDFFCA-06E3-40D6-33A0-F31563955D7C}"/>
+              </a:ext>
+            </a:extLst>
+          </p:cNvPr>
+          <p:cNvSpPr/>
+          <p:nvPr/>
+        </p:nvSpPr>
+        <p:spPr>
+          <a:xfrm>
+            <a:off x="5551747" y="1438456"/>
+            <a:ext cx="6114791" cy="0"/>
+          </a:xfrm>
+          <a:prstGeom prst="line">
+            <a:avLst/>
+          </a:prstGeom>
+          <a:noFill/>
+          <a:ln w="50800" cap="flat">
+            <a:solidFill>
+              <a:srgbClr val="FFB310"/>
+            </a:solidFill>
+            <a:prstDash val="solid"/>
+            <a:miter lim="400000"/>
+          </a:ln>
+          <a:effectLst/>
+        </p:spPr>
+        <p:txBody>
+          <a:bodyPr wrap="square" lIns="0" tIns="0" rIns="0" bIns="0" numCol="1" anchor="ctr">
+            <a:noAutofit/>
+          </a:bodyPr>
+          <a:lstStyle>
+            <a:defPPr>
+              <a:defRPr lang="en-US"/>
+            </a:defPPr>
+            <a:lvl1pPr marL="0" algn="l" defTabSz="914400" rtl="0" eaLnBrk="1" latinLnBrk="0" hangingPunct="1">
+              <a:defRPr sz="1800" kern="1200">
+                <a:solidFill>
+                  <a:schemeClr val="tx1"/>
+                </a:solidFill>
+                <a:latin typeface="+mn-lt"/>
+                <a:ea typeface="+mn-ea"/>
+                <a:cs typeface="+mn-cs"/>
+              </a:defRPr>
+            </a:lvl1pPr>
+            <a:lvl2pPr marL="457200" algn="l" defTabSz="914400" rtl="0" eaLnBrk="1" latinLnBrk="0" hangingPunct="1">
+              <a:defRPr sz="1800" kern="1200">
+                <a:solidFill>
+                  <a:schemeClr val="tx1"/>
+                </a:solidFill>
+                <a:latin typeface="+mn-lt"/>
+                <a:ea typeface="+mn-ea"/>
+                <a:cs typeface="+mn-cs"/>
+              </a:defRPr>
+            </a:lvl2pPr>
+            <a:lvl3pPr marL="914400" algn="l" defTabSz="914400" rtl="0" eaLnBrk="1" latinLnBrk="0" hangingPunct="1">
+              <a:defRPr sz="1800" kern="1200">
+                <a:solidFill>
+                  <a:schemeClr val="tx1"/>
+                </a:solidFill>
+                <a:latin typeface="+mn-lt"/>
+                <a:ea typeface="+mn-ea"/>
+                <a:cs typeface="+mn-cs"/>
+              </a:defRPr>
+            </a:lvl3pPr>
+            <a:lvl4pPr marL="1371600" algn="l" defTabSz="914400" rtl="0" eaLnBrk="1" latinLnBrk="0" hangingPunct="1">
+              <a:defRPr sz="1800" kern="1200">
+                <a:solidFill>
+                  <a:schemeClr val="tx1"/>
+                </a:solidFill>
+                <a:latin typeface="+mn-lt"/>
+                <a:ea typeface="+mn-ea"/>
+                <a:cs typeface="+mn-cs"/>
+              </a:defRPr>
+            </a:lvl4pPr>
+            <a:lvl5pPr marL="1828800" algn="l" defTabSz="914400" rtl="0" eaLnBrk="1" latinLnBrk="0" hangingPunct="1">
+              <a:defRPr sz="1800" kern="1200">
+                <a:solidFill>
+                  <a:schemeClr val="tx1"/>
+                </a:solidFill>
+                <a:latin typeface="+mn-lt"/>
+                <a:ea typeface="+mn-ea"/>
+                <a:cs typeface="+mn-cs"/>
+              </a:defRPr>
+            </a:lvl5pPr>
+            <a:lvl6pPr marL="2286000" algn="l" defTabSz="914400" rtl="0" eaLnBrk="1" latinLnBrk="0" hangingPunct="1">
+              <a:defRPr sz="1800" kern="1200">
+                <a:solidFill>
+                  <a:schemeClr val="tx1"/>
+                </a:solidFill>
+                <a:latin typeface="+mn-lt"/>
+                <a:ea typeface="+mn-ea"/>
+                <a:cs typeface="+mn-cs"/>
+              </a:defRPr>
+            </a:lvl6pPr>
+            <a:lvl7pPr marL="2743200" algn="l" defTabSz="914400" rtl="0" eaLnBrk="1" latinLnBrk="0" hangingPunct="1">
+              <a:defRPr sz="1800" kern="1200">
+                <a:solidFill>
+                  <a:schemeClr val="tx1"/>
+                </a:solidFill>
+                <a:latin typeface="+mn-lt"/>
+                <a:ea typeface="+mn-ea"/>
+                <a:cs typeface="+mn-cs"/>
+              </a:defRPr>
+            </a:lvl7pPr>
+            <a:lvl8pPr marL="3200400" algn="l" defTabSz="914400" rtl="0" eaLnBrk="1" latinLnBrk="0" hangingPunct="1">
+              <a:defRPr sz="1800" kern="1200">
+                <a:solidFill>
+                  <a:schemeClr val="tx1"/>
+                </a:solidFill>
+                <a:latin typeface="+mn-lt"/>
+                <a:ea typeface="+mn-ea"/>
+                <a:cs typeface="+mn-cs"/>
+              </a:defRPr>
+            </a:lvl8pPr>
+            <a:lvl9pPr marL="3657600" algn="l" defTabSz="914400" rtl="0" eaLnBrk="1" latinLnBrk="0" hangingPunct="1">
+              <a:defRPr sz="1800" kern="1200">
+                <a:solidFill>
+                  <a:schemeClr val="tx1"/>
+                </a:solidFill>
+                <a:latin typeface="+mn-lt"/>
+                <a:ea typeface="+mn-ea"/>
+                <a:cs typeface="+mn-cs"/>
+              </a:defRPr>
+            </a:lvl9pPr>
+          </a:lstStyle>
+          <a:p>
+            <a:pPr marL="0" marR="0" lvl="0" indent="0" algn="ctr" defTabSz="410766" rtl="0" eaLnBrk="1" fontAlgn="auto" latinLnBrk="0" hangingPunct="0">
+              <a:lnSpc>
+                <a:spcPct val="100000"/>
+              </a:lnSpc>
+              <a:spcBef>
+                <a:spcPts val="0"/>
+              </a:spcBef>
+              <a:spcAft>
+                <a:spcPts val="0"/>
+              </a:spcAft>
+              <a:buClrTx/>
+              <a:buSzTx/>
+              <a:buFontTx/>
+              <a:buNone/>
+              <a:tabLst/>
+              <a:defRPr sz="3000" b="1">
+                <a:solidFill>
+                  <a:srgbClr val="FFFFFF"/>
+                </a:solidFill>
+              </a:defRPr>
+            </a:pPr>
+            <a:endParaRPr kumimoji="0" lang="en-US" sz="1200" b="1" i="0" u="none" strike="noStrike" kern="0" cap="none" spc="0" normalizeH="0" baseline="0" noProof="0" dirty="0">
+              <a:ln>
+                <a:noFill/>
+              </a:ln>
+              <a:solidFill>
+                <a:srgbClr val="44546A"/>
+              </a:solidFill>
+              <a:effectLst/>
+              <a:uLnTx/>
+              <a:uFillTx/>
+              <a:ea typeface="+mn-ea"/>
+              <a:cs typeface="Segoe UI"/>
+              <a:sym typeface="Segoe UI"/>
+            </a:endParaRPr>
+          </a:p>
+        </p:txBody>
+      </p:sp>
+      <p:sp>
+        <p:nvSpPr>
+          <p:cNvPr id="23" name="Rounded Rectangle">
+            <a:extLst>
+              <a:ext uri="{FF2B5EF4-FFF2-40B4-BE49-F238E27FC236}">
+                <a16:creationId xmlns:a16="http://schemas.microsoft.com/office/drawing/2014/main" id="{6892E98A-DF5A-1040-F6C3-63A08A2AB1E4}"/>
+              </a:ext>
+            </a:extLst>
+          </p:cNvPr>
+          <p:cNvSpPr/>
+          <p:nvPr/>
+        </p:nvSpPr>
+        <p:spPr>
+          <a:xfrm>
+            <a:off x="515938" y="4040584"/>
+            <a:ext cx="4884740" cy="2303063"/>
+          </a:xfrm>
+          <a:prstGeom prst="roundRect">
+            <a:avLst>
+              <a:gd name="adj" fmla="val 3067"/>
+            </a:avLst>
+          </a:prstGeom>
+          <a:solidFill>
+            <a:schemeClr val="bg1">
+              <a:alpha val="87000"/>
+            </a:schemeClr>
+          </a:solidFill>
+          <a:ln w="12700" cap="flat">
+            <a:noFill/>
+            <a:miter lim="400000"/>
+          </a:ln>
+          <a:effectLst>
+            <a:outerShdw blurRad="952500" dist="444500" dir="5400000" rotWithShape="0">
+              <a:srgbClr val="000000">
+                <a:alpha val="15000"/>
+              </a:srgbClr>
+            </a:outerShdw>
+          </a:effectLst>
+        </p:spPr>
+        <p:txBody>
+          <a:bodyPr wrap="square" lIns="0" tIns="0" rIns="0" bIns="0" numCol="1" anchor="ctr">
+            <a:noAutofit/>
+          </a:bodyPr>
+          <a:lstStyle>
+            <a:defPPr>
+              <a:defRPr lang="en-US"/>
+            </a:defPPr>
+            <a:lvl1pPr marL="0" algn="l" defTabSz="914400" rtl="0" eaLnBrk="1" latinLnBrk="0" hangingPunct="1">
+              <a:defRPr sz="1800" kern="1200">
+                <a:solidFill>
+                  <a:schemeClr val="tx1"/>
+                </a:solidFill>
+                <a:latin typeface="+mn-lt"/>
+                <a:ea typeface="+mn-ea"/>
+                <a:cs typeface="+mn-cs"/>
+              </a:defRPr>
+            </a:lvl1pPr>
+            <a:lvl2pPr marL="457200" algn="l" defTabSz="914400" rtl="0" eaLnBrk="1" latinLnBrk="0" hangingPunct="1">
+              <a:defRPr sz="1800" kern="1200">
+                <a:solidFill>
+                  <a:schemeClr val="tx1"/>
+                </a:solidFill>
+                <a:latin typeface="+mn-lt"/>
+                <a:ea typeface="+mn-ea"/>
+                <a:cs typeface="+mn-cs"/>
+              </a:defRPr>
+            </a:lvl2pPr>
+            <a:lvl3pPr marL="914400" algn="l" defTabSz="914400" rtl="0" eaLnBrk="1" latinLnBrk="0" hangingPunct="1">
+              <a:defRPr sz="1800" kern="1200">
+                <a:solidFill>
+                  <a:schemeClr val="tx1"/>
+                </a:solidFill>
+                <a:latin typeface="+mn-lt"/>
+                <a:ea typeface="+mn-ea"/>
+                <a:cs typeface="+mn-cs"/>
+              </a:defRPr>
+            </a:lvl3pPr>
+            <a:lvl4pPr marL="1371600" algn="l" defTabSz="914400" rtl="0" eaLnBrk="1" latinLnBrk="0" hangingPunct="1">
+              <a:defRPr sz="1800" kern="1200">
+                <a:solidFill>
+                  <a:schemeClr val="tx1"/>
+                </a:solidFill>
+                <a:latin typeface="+mn-lt"/>
+                <a:ea typeface="+mn-ea"/>
+                <a:cs typeface="+mn-cs"/>
+              </a:defRPr>
+            </a:lvl4pPr>
+            <a:lvl5pPr marL="1828800" algn="l" defTabSz="914400" rtl="0" eaLnBrk="1" latinLnBrk="0" hangingPunct="1">
+              <a:defRPr sz="1800" kern="1200">
+                <a:solidFill>
+                  <a:schemeClr val="tx1"/>
+                </a:solidFill>
+                <a:latin typeface="+mn-lt"/>
+                <a:ea typeface="+mn-ea"/>
+                <a:cs typeface="+mn-cs"/>
+              </a:defRPr>
+            </a:lvl5pPr>
+            <a:lvl6pPr marL="2286000" algn="l" defTabSz="914400" rtl="0" eaLnBrk="1" latinLnBrk="0" hangingPunct="1">
+              <a:defRPr sz="1800" kern="1200">
+                <a:solidFill>
+                  <a:schemeClr val="tx1"/>
+                </a:solidFill>
+                <a:latin typeface="+mn-lt"/>
+                <a:ea typeface="+mn-ea"/>
+                <a:cs typeface="+mn-cs"/>
+              </a:defRPr>
+            </a:lvl6pPr>
+            <a:lvl7pPr marL="2743200" algn="l" defTabSz="914400" rtl="0" eaLnBrk="1" latinLnBrk="0" hangingPunct="1">
+              <a:defRPr sz="1800" kern="1200">
+                <a:solidFill>
+                  <a:schemeClr val="tx1"/>
+                </a:solidFill>
+                <a:latin typeface="+mn-lt"/>
+                <a:ea typeface="+mn-ea"/>
+                <a:cs typeface="+mn-cs"/>
+              </a:defRPr>
+            </a:lvl7pPr>
+            <a:lvl8pPr marL="3200400" algn="l" defTabSz="914400" rtl="0" eaLnBrk="1" latinLnBrk="0" hangingPunct="1">
+              <a:defRPr sz="1800" kern="1200">
+                <a:solidFill>
+                  <a:schemeClr val="tx1"/>
+                </a:solidFill>
+                <a:latin typeface="+mn-lt"/>
+                <a:ea typeface="+mn-ea"/>
+                <a:cs typeface="+mn-cs"/>
+              </a:defRPr>
+            </a:lvl8pPr>
+            <a:lvl9pPr marL="3657600" algn="l" defTabSz="914400" rtl="0" eaLnBrk="1" latinLnBrk="0" hangingPunct="1">
+              <a:defRPr sz="1800" kern="1200">
+                <a:solidFill>
+                  <a:schemeClr val="tx1"/>
+                </a:solidFill>
+                <a:latin typeface="+mn-lt"/>
+                <a:ea typeface="+mn-ea"/>
+                <a:cs typeface="+mn-cs"/>
+              </a:defRPr>
+            </a:lvl9pPr>
+          </a:lstStyle>
+          <a:p>
+            <a:pPr marL="0" marR="0" lvl="0" indent="0" algn="ctr" defTabSz="410766" rtl="0" eaLnBrk="1" fontAlgn="auto" latinLnBrk="0" hangingPunct="0">
+              <a:lnSpc>
+                <a:spcPct val="100000"/>
+              </a:lnSpc>
+              <a:spcBef>
+                <a:spcPts val="0"/>
+              </a:spcBef>
+              <a:spcAft>
+                <a:spcPts val="0"/>
+              </a:spcAft>
+              <a:buClrTx/>
+              <a:buSzTx/>
+              <a:buFontTx/>
+              <a:buNone/>
+              <a:tabLst/>
+              <a:defRPr sz="3000" b="1">
+                <a:solidFill>
+                  <a:srgbClr val="FFFFFF"/>
+                </a:solidFill>
+              </a:defRPr>
+            </a:pPr>
+            <a:endParaRPr kumimoji="0" sz="1500" b="1" i="0" u="none" strike="noStrike" kern="0" cap="none" spc="0" normalizeH="0" baseline="0" noProof="0" dirty="0">
+              <a:ln>
+                <a:noFill/>
+              </a:ln>
+              <a:solidFill>
+                <a:srgbClr val="44546A"/>
+              </a:solidFill>
+              <a:effectLst/>
+              <a:uLnTx/>
+              <a:uFillTx/>
+              <a:ea typeface="+mn-ea"/>
+              <a:cs typeface="Segoe UI"/>
+              <a:sym typeface="Segoe UI"/>
+            </a:endParaRPr>
+          </a:p>
+        </p:txBody>
+      </p:sp>
+      <p:sp>
+        <p:nvSpPr>
+          <p:cNvPr id="30" name="Mobilisation &amp; Inputs Gathering">
+            <a:extLst>
+              <a:ext uri="{FF2B5EF4-FFF2-40B4-BE49-F238E27FC236}">
+                <a16:creationId xmlns:a16="http://schemas.microsoft.com/office/drawing/2014/main" id="{2D0F16AC-278D-D7C7-CFC1-5659661AF08A}"/>
+              </a:ext>
+            </a:extLst>
+          </p:cNvPr>
+          <p:cNvSpPr txBox="1"/>
+          <p:nvPr/>
+        </p:nvSpPr>
+        <p:spPr>
+          <a:xfrm>
+            <a:off x="515937" y="4167612"/>
+            <a:ext cx="5376861" cy="377910"/>
+          </a:xfrm>
+          <a:prstGeom prst="rect">
+            <a:avLst/>
+          </a:prstGeom>
+          <a:noFill/>
+          <a:ln w="12700" cap="flat">
+            <a:noFill/>
+            <a:miter lim="400000"/>
+          </a:ln>
+          <a:effectLst/>
+          <a:extLst>
+            <a:ext uri="{C572A759-6A51-4108-AA02-DFA0A04FC94B}">
+              <ma14:wrappingTextBoxFlag xmlns:lc="http://schemas.openxmlformats.org/drawingml/2006/lockedCanvas" xmlns:ma14="http://schemas.microsoft.com/office/mac/drawingml/2011/main" xmlns:a14="http://schemas.microsoft.com/office/drawing/2010/main" xmlns:m="http://schemas.openxmlformats.org/officeDocument/2006/math" xmlns="" val="1"/>
+            </a:ext>
+          </a:extLst>
+        </p:spPr>
+        <p:txBody>
+          <a:bodyPr wrap="square" lIns="35719" tIns="35719" rIns="35719" bIns="35719" numCol="1" anchor="t">
+            <a:noAutofit/>
+          </a:bodyPr>
+          <a:lstStyle>
+            <a:defPPr>
+              <a:defRPr lang="en-US"/>
+            </a:defPPr>
+            <a:lvl1pPr marL="0" algn="l" defTabSz="914400" rtl="0" eaLnBrk="1" latinLnBrk="0" hangingPunct="1">
+              <a:defRPr sz="1800" kern="1200">
+                <a:solidFill>
+                  <a:schemeClr val="tx1"/>
+                </a:solidFill>
+                <a:latin typeface="+mn-lt"/>
+                <a:ea typeface="+mn-ea"/>
+                <a:cs typeface="+mn-cs"/>
+              </a:defRPr>
+            </a:lvl1pPr>
+            <a:lvl2pPr marL="457200" algn="l" defTabSz="914400" rtl="0" eaLnBrk="1" latinLnBrk="0" hangingPunct="1">
+              <a:defRPr sz="1800" kern="1200">
+                <a:solidFill>
+                  <a:schemeClr val="tx1"/>
+                </a:solidFill>
+                <a:latin typeface="+mn-lt"/>
+                <a:ea typeface="+mn-ea"/>
+                <a:cs typeface="+mn-cs"/>
+              </a:defRPr>
+            </a:lvl2pPr>
+            <a:lvl3pPr marL="914400" algn="l" defTabSz="914400" rtl="0" eaLnBrk="1" latinLnBrk="0" hangingPunct="1">
+              <a:defRPr sz="1800" kern="1200">
+                <a:solidFill>
+                  <a:schemeClr val="tx1"/>
+                </a:solidFill>
+                <a:latin typeface="+mn-lt"/>
+                <a:ea typeface="+mn-ea"/>
+                <a:cs typeface="+mn-cs"/>
+              </a:defRPr>
+            </a:lvl3pPr>
+            <a:lvl4pPr marL="1371600" algn="l" defTabSz="914400" rtl="0" eaLnBrk="1" latinLnBrk="0" hangingPunct="1">
+              <a:defRPr sz="1800" kern="1200">
+                <a:solidFill>
+                  <a:schemeClr val="tx1"/>
+                </a:solidFill>
+                <a:latin typeface="+mn-lt"/>
+                <a:ea typeface="+mn-ea"/>
+                <a:cs typeface="+mn-cs"/>
+              </a:defRPr>
+            </a:lvl4pPr>
+            <a:lvl5pPr marL="1828800" algn="l" defTabSz="914400" rtl="0" eaLnBrk="1" latinLnBrk="0" hangingPunct="1">
+              <a:defRPr sz="1800" kern="1200">
+                <a:solidFill>
+                  <a:schemeClr val="tx1"/>
+                </a:solidFill>
+                <a:latin typeface="+mn-lt"/>
+                <a:ea typeface="+mn-ea"/>
+                <a:cs typeface="+mn-cs"/>
+              </a:defRPr>
+            </a:lvl5pPr>
+            <a:lvl6pPr marL="2286000" algn="l" defTabSz="914400" rtl="0" eaLnBrk="1" latinLnBrk="0" hangingPunct="1">
+              <a:defRPr sz="1800" kern="1200">
+                <a:solidFill>
+                  <a:schemeClr val="tx1"/>
+                </a:solidFill>
+                <a:latin typeface="+mn-lt"/>
+                <a:ea typeface="+mn-ea"/>
+                <a:cs typeface="+mn-cs"/>
+              </a:defRPr>
+            </a:lvl6pPr>
+            <a:lvl7pPr marL="2743200" algn="l" defTabSz="914400" rtl="0" eaLnBrk="1" latinLnBrk="0" hangingPunct="1">
+              <a:defRPr sz="1800" kern="1200">
+                <a:solidFill>
+                  <a:schemeClr val="tx1"/>
+                </a:solidFill>
+                <a:latin typeface="+mn-lt"/>
+                <a:ea typeface="+mn-ea"/>
+                <a:cs typeface="+mn-cs"/>
+              </a:defRPr>
+            </a:lvl7pPr>
+            <a:lvl8pPr marL="3200400" algn="l" defTabSz="914400" rtl="0" eaLnBrk="1" latinLnBrk="0" hangingPunct="1">
+              <a:defRPr sz="1800" kern="1200">
+                <a:solidFill>
+                  <a:schemeClr val="tx1"/>
+                </a:solidFill>
+                <a:latin typeface="+mn-lt"/>
+                <a:ea typeface="+mn-ea"/>
+                <a:cs typeface="+mn-cs"/>
+              </a:defRPr>
+            </a:lvl8pPr>
+            <a:lvl9pPr marL="3657600" algn="l" defTabSz="914400" rtl="0" eaLnBrk="1" latinLnBrk="0" hangingPunct="1">
+              <a:defRPr sz="1800" kern="1200">
+                <a:solidFill>
+                  <a:schemeClr val="tx1"/>
+                </a:solidFill>
+                <a:latin typeface="+mn-lt"/>
+                <a:ea typeface="+mn-ea"/>
+                <a:cs typeface="+mn-cs"/>
+              </a:defRPr>
+            </a:lvl9pPr>
+          </a:lstStyle>
+          <a:p>
+            <a:pPr algn="ctr" defTabSz="533400">
+              <a:lnSpc>
+                <a:spcPct val="90000"/>
+              </a:lnSpc>
+              <a:spcBef>
+                <a:spcPct val="0"/>
+              </a:spcBef>
+              <a:spcAft>
+                <a:spcPct val="35000"/>
+              </a:spcAft>
+            </a:pPr>
+            <a:r>
+              <a:rPr lang="en-US" b="1" noProof="0" dirty="0">
+                <a:solidFill>
+                  <a:srgbClr val="44546A"/>
+                </a:solidFill>
+                <a:cs typeface="Segoe UI Light" panose="020B0502040204020203" pitchFamily="34" charset="0"/>
+              </a:rPr>
+              <a:t>Deployment on Azure</a:t>
+            </a:r>
+          </a:p>
+        </p:txBody>
+      </p:sp>
+      <p:sp>
+        <p:nvSpPr>
+          <p:cNvPr id="32" name="Mobilisation &amp; Inputs Gathering">
+            <a:extLst>
+              <a:ext uri="{FF2B5EF4-FFF2-40B4-BE49-F238E27FC236}">
+                <a16:creationId xmlns:a16="http://schemas.microsoft.com/office/drawing/2014/main" id="{0E4337C1-044D-1EF6-D36A-59FD7DE9BE1D}"/>
+              </a:ext>
+            </a:extLst>
+          </p:cNvPr>
+          <p:cNvSpPr txBox="1"/>
+          <p:nvPr/>
+        </p:nvSpPr>
+        <p:spPr>
+          <a:xfrm>
+            <a:off x="805498" y="4717895"/>
+            <a:ext cx="4186757" cy="1141621"/>
+          </a:xfrm>
+          <a:prstGeom prst="rect">
+            <a:avLst/>
+          </a:prstGeom>
+          <a:noFill/>
+          <a:ln w="12700" cap="flat">
+            <a:noFill/>
+            <a:miter lim="400000"/>
+          </a:ln>
+          <a:effectLst/>
+          <a:extLst>
+            <a:ext uri="{C572A759-6A51-4108-AA02-DFA0A04FC94B}">
+              <ma14:wrappingTextBoxFlag xmlns:lc="http://schemas.openxmlformats.org/drawingml/2006/lockedCanvas" xmlns:ma14="http://schemas.microsoft.com/office/mac/drawingml/2011/main" xmlns:a14="http://schemas.microsoft.com/office/drawing/2010/main" xmlns:m="http://schemas.openxmlformats.org/officeDocument/2006/math" xmlns="" val="1"/>
+            </a:ext>
+          </a:extLst>
+        </p:spPr>
+        <p:txBody>
+          <a:bodyPr wrap="square" lIns="35719" tIns="35719" rIns="35719" bIns="35719" numCol="1" anchor="t">
+            <a:noAutofit/>
+          </a:bodyPr>
+          <a:lstStyle>
+            <a:defPPr>
+              <a:defRPr lang="en-US"/>
+            </a:defPPr>
+            <a:lvl1pPr marL="0" algn="l" defTabSz="914400" rtl="0" eaLnBrk="1" latinLnBrk="0" hangingPunct="1">
+              <a:defRPr sz="1800" kern="1200">
+                <a:solidFill>
+                  <a:schemeClr val="tx1"/>
+                </a:solidFill>
+                <a:latin typeface="+mn-lt"/>
+                <a:ea typeface="+mn-ea"/>
+                <a:cs typeface="+mn-cs"/>
+              </a:defRPr>
+            </a:lvl1pPr>
+            <a:lvl2pPr marL="457200" algn="l" defTabSz="914400" rtl="0" eaLnBrk="1" latinLnBrk="0" hangingPunct="1">
+              <a:defRPr sz="1800" kern="1200">
+                <a:solidFill>
+                  <a:schemeClr val="tx1"/>
+                </a:solidFill>
+                <a:latin typeface="+mn-lt"/>
+                <a:ea typeface="+mn-ea"/>
+                <a:cs typeface="+mn-cs"/>
+              </a:defRPr>
+            </a:lvl2pPr>
+            <a:lvl3pPr marL="914400" algn="l" defTabSz="914400" rtl="0" eaLnBrk="1" latinLnBrk="0" hangingPunct="1">
+              <a:defRPr sz="1800" kern="1200">
+                <a:solidFill>
+                  <a:schemeClr val="tx1"/>
+                </a:solidFill>
+                <a:latin typeface="+mn-lt"/>
+                <a:ea typeface="+mn-ea"/>
+                <a:cs typeface="+mn-cs"/>
+              </a:defRPr>
+            </a:lvl3pPr>
+            <a:lvl4pPr marL="1371600" algn="l" defTabSz="914400" rtl="0" eaLnBrk="1" latinLnBrk="0" hangingPunct="1">
+              <a:defRPr sz="1800" kern="1200">
+                <a:solidFill>
+                  <a:schemeClr val="tx1"/>
+                </a:solidFill>
+                <a:latin typeface="+mn-lt"/>
+                <a:ea typeface="+mn-ea"/>
+                <a:cs typeface="+mn-cs"/>
+              </a:defRPr>
+            </a:lvl4pPr>
+            <a:lvl5pPr marL="1828800" algn="l" defTabSz="914400" rtl="0" eaLnBrk="1" latinLnBrk="0" hangingPunct="1">
+              <a:defRPr sz="1800" kern="1200">
+                <a:solidFill>
+                  <a:schemeClr val="tx1"/>
+                </a:solidFill>
+                <a:latin typeface="+mn-lt"/>
+                <a:ea typeface="+mn-ea"/>
+                <a:cs typeface="+mn-cs"/>
+              </a:defRPr>
+            </a:lvl5pPr>
+            <a:lvl6pPr marL="2286000" algn="l" defTabSz="914400" rtl="0" eaLnBrk="1" latinLnBrk="0" hangingPunct="1">
+              <a:defRPr sz="1800" kern="1200">
+                <a:solidFill>
+                  <a:schemeClr val="tx1"/>
+                </a:solidFill>
+                <a:latin typeface="+mn-lt"/>
+                <a:ea typeface="+mn-ea"/>
+                <a:cs typeface="+mn-cs"/>
+              </a:defRPr>
+            </a:lvl6pPr>
+            <a:lvl7pPr marL="2743200" algn="l" defTabSz="914400" rtl="0" eaLnBrk="1" latinLnBrk="0" hangingPunct="1">
+              <a:defRPr sz="1800" kern="1200">
+                <a:solidFill>
+                  <a:schemeClr val="tx1"/>
+                </a:solidFill>
+                <a:latin typeface="+mn-lt"/>
+                <a:ea typeface="+mn-ea"/>
+                <a:cs typeface="+mn-cs"/>
+              </a:defRPr>
+            </a:lvl7pPr>
+            <a:lvl8pPr marL="3200400" algn="l" defTabSz="914400" rtl="0" eaLnBrk="1" latinLnBrk="0" hangingPunct="1">
+              <a:defRPr sz="1800" kern="1200">
+                <a:solidFill>
+                  <a:schemeClr val="tx1"/>
+                </a:solidFill>
+                <a:latin typeface="+mn-lt"/>
+                <a:ea typeface="+mn-ea"/>
+                <a:cs typeface="+mn-cs"/>
+              </a:defRPr>
+            </a:lvl8pPr>
+            <a:lvl9pPr marL="3657600" algn="l" defTabSz="914400" rtl="0" eaLnBrk="1" latinLnBrk="0" hangingPunct="1">
+              <a:defRPr sz="1800" kern="1200">
+                <a:solidFill>
+                  <a:schemeClr val="tx1"/>
+                </a:solidFill>
+                <a:latin typeface="+mn-lt"/>
+                <a:ea typeface="+mn-ea"/>
+                <a:cs typeface="+mn-cs"/>
+              </a:defRPr>
+            </a:lvl9pPr>
+          </a:lstStyle>
+          <a:p>
+            <a:r>
+              <a:rPr lang="en-US" sz="1500" dirty="0">
+                <a:solidFill>
+                  <a:schemeClr val="accent1"/>
+                </a:solidFill>
+                <a:cs typeface="Segoe UI Light" panose="020B0502040204020203" pitchFamily="34" charset="0"/>
+              </a:rPr>
+              <a:t>We chose Azure for its enterprise-grade deployment capabilities and flexibility:</a:t>
+            </a:r>
+          </a:p>
+          <a:p>
+            <a:pPr marL="285750" indent="-285750">
+              <a:buFont typeface="Arial" panose="020B0604020202020204" pitchFamily="34" charset="0"/>
+              <a:buChar char="•"/>
+            </a:pPr>
+            <a:r>
+              <a:rPr lang="en-US" sz="1500" b="1" dirty="0">
+                <a:solidFill>
+                  <a:schemeClr val="accent1"/>
+                </a:solidFill>
+                <a:cs typeface="Segoe UI Light" panose="020B0502040204020203" pitchFamily="34" charset="0"/>
+              </a:rPr>
+              <a:t>Azure App Service </a:t>
+            </a:r>
+            <a:r>
+              <a:rPr lang="en-US" sz="1500" dirty="0">
+                <a:solidFill>
+                  <a:schemeClr val="accent1"/>
+                </a:solidFill>
+                <a:cs typeface="Segoe UI Light" panose="020B0502040204020203" pitchFamily="34" charset="0"/>
+              </a:rPr>
+              <a:t>for both frontend (</a:t>
+            </a:r>
+            <a:r>
+              <a:rPr lang="en-US" sz="1500" dirty="0" err="1">
+                <a:solidFill>
+                  <a:schemeClr val="accent1"/>
+                </a:solidFill>
+                <a:cs typeface="Segoe UI Light" panose="020B0502040204020203" pitchFamily="34" charset="0"/>
+              </a:rPr>
+              <a:t>Streamlit</a:t>
+            </a:r>
+            <a:r>
+              <a:rPr lang="en-US" sz="1500" dirty="0">
+                <a:solidFill>
+                  <a:schemeClr val="accent1"/>
+                </a:solidFill>
+                <a:cs typeface="Segoe UI Light" panose="020B0502040204020203" pitchFamily="34" charset="0"/>
+              </a:rPr>
+              <a:t>) and backend (</a:t>
+            </a:r>
+            <a:r>
+              <a:rPr lang="en-US" sz="1500" dirty="0" err="1">
+                <a:solidFill>
+                  <a:schemeClr val="accent1"/>
+                </a:solidFill>
+                <a:cs typeface="Segoe UI Light" panose="020B0502040204020203" pitchFamily="34" charset="0"/>
+              </a:rPr>
+              <a:t>FastAPI</a:t>
+            </a:r>
+            <a:r>
+              <a:rPr lang="en-US" sz="1500" dirty="0">
+                <a:solidFill>
+                  <a:schemeClr val="accent1"/>
+                </a:solidFill>
+                <a:cs typeface="Segoe UI Light" panose="020B0502040204020203" pitchFamily="34" charset="0"/>
+              </a:rPr>
+              <a:t>).</a:t>
+            </a:r>
+          </a:p>
+          <a:p>
+            <a:pPr marL="285750" indent="-285750">
+              <a:buFont typeface="Arial" panose="020B0604020202020204" pitchFamily="34" charset="0"/>
+              <a:buChar char="•"/>
+            </a:pPr>
+            <a:r>
+              <a:rPr lang="en-US" sz="1500" b="1" dirty="0">
+                <a:solidFill>
+                  <a:schemeClr val="accent1"/>
+                </a:solidFill>
+                <a:cs typeface="Segoe UI Light" panose="020B0502040204020203" pitchFamily="34" charset="0"/>
+              </a:rPr>
+              <a:t>Azure Container Registry (ACR)</a:t>
+            </a:r>
+            <a:r>
+              <a:rPr lang="en-US" sz="1500" dirty="0">
+                <a:solidFill>
+                  <a:schemeClr val="accent1"/>
+                </a:solidFill>
+                <a:cs typeface="Segoe UI Light" panose="020B0502040204020203" pitchFamily="34" charset="0"/>
+              </a:rPr>
+              <a:t> to host Docker images securely.</a:t>
+            </a:r>
+            <a:endParaRPr lang="fr-BE" sz="1500" dirty="0">
+              <a:solidFill>
+                <a:schemeClr val="accent1"/>
+              </a:solidFill>
+              <a:cs typeface="Segoe UI Light" panose="020B0502040204020203" pitchFamily="34" charset="0"/>
+            </a:endParaRPr>
+          </a:p>
+        </p:txBody>
+      </p:sp>
+      <p:sp>
+        <p:nvSpPr>
+          <p:cNvPr id="33" name="Line">
+            <a:extLst>
+              <a:ext uri="{FF2B5EF4-FFF2-40B4-BE49-F238E27FC236}">
+                <a16:creationId xmlns:a16="http://schemas.microsoft.com/office/drawing/2014/main" id="{2BB991C4-FB9F-7CF2-621C-1B81F2CC3D44}"/>
+              </a:ext>
+            </a:extLst>
+          </p:cNvPr>
+          <p:cNvSpPr/>
+          <p:nvPr/>
+        </p:nvSpPr>
+        <p:spPr>
+          <a:xfrm>
+            <a:off x="515938" y="4592513"/>
+            <a:ext cx="4873480" cy="0"/>
+          </a:xfrm>
+          <a:prstGeom prst="line">
+            <a:avLst/>
+          </a:prstGeom>
+          <a:noFill/>
+          <a:ln w="50800" cap="flat">
+            <a:solidFill>
+              <a:srgbClr val="00B050"/>
+            </a:solidFill>
+            <a:prstDash val="solid"/>
+            <a:miter lim="400000"/>
+          </a:ln>
+          <a:effectLst/>
+        </p:spPr>
+        <p:txBody>
+          <a:bodyPr wrap="square" lIns="0" tIns="0" rIns="0" bIns="0" numCol="1" anchor="ctr">
+            <a:noAutofit/>
+          </a:bodyPr>
+          <a:lstStyle>
+            <a:defPPr>
+              <a:defRPr lang="en-US"/>
+            </a:defPPr>
+            <a:lvl1pPr marL="0" algn="l" defTabSz="914400" rtl="0" eaLnBrk="1" latinLnBrk="0" hangingPunct="1">
+              <a:defRPr sz="1800" kern="1200">
+                <a:solidFill>
+                  <a:schemeClr val="tx1"/>
+                </a:solidFill>
+                <a:latin typeface="+mn-lt"/>
+                <a:ea typeface="+mn-ea"/>
+                <a:cs typeface="+mn-cs"/>
+              </a:defRPr>
+            </a:lvl1pPr>
+            <a:lvl2pPr marL="457200" algn="l" defTabSz="914400" rtl="0" eaLnBrk="1" latinLnBrk="0" hangingPunct="1">
+              <a:defRPr sz="1800" kern="1200">
+                <a:solidFill>
+                  <a:schemeClr val="tx1"/>
+                </a:solidFill>
+                <a:latin typeface="+mn-lt"/>
+                <a:ea typeface="+mn-ea"/>
+                <a:cs typeface="+mn-cs"/>
+              </a:defRPr>
+            </a:lvl2pPr>
+            <a:lvl3pPr marL="914400" algn="l" defTabSz="914400" rtl="0" eaLnBrk="1" latinLnBrk="0" hangingPunct="1">
+              <a:defRPr sz="1800" kern="1200">
+                <a:solidFill>
+                  <a:schemeClr val="tx1"/>
+                </a:solidFill>
+                <a:latin typeface="+mn-lt"/>
+                <a:ea typeface="+mn-ea"/>
+                <a:cs typeface="+mn-cs"/>
+              </a:defRPr>
+            </a:lvl3pPr>
+            <a:lvl4pPr marL="1371600" algn="l" defTabSz="914400" rtl="0" eaLnBrk="1" latinLnBrk="0" hangingPunct="1">
+              <a:defRPr sz="1800" kern="1200">
+                <a:solidFill>
+                  <a:schemeClr val="tx1"/>
+                </a:solidFill>
+                <a:latin typeface="+mn-lt"/>
+                <a:ea typeface="+mn-ea"/>
+                <a:cs typeface="+mn-cs"/>
+              </a:defRPr>
+            </a:lvl4pPr>
+            <a:lvl5pPr marL="1828800" algn="l" defTabSz="914400" rtl="0" eaLnBrk="1" latinLnBrk="0" hangingPunct="1">
+              <a:defRPr sz="1800" kern="1200">
+                <a:solidFill>
+                  <a:schemeClr val="tx1"/>
+                </a:solidFill>
+                <a:latin typeface="+mn-lt"/>
+                <a:ea typeface="+mn-ea"/>
+                <a:cs typeface="+mn-cs"/>
+              </a:defRPr>
+            </a:lvl5pPr>
+            <a:lvl6pPr marL="2286000" algn="l" defTabSz="914400" rtl="0" eaLnBrk="1" latinLnBrk="0" hangingPunct="1">
+              <a:defRPr sz="1800" kern="1200">
+                <a:solidFill>
+                  <a:schemeClr val="tx1"/>
+                </a:solidFill>
+                <a:latin typeface="+mn-lt"/>
+                <a:ea typeface="+mn-ea"/>
+                <a:cs typeface="+mn-cs"/>
+              </a:defRPr>
+            </a:lvl6pPr>
+            <a:lvl7pPr marL="2743200" algn="l" defTabSz="914400" rtl="0" eaLnBrk="1" latinLnBrk="0" hangingPunct="1">
+              <a:defRPr sz="1800" kern="1200">
+                <a:solidFill>
+                  <a:schemeClr val="tx1"/>
+                </a:solidFill>
+                <a:latin typeface="+mn-lt"/>
+                <a:ea typeface="+mn-ea"/>
+                <a:cs typeface="+mn-cs"/>
+              </a:defRPr>
+            </a:lvl7pPr>
+            <a:lvl8pPr marL="3200400" algn="l" defTabSz="914400" rtl="0" eaLnBrk="1" latinLnBrk="0" hangingPunct="1">
+              <a:defRPr sz="1800" kern="1200">
+                <a:solidFill>
+                  <a:schemeClr val="tx1"/>
+                </a:solidFill>
+                <a:latin typeface="+mn-lt"/>
+                <a:ea typeface="+mn-ea"/>
+                <a:cs typeface="+mn-cs"/>
+              </a:defRPr>
+            </a:lvl8pPr>
+            <a:lvl9pPr marL="3657600" algn="l" defTabSz="914400" rtl="0" eaLnBrk="1" latinLnBrk="0" hangingPunct="1">
+              <a:defRPr sz="1800" kern="1200">
+                <a:solidFill>
+                  <a:schemeClr val="tx1"/>
+                </a:solidFill>
+                <a:latin typeface="+mn-lt"/>
+                <a:ea typeface="+mn-ea"/>
+                <a:cs typeface="+mn-cs"/>
+              </a:defRPr>
+            </a:lvl9pPr>
+          </a:lstStyle>
+          <a:p>
+            <a:pPr marL="0" marR="0" lvl="0" indent="0" algn="ctr" defTabSz="410766" rtl="0" eaLnBrk="1" fontAlgn="auto" latinLnBrk="0" hangingPunct="0">
+              <a:lnSpc>
+                <a:spcPct val="100000"/>
+              </a:lnSpc>
+              <a:spcBef>
+                <a:spcPts val="0"/>
+              </a:spcBef>
+              <a:spcAft>
+                <a:spcPts val="0"/>
+              </a:spcAft>
+              <a:buClrTx/>
+              <a:buSzTx/>
+              <a:buFontTx/>
+              <a:buNone/>
+              <a:tabLst/>
+              <a:defRPr sz="3000" b="1">
+                <a:solidFill>
+                  <a:srgbClr val="FFFFFF"/>
+                </a:solidFill>
+              </a:defRPr>
+            </a:pPr>
+            <a:endParaRPr kumimoji="0" lang="en-US" sz="1200" b="1" i="0" u="none" strike="noStrike" kern="0" cap="none" spc="0" normalizeH="0" baseline="0" noProof="0" dirty="0">
+              <a:ln>
+                <a:noFill/>
+              </a:ln>
+              <a:solidFill>
+                <a:srgbClr val="44546A"/>
+              </a:solidFill>
+              <a:effectLst/>
+              <a:uLnTx/>
+              <a:uFillTx/>
+              <a:ea typeface="+mn-ea"/>
+              <a:cs typeface="Segoe UI"/>
+              <a:sym typeface="Segoe UI"/>
+            </a:endParaRPr>
+          </a:p>
+        </p:txBody>
+      </p:sp>
+      <p:sp>
+        <p:nvSpPr>
+          <p:cNvPr id="34" name="Rounded Rectangle">
+            <a:extLst>
+              <a:ext uri="{FF2B5EF4-FFF2-40B4-BE49-F238E27FC236}">
+                <a16:creationId xmlns:a16="http://schemas.microsoft.com/office/drawing/2014/main" id="{E5D190CC-A4BD-421A-6DDA-9769A729D13F}"/>
+              </a:ext>
+            </a:extLst>
+          </p:cNvPr>
+          <p:cNvSpPr/>
+          <p:nvPr/>
+        </p:nvSpPr>
+        <p:spPr>
+          <a:xfrm>
+            <a:off x="5551747" y="4038756"/>
+            <a:ext cx="6148762" cy="2304891"/>
+          </a:xfrm>
+          <a:prstGeom prst="roundRect">
+            <a:avLst>
+              <a:gd name="adj" fmla="val 3067"/>
+            </a:avLst>
+          </a:prstGeom>
+          <a:solidFill>
+            <a:schemeClr val="bg1">
+              <a:alpha val="87000"/>
+            </a:schemeClr>
+          </a:solidFill>
+          <a:ln w="12700" cap="flat">
+            <a:noFill/>
+            <a:miter lim="400000"/>
+          </a:ln>
+          <a:effectLst>
+            <a:outerShdw blurRad="952500" dist="444500" dir="5400000" rotWithShape="0">
+              <a:srgbClr val="000000">
+                <a:alpha val="15000"/>
+              </a:srgbClr>
+            </a:outerShdw>
+          </a:effectLst>
+        </p:spPr>
+        <p:txBody>
+          <a:bodyPr wrap="square" lIns="0" tIns="0" rIns="0" bIns="0" numCol="1" anchor="ctr">
+            <a:noAutofit/>
+          </a:bodyPr>
+          <a:lstStyle>
+            <a:defPPr>
+              <a:defRPr lang="en-US"/>
+            </a:defPPr>
+            <a:lvl1pPr marL="0" algn="l" defTabSz="914400" rtl="0" eaLnBrk="1" latinLnBrk="0" hangingPunct="1">
+              <a:defRPr sz="1800" kern="1200">
+                <a:solidFill>
+                  <a:schemeClr val="tx1"/>
+                </a:solidFill>
+                <a:latin typeface="+mn-lt"/>
+                <a:ea typeface="+mn-ea"/>
+                <a:cs typeface="+mn-cs"/>
+              </a:defRPr>
+            </a:lvl1pPr>
+            <a:lvl2pPr marL="457200" algn="l" defTabSz="914400" rtl="0" eaLnBrk="1" latinLnBrk="0" hangingPunct="1">
+              <a:defRPr sz="1800" kern="1200">
+                <a:solidFill>
+                  <a:schemeClr val="tx1"/>
+                </a:solidFill>
+                <a:latin typeface="+mn-lt"/>
+                <a:ea typeface="+mn-ea"/>
+                <a:cs typeface="+mn-cs"/>
+              </a:defRPr>
+            </a:lvl2pPr>
+            <a:lvl3pPr marL="914400" algn="l" defTabSz="914400" rtl="0" eaLnBrk="1" latinLnBrk="0" hangingPunct="1">
+              <a:defRPr sz="1800" kern="1200">
+                <a:solidFill>
+                  <a:schemeClr val="tx1"/>
+                </a:solidFill>
+                <a:latin typeface="+mn-lt"/>
+                <a:ea typeface="+mn-ea"/>
+                <a:cs typeface="+mn-cs"/>
+              </a:defRPr>
+            </a:lvl3pPr>
+            <a:lvl4pPr marL="1371600" algn="l" defTabSz="914400" rtl="0" eaLnBrk="1" latinLnBrk="0" hangingPunct="1">
+              <a:defRPr sz="1800" kern="1200">
+                <a:solidFill>
+                  <a:schemeClr val="tx1"/>
+                </a:solidFill>
+                <a:latin typeface="+mn-lt"/>
+                <a:ea typeface="+mn-ea"/>
+                <a:cs typeface="+mn-cs"/>
+              </a:defRPr>
+            </a:lvl4pPr>
+            <a:lvl5pPr marL="1828800" algn="l" defTabSz="914400" rtl="0" eaLnBrk="1" latinLnBrk="0" hangingPunct="1">
+              <a:defRPr sz="1800" kern="1200">
+                <a:solidFill>
+                  <a:schemeClr val="tx1"/>
+                </a:solidFill>
+                <a:latin typeface="+mn-lt"/>
+                <a:ea typeface="+mn-ea"/>
+                <a:cs typeface="+mn-cs"/>
+              </a:defRPr>
+            </a:lvl5pPr>
+            <a:lvl6pPr marL="2286000" algn="l" defTabSz="914400" rtl="0" eaLnBrk="1" latinLnBrk="0" hangingPunct="1">
+              <a:defRPr sz="1800" kern="1200">
+                <a:solidFill>
+                  <a:schemeClr val="tx1"/>
+                </a:solidFill>
+                <a:latin typeface="+mn-lt"/>
+                <a:ea typeface="+mn-ea"/>
+                <a:cs typeface="+mn-cs"/>
+              </a:defRPr>
+            </a:lvl6pPr>
+            <a:lvl7pPr marL="2743200" algn="l" defTabSz="914400" rtl="0" eaLnBrk="1" latinLnBrk="0" hangingPunct="1">
+              <a:defRPr sz="1800" kern="1200">
+                <a:solidFill>
+                  <a:schemeClr val="tx1"/>
+                </a:solidFill>
+                <a:latin typeface="+mn-lt"/>
+                <a:ea typeface="+mn-ea"/>
+                <a:cs typeface="+mn-cs"/>
+              </a:defRPr>
+            </a:lvl7pPr>
+            <a:lvl8pPr marL="3200400" algn="l" defTabSz="914400" rtl="0" eaLnBrk="1" latinLnBrk="0" hangingPunct="1">
+              <a:defRPr sz="1800" kern="1200">
+                <a:solidFill>
+                  <a:schemeClr val="tx1"/>
+                </a:solidFill>
+                <a:latin typeface="+mn-lt"/>
+                <a:ea typeface="+mn-ea"/>
+                <a:cs typeface="+mn-cs"/>
+              </a:defRPr>
+            </a:lvl8pPr>
+            <a:lvl9pPr marL="3657600" algn="l" defTabSz="914400" rtl="0" eaLnBrk="1" latinLnBrk="0" hangingPunct="1">
+              <a:defRPr sz="1800" kern="1200">
+                <a:solidFill>
+                  <a:schemeClr val="tx1"/>
+                </a:solidFill>
+                <a:latin typeface="+mn-lt"/>
+                <a:ea typeface="+mn-ea"/>
+                <a:cs typeface="+mn-cs"/>
+              </a:defRPr>
+            </a:lvl9pPr>
+          </a:lstStyle>
+          <a:p>
+            <a:pPr marL="0" marR="0" lvl="0" indent="0" algn="ctr" defTabSz="410766" rtl="0" eaLnBrk="1" fontAlgn="auto" latinLnBrk="0" hangingPunct="0">
+              <a:lnSpc>
+                <a:spcPct val="100000"/>
+              </a:lnSpc>
+              <a:spcBef>
+                <a:spcPts val="0"/>
+              </a:spcBef>
+              <a:spcAft>
+                <a:spcPts val="0"/>
+              </a:spcAft>
+              <a:buClrTx/>
+              <a:buSzTx/>
+              <a:buFontTx/>
+              <a:buNone/>
+              <a:tabLst/>
+              <a:defRPr sz="3000" b="1">
+                <a:solidFill>
+                  <a:srgbClr val="FFFFFF"/>
+                </a:solidFill>
+              </a:defRPr>
+            </a:pPr>
+            <a:endParaRPr kumimoji="0" sz="1500" b="1" i="0" u="none" strike="noStrike" kern="0" cap="none" spc="0" normalizeH="0" baseline="0" noProof="0" dirty="0">
+              <a:ln>
+                <a:noFill/>
+              </a:ln>
+              <a:solidFill>
+                <a:srgbClr val="44546A"/>
+              </a:solidFill>
+              <a:effectLst/>
+              <a:uLnTx/>
+              <a:uFillTx/>
+              <a:ea typeface="+mn-ea"/>
+              <a:cs typeface="Segoe UI"/>
+              <a:sym typeface="Segoe UI"/>
+            </a:endParaRPr>
+          </a:p>
+        </p:txBody>
+      </p:sp>
+      <p:sp>
+        <p:nvSpPr>
+          <p:cNvPr id="35" name="Mobilisation &amp; Inputs Gathering">
+            <a:extLst>
+              <a:ext uri="{FF2B5EF4-FFF2-40B4-BE49-F238E27FC236}">
+                <a16:creationId xmlns:a16="http://schemas.microsoft.com/office/drawing/2014/main" id="{E32C0D2A-A0A3-8120-4091-74719F91FB31}"/>
+              </a:ext>
+            </a:extLst>
+          </p:cNvPr>
+          <p:cNvSpPr txBox="1"/>
+          <p:nvPr/>
+        </p:nvSpPr>
+        <p:spPr>
+          <a:xfrm>
+            <a:off x="5551746" y="4169655"/>
+            <a:ext cx="6148761" cy="377910"/>
+          </a:xfrm>
+          <a:prstGeom prst="rect">
+            <a:avLst/>
+          </a:prstGeom>
+          <a:noFill/>
+          <a:ln w="12700" cap="flat">
+            <a:noFill/>
+            <a:miter lim="400000"/>
+          </a:ln>
+          <a:effectLst/>
+          <a:extLst>
+            <a:ext uri="{C572A759-6A51-4108-AA02-DFA0A04FC94B}">
+              <ma14:wrappingTextBoxFlag xmlns:lc="http://schemas.openxmlformats.org/drawingml/2006/lockedCanvas" xmlns:ma14="http://schemas.microsoft.com/office/mac/drawingml/2011/main" xmlns:a14="http://schemas.microsoft.com/office/drawing/2010/main" xmlns:m="http://schemas.openxmlformats.org/officeDocument/2006/math" xmlns="" val="1"/>
+            </a:ext>
+          </a:extLst>
+        </p:spPr>
+        <p:txBody>
+          <a:bodyPr wrap="square" lIns="35719" tIns="35719" rIns="35719" bIns="35719" numCol="1" anchor="t">
+            <a:noAutofit/>
+          </a:bodyPr>
+          <a:lstStyle>
+            <a:defPPr>
+              <a:defRPr lang="en-US"/>
+            </a:defPPr>
+            <a:lvl1pPr marL="0" algn="l" defTabSz="914400" rtl="0" eaLnBrk="1" latinLnBrk="0" hangingPunct="1">
+              <a:defRPr sz="1800" kern="1200">
+                <a:solidFill>
+                  <a:schemeClr val="tx1"/>
+                </a:solidFill>
+                <a:latin typeface="+mn-lt"/>
+                <a:ea typeface="+mn-ea"/>
+                <a:cs typeface="+mn-cs"/>
+              </a:defRPr>
+            </a:lvl1pPr>
+            <a:lvl2pPr marL="457200" algn="l" defTabSz="914400" rtl="0" eaLnBrk="1" latinLnBrk="0" hangingPunct="1">
+              <a:defRPr sz="1800" kern="1200">
+                <a:solidFill>
+                  <a:schemeClr val="tx1"/>
+                </a:solidFill>
+                <a:latin typeface="+mn-lt"/>
+                <a:ea typeface="+mn-ea"/>
+                <a:cs typeface="+mn-cs"/>
+              </a:defRPr>
+            </a:lvl2pPr>
+            <a:lvl3pPr marL="914400" algn="l" defTabSz="914400" rtl="0" eaLnBrk="1" latinLnBrk="0" hangingPunct="1">
+              <a:defRPr sz="1800" kern="1200">
+                <a:solidFill>
+                  <a:schemeClr val="tx1"/>
+                </a:solidFill>
+                <a:latin typeface="+mn-lt"/>
+                <a:ea typeface="+mn-ea"/>
+                <a:cs typeface="+mn-cs"/>
+              </a:defRPr>
+            </a:lvl3pPr>
+            <a:lvl4pPr marL="1371600" algn="l" defTabSz="914400" rtl="0" eaLnBrk="1" latinLnBrk="0" hangingPunct="1">
+              <a:defRPr sz="1800" kern="1200">
+                <a:solidFill>
+                  <a:schemeClr val="tx1"/>
+                </a:solidFill>
+                <a:latin typeface="+mn-lt"/>
+                <a:ea typeface="+mn-ea"/>
+                <a:cs typeface="+mn-cs"/>
+              </a:defRPr>
+            </a:lvl4pPr>
+            <a:lvl5pPr marL="1828800" algn="l" defTabSz="914400" rtl="0" eaLnBrk="1" latinLnBrk="0" hangingPunct="1">
+              <a:defRPr sz="1800" kern="1200">
+                <a:solidFill>
+                  <a:schemeClr val="tx1"/>
+                </a:solidFill>
+                <a:latin typeface="+mn-lt"/>
+                <a:ea typeface="+mn-ea"/>
+                <a:cs typeface="+mn-cs"/>
+              </a:defRPr>
+            </a:lvl5pPr>
+            <a:lvl6pPr marL="2286000" algn="l" defTabSz="914400" rtl="0" eaLnBrk="1" latinLnBrk="0" hangingPunct="1">
+              <a:defRPr sz="1800" kern="1200">
+                <a:solidFill>
+                  <a:schemeClr val="tx1"/>
+                </a:solidFill>
+                <a:latin typeface="+mn-lt"/>
+                <a:ea typeface="+mn-ea"/>
+                <a:cs typeface="+mn-cs"/>
+              </a:defRPr>
+            </a:lvl6pPr>
+            <a:lvl7pPr marL="2743200" algn="l" defTabSz="914400" rtl="0" eaLnBrk="1" latinLnBrk="0" hangingPunct="1">
+              <a:defRPr sz="1800" kern="1200">
+                <a:solidFill>
+                  <a:schemeClr val="tx1"/>
+                </a:solidFill>
+                <a:latin typeface="+mn-lt"/>
+                <a:ea typeface="+mn-ea"/>
+                <a:cs typeface="+mn-cs"/>
+              </a:defRPr>
+            </a:lvl7pPr>
+            <a:lvl8pPr marL="3200400" algn="l" defTabSz="914400" rtl="0" eaLnBrk="1" latinLnBrk="0" hangingPunct="1">
+              <a:defRPr sz="1800" kern="1200">
+                <a:solidFill>
+                  <a:schemeClr val="tx1"/>
+                </a:solidFill>
+                <a:latin typeface="+mn-lt"/>
+                <a:ea typeface="+mn-ea"/>
+                <a:cs typeface="+mn-cs"/>
+              </a:defRPr>
+            </a:lvl8pPr>
+            <a:lvl9pPr marL="3657600" algn="l" defTabSz="914400" rtl="0" eaLnBrk="1" latinLnBrk="0" hangingPunct="1">
+              <a:defRPr sz="1800" kern="1200">
+                <a:solidFill>
+                  <a:schemeClr val="tx1"/>
+                </a:solidFill>
+                <a:latin typeface="+mn-lt"/>
+                <a:ea typeface="+mn-ea"/>
+                <a:cs typeface="+mn-cs"/>
+              </a:defRPr>
+            </a:lvl9pPr>
+          </a:lstStyle>
+          <a:p>
+            <a:pPr algn="ctr" defTabSz="533400">
+              <a:lnSpc>
+                <a:spcPct val="90000"/>
+              </a:lnSpc>
+              <a:spcBef>
+                <a:spcPct val="0"/>
+              </a:spcBef>
+              <a:spcAft>
+                <a:spcPct val="35000"/>
+              </a:spcAft>
+            </a:pPr>
+            <a:r>
+              <a:rPr lang="en-US" b="1" noProof="0" dirty="0">
+                <a:solidFill>
+                  <a:srgbClr val="44546A"/>
+                </a:solidFill>
+                <a:cs typeface="Segoe UI Light" panose="020B0502040204020203" pitchFamily="34" charset="0"/>
+              </a:rPr>
+              <a:t>Deployment on Azure (benefits over Render)</a:t>
+            </a:r>
+          </a:p>
+        </p:txBody>
+      </p:sp>
+      <p:sp>
+        <p:nvSpPr>
+          <p:cNvPr id="36" name="Mobilisation &amp; Inputs Gathering">
+            <a:extLst>
+              <a:ext uri="{FF2B5EF4-FFF2-40B4-BE49-F238E27FC236}">
+                <a16:creationId xmlns:a16="http://schemas.microsoft.com/office/drawing/2014/main" id="{4F1B77C4-4035-1835-120F-218AF686A3FE}"/>
+              </a:ext>
+            </a:extLst>
+          </p:cNvPr>
+          <p:cNvSpPr txBox="1"/>
+          <p:nvPr/>
+        </p:nvSpPr>
+        <p:spPr>
+          <a:xfrm>
+            <a:off x="5735782" y="4717226"/>
+            <a:ext cx="5964725" cy="1141621"/>
+          </a:xfrm>
+          <a:prstGeom prst="rect">
+            <a:avLst/>
+          </a:prstGeom>
+          <a:noFill/>
+          <a:ln w="12700" cap="flat">
+            <a:noFill/>
+            <a:miter lim="400000"/>
+          </a:ln>
+          <a:effectLst/>
+          <a:extLst>
+            <a:ext uri="{C572A759-6A51-4108-AA02-DFA0A04FC94B}">
+              <ma14:wrappingTextBoxFlag xmlns:lc="http://schemas.openxmlformats.org/drawingml/2006/lockedCanvas" xmlns:ma14="http://schemas.microsoft.com/office/mac/drawingml/2011/main" xmlns:a14="http://schemas.microsoft.com/office/drawing/2010/main" xmlns:m="http://schemas.openxmlformats.org/officeDocument/2006/math" xmlns="" val="1"/>
+            </a:ext>
+          </a:extLst>
+        </p:spPr>
+        <p:txBody>
+          <a:bodyPr wrap="square" lIns="35719" tIns="35719" rIns="35719" bIns="35719" numCol="1" anchor="t">
+            <a:noAutofit/>
+          </a:bodyPr>
+          <a:lstStyle>
+            <a:defPPr>
+              <a:defRPr lang="en-US"/>
+            </a:defPPr>
+            <a:lvl1pPr marL="0" algn="l" defTabSz="914400" rtl="0" eaLnBrk="1" latinLnBrk="0" hangingPunct="1">
+              <a:defRPr sz="1800" kern="1200">
+                <a:solidFill>
+                  <a:schemeClr val="tx1"/>
+                </a:solidFill>
+                <a:latin typeface="+mn-lt"/>
+                <a:ea typeface="+mn-ea"/>
+                <a:cs typeface="+mn-cs"/>
+              </a:defRPr>
+            </a:lvl1pPr>
+            <a:lvl2pPr marL="457200" algn="l" defTabSz="914400" rtl="0" eaLnBrk="1" latinLnBrk="0" hangingPunct="1">
+              <a:defRPr sz="1800" kern="1200">
+                <a:solidFill>
+                  <a:schemeClr val="tx1"/>
+                </a:solidFill>
+                <a:latin typeface="+mn-lt"/>
+                <a:ea typeface="+mn-ea"/>
+                <a:cs typeface="+mn-cs"/>
+              </a:defRPr>
+            </a:lvl2pPr>
+            <a:lvl3pPr marL="914400" algn="l" defTabSz="914400" rtl="0" eaLnBrk="1" latinLnBrk="0" hangingPunct="1">
+              <a:defRPr sz="1800" kern="1200">
+                <a:solidFill>
+                  <a:schemeClr val="tx1"/>
+                </a:solidFill>
+                <a:latin typeface="+mn-lt"/>
+                <a:ea typeface="+mn-ea"/>
+                <a:cs typeface="+mn-cs"/>
+              </a:defRPr>
+            </a:lvl3pPr>
+            <a:lvl4pPr marL="1371600" algn="l" defTabSz="914400" rtl="0" eaLnBrk="1" latinLnBrk="0" hangingPunct="1">
+              <a:defRPr sz="1800" kern="1200">
+                <a:solidFill>
+                  <a:schemeClr val="tx1"/>
+                </a:solidFill>
+                <a:latin typeface="+mn-lt"/>
+                <a:ea typeface="+mn-ea"/>
+                <a:cs typeface="+mn-cs"/>
+              </a:defRPr>
+            </a:lvl4pPr>
+            <a:lvl5pPr marL="1828800" algn="l" defTabSz="914400" rtl="0" eaLnBrk="1" latinLnBrk="0" hangingPunct="1">
+              <a:defRPr sz="1800" kern="1200">
+                <a:solidFill>
+                  <a:schemeClr val="tx1"/>
+                </a:solidFill>
+                <a:latin typeface="+mn-lt"/>
+                <a:ea typeface="+mn-ea"/>
+                <a:cs typeface="+mn-cs"/>
+              </a:defRPr>
+            </a:lvl5pPr>
+            <a:lvl6pPr marL="2286000" algn="l" defTabSz="914400" rtl="0" eaLnBrk="1" latinLnBrk="0" hangingPunct="1">
+              <a:defRPr sz="1800" kern="1200">
+                <a:solidFill>
+                  <a:schemeClr val="tx1"/>
+                </a:solidFill>
+                <a:latin typeface="+mn-lt"/>
+                <a:ea typeface="+mn-ea"/>
+                <a:cs typeface="+mn-cs"/>
+              </a:defRPr>
+            </a:lvl6pPr>
+            <a:lvl7pPr marL="2743200" algn="l" defTabSz="914400" rtl="0" eaLnBrk="1" latinLnBrk="0" hangingPunct="1">
+              <a:defRPr sz="1800" kern="1200">
+                <a:solidFill>
+                  <a:schemeClr val="tx1"/>
+                </a:solidFill>
+                <a:latin typeface="+mn-lt"/>
+                <a:ea typeface="+mn-ea"/>
+                <a:cs typeface="+mn-cs"/>
+              </a:defRPr>
+            </a:lvl7pPr>
+            <a:lvl8pPr marL="3200400" algn="l" defTabSz="914400" rtl="0" eaLnBrk="1" latinLnBrk="0" hangingPunct="1">
+              <a:defRPr sz="1800" kern="1200">
+                <a:solidFill>
+                  <a:schemeClr val="tx1"/>
+                </a:solidFill>
+                <a:latin typeface="+mn-lt"/>
+                <a:ea typeface="+mn-ea"/>
+                <a:cs typeface="+mn-cs"/>
+              </a:defRPr>
+            </a:lvl8pPr>
+            <a:lvl9pPr marL="3657600" algn="l" defTabSz="914400" rtl="0" eaLnBrk="1" latinLnBrk="0" hangingPunct="1">
+              <a:defRPr sz="1800" kern="1200">
+                <a:solidFill>
+                  <a:schemeClr val="tx1"/>
+                </a:solidFill>
+                <a:latin typeface="+mn-lt"/>
+                <a:ea typeface="+mn-ea"/>
+                <a:cs typeface="+mn-cs"/>
+              </a:defRPr>
+            </a:lvl9pPr>
+          </a:lstStyle>
+          <a:p>
+            <a:pPr marL="285750" indent="-285750">
+              <a:buFont typeface="Arial" panose="020B0604020202020204" pitchFamily="34" charset="0"/>
+              <a:buChar char="•"/>
+            </a:pPr>
+            <a:r>
+              <a:rPr lang="en-US" sz="1500" dirty="0">
+                <a:solidFill>
+                  <a:schemeClr val="accent1"/>
+                </a:solidFill>
+                <a:cs typeface="Segoe UI Light" panose="020B0502040204020203" pitchFamily="34" charset="0"/>
+              </a:rPr>
+              <a:t>Better control over </a:t>
+            </a:r>
+            <a:r>
+              <a:rPr lang="en-US" sz="1500" b="1" dirty="0">
+                <a:solidFill>
+                  <a:schemeClr val="accent1"/>
+                </a:solidFill>
+                <a:cs typeface="Segoe UI Light" panose="020B0502040204020203" pitchFamily="34" charset="0"/>
+              </a:rPr>
+              <a:t>environment variables</a:t>
+            </a:r>
+            <a:r>
+              <a:rPr lang="en-US" sz="1500" dirty="0">
+                <a:solidFill>
+                  <a:schemeClr val="accent1"/>
+                </a:solidFill>
+                <a:cs typeface="Segoe UI Light" panose="020B0502040204020203" pitchFamily="34" charset="0"/>
+              </a:rPr>
+              <a:t>, </a:t>
+            </a:r>
+            <a:r>
+              <a:rPr lang="en-US" sz="1500" b="1" dirty="0">
+                <a:solidFill>
+                  <a:schemeClr val="accent1"/>
+                </a:solidFill>
+                <a:cs typeface="Segoe UI Light" panose="020B0502040204020203" pitchFamily="34" charset="0"/>
+              </a:rPr>
+              <a:t>logs</a:t>
+            </a:r>
+            <a:r>
+              <a:rPr lang="en-US" sz="1500" dirty="0">
+                <a:solidFill>
+                  <a:schemeClr val="accent1"/>
+                </a:solidFill>
+                <a:cs typeface="Segoe UI Light" panose="020B0502040204020203" pitchFamily="34" charset="0"/>
+              </a:rPr>
+              <a:t>, and </a:t>
+            </a:r>
+            <a:r>
+              <a:rPr lang="en-US" sz="1500" b="1" dirty="0">
+                <a:solidFill>
+                  <a:schemeClr val="accent1"/>
+                </a:solidFill>
+                <a:cs typeface="Segoe UI Light" panose="020B0502040204020203" pitchFamily="34" charset="0"/>
+              </a:rPr>
+              <a:t>startup behavior</a:t>
+            </a:r>
+            <a:r>
+              <a:rPr lang="en-US" sz="1500" dirty="0">
+                <a:solidFill>
+                  <a:schemeClr val="accent1"/>
+                </a:solidFill>
+                <a:cs typeface="Segoe UI Light" panose="020B0502040204020203" pitchFamily="34" charset="0"/>
+              </a:rPr>
+              <a:t>.</a:t>
+            </a:r>
+          </a:p>
+          <a:p>
+            <a:pPr marL="285750" indent="-285750">
+              <a:buFont typeface="Arial" panose="020B0604020202020204" pitchFamily="34" charset="0"/>
+              <a:buChar char="•"/>
+            </a:pPr>
+            <a:endParaRPr lang="en-US" sz="1500" dirty="0">
+              <a:solidFill>
+                <a:schemeClr val="accent1"/>
+              </a:solidFill>
+              <a:cs typeface="Segoe UI Light" panose="020B0502040204020203" pitchFamily="34" charset="0"/>
+            </a:endParaRPr>
+          </a:p>
+          <a:p>
+            <a:pPr marL="285750" indent="-285750">
+              <a:buFont typeface="Arial" panose="020B0604020202020204" pitchFamily="34" charset="0"/>
+              <a:buChar char="•"/>
+            </a:pPr>
+            <a:r>
+              <a:rPr lang="en-US" sz="1500" b="1" dirty="0">
+                <a:solidFill>
+                  <a:schemeClr val="accent1"/>
+                </a:solidFill>
+                <a:cs typeface="Segoe UI Light" panose="020B0502040204020203" pitchFamily="34" charset="0"/>
+              </a:rPr>
+              <a:t>Built-in monitoring </a:t>
+            </a:r>
+            <a:r>
+              <a:rPr lang="en-US" sz="1500" dirty="0">
+                <a:solidFill>
+                  <a:schemeClr val="accent1"/>
+                </a:solidFill>
+                <a:cs typeface="Segoe UI Light" panose="020B0502040204020203" pitchFamily="34" charset="0"/>
+              </a:rPr>
+              <a:t>via Azure Monitor and Application Insights.</a:t>
+            </a:r>
+          </a:p>
+          <a:p>
+            <a:pPr marL="285750" indent="-285750">
+              <a:buFont typeface="Arial" panose="020B0604020202020204" pitchFamily="34" charset="0"/>
+              <a:buChar char="•"/>
+            </a:pPr>
+            <a:endParaRPr lang="en-US" sz="1500" dirty="0">
+              <a:solidFill>
+                <a:schemeClr val="accent1"/>
+              </a:solidFill>
+              <a:cs typeface="Segoe UI Light" panose="020B0502040204020203" pitchFamily="34" charset="0"/>
+            </a:endParaRPr>
+          </a:p>
+          <a:p>
+            <a:pPr marL="285750" indent="-285750">
+              <a:buFont typeface="Arial" panose="020B0604020202020204" pitchFamily="34" charset="0"/>
+              <a:buChar char="•"/>
+            </a:pPr>
+            <a:r>
+              <a:rPr lang="en-US" sz="1500" dirty="0">
+                <a:solidFill>
+                  <a:schemeClr val="accent1"/>
+                </a:solidFill>
+                <a:cs typeface="Segoe UI Light" panose="020B0502040204020203" pitchFamily="34" charset="0"/>
+              </a:rPr>
+              <a:t>Stable and scalable infrastructure, with support for production-grade workloads.</a:t>
+            </a:r>
+            <a:endParaRPr lang="fr-BE" sz="1500" dirty="0">
+              <a:solidFill>
+                <a:schemeClr val="accent1"/>
+              </a:solidFill>
+              <a:cs typeface="Segoe UI Light" panose="020B0502040204020203" pitchFamily="34" charset="0"/>
+            </a:endParaRPr>
+          </a:p>
+        </p:txBody>
+      </p:sp>
+      <p:sp>
+        <p:nvSpPr>
+          <p:cNvPr id="37" name="Line">
+            <a:extLst>
+              <a:ext uri="{FF2B5EF4-FFF2-40B4-BE49-F238E27FC236}">
+                <a16:creationId xmlns:a16="http://schemas.microsoft.com/office/drawing/2014/main" id="{305CAE86-B878-7893-0EC4-64745DDF5C62}"/>
+              </a:ext>
+            </a:extLst>
+          </p:cNvPr>
+          <p:cNvSpPr/>
+          <p:nvPr/>
+        </p:nvSpPr>
+        <p:spPr>
+          <a:xfrm>
+            <a:off x="5551747" y="4606676"/>
+            <a:ext cx="6148762" cy="0"/>
+          </a:xfrm>
+          <a:prstGeom prst="line">
+            <a:avLst/>
+          </a:prstGeom>
+          <a:noFill/>
+          <a:ln w="50800" cap="flat">
+            <a:solidFill>
+              <a:srgbClr val="00B0F0"/>
+            </a:solidFill>
+            <a:prstDash val="solid"/>
+            <a:miter lim="400000"/>
+          </a:ln>
+          <a:effectLst/>
+        </p:spPr>
+        <p:txBody>
+          <a:bodyPr wrap="square" lIns="0" tIns="0" rIns="0" bIns="0" numCol="1" anchor="ctr">
+            <a:noAutofit/>
+          </a:bodyPr>
+          <a:lstStyle>
+            <a:defPPr>
+              <a:defRPr lang="en-US"/>
+            </a:defPPr>
+            <a:lvl1pPr marL="0" algn="l" defTabSz="914400" rtl="0" eaLnBrk="1" latinLnBrk="0" hangingPunct="1">
+              <a:defRPr sz="1800" kern="1200">
+                <a:solidFill>
+                  <a:schemeClr val="tx1"/>
+                </a:solidFill>
+                <a:latin typeface="+mn-lt"/>
+                <a:ea typeface="+mn-ea"/>
+                <a:cs typeface="+mn-cs"/>
+              </a:defRPr>
+            </a:lvl1pPr>
+            <a:lvl2pPr marL="457200" algn="l" defTabSz="914400" rtl="0" eaLnBrk="1" latinLnBrk="0" hangingPunct="1">
+              <a:defRPr sz="1800" kern="1200">
+                <a:solidFill>
+                  <a:schemeClr val="tx1"/>
+                </a:solidFill>
+                <a:latin typeface="+mn-lt"/>
+                <a:ea typeface="+mn-ea"/>
+                <a:cs typeface="+mn-cs"/>
+              </a:defRPr>
+            </a:lvl2pPr>
+            <a:lvl3pPr marL="914400" algn="l" defTabSz="914400" rtl="0" eaLnBrk="1" latinLnBrk="0" hangingPunct="1">
+              <a:defRPr sz="1800" kern="1200">
+                <a:solidFill>
+                  <a:schemeClr val="tx1"/>
+                </a:solidFill>
+                <a:latin typeface="+mn-lt"/>
+                <a:ea typeface="+mn-ea"/>
+                <a:cs typeface="+mn-cs"/>
+              </a:defRPr>
+            </a:lvl3pPr>
+            <a:lvl4pPr marL="1371600" algn="l" defTabSz="914400" rtl="0" eaLnBrk="1" latinLnBrk="0" hangingPunct="1">
+              <a:defRPr sz="1800" kern="1200">
+                <a:solidFill>
+                  <a:schemeClr val="tx1"/>
+                </a:solidFill>
+                <a:latin typeface="+mn-lt"/>
+                <a:ea typeface="+mn-ea"/>
+                <a:cs typeface="+mn-cs"/>
+              </a:defRPr>
+            </a:lvl4pPr>
+            <a:lvl5pPr marL="1828800" algn="l" defTabSz="914400" rtl="0" eaLnBrk="1" latinLnBrk="0" hangingPunct="1">
+              <a:defRPr sz="1800" kern="1200">
+                <a:solidFill>
+                  <a:schemeClr val="tx1"/>
+                </a:solidFill>
+                <a:latin typeface="+mn-lt"/>
+                <a:ea typeface="+mn-ea"/>
+                <a:cs typeface="+mn-cs"/>
+              </a:defRPr>
+            </a:lvl5pPr>
+            <a:lvl6pPr marL="2286000" algn="l" defTabSz="914400" rtl="0" eaLnBrk="1" latinLnBrk="0" hangingPunct="1">
+              <a:defRPr sz="1800" kern="1200">
+                <a:solidFill>
+                  <a:schemeClr val="tx1"/>
+                </a:solidFill>
+                <a:latin typeface="+mn-lt"/>
+                <a:ea typeface="+mn-ea"/>
+                <a:cs typeface="+mn-cs"/>
+              </a:defRPr>
+            </a:lvl6pPr>
+            <a:lvl7pPr marL="2743200" algn="l" defTabSz="914400" rtl="0" eaLnBrk="1" latinLnBrk="0" hangingPunct="1">
+              <a:defRPr sz="1800" kern="1200">
+                <a:solidFill>
+                  <a:schemeClr val="tx1"/>
+                </a:solidFill>
+                <a:latin typeface="+mn-lt"/>
+                <a:ea typeface="+mn-ea"/>
+                <a:cs typeface="+mn-cs"/>
+              </a:defRPr>
+            </a:lvl7pPr>
+            <a:lvl8pPr marL="3200400" algn="l" defTabSz="914400" rtl="0" eaLnBrk="1" latinLnBrk="0" hangingPunct="1">
+              <a:defRPr sz="1800" kern="1200">
+                <a:solidFill>
+                  <a:schemeClr val="tx1"/>
+                </a:solidFill>
+                <a:latin typeface="+mn-lt"/>
+                <a:ea typeface="+mn-ea"/>
+                <a:cs typeface="+mn-cs"/>
+              </a:defRPr>
+            </a:lvl8pPr>
+            <a:lvl9pPr marL="3657600" algn="l" defTabSz="914400" rtl="0" eaLnBrk="1" latinLnBrk="0" hangingPunct="1">
+              <a:defRPr sz="1800" kern="1200">
+                <a:solidFill>
+                  <a:schemeClr val="tx1"/>
+                </a:solidFill>
+                <a:latin typeface="+mn-lt"/>
+                <a:ea typeface="+mn-ea"/>
+                <a:cs typeface="+mn-cs"/>
+              </a:defRPr>
+            </a:lvl9pPr>
+          </a:lstStyle>
+          <a:p>
+            <a:pPr marL="0" marR="0" lvl="0" indent="0" algn="ctr" defTabSz="410766" rtl="0" eaLnBrk="1" fontAlgn="auto" latinLnBrk="0" hangingPunct="0">
+              <a:lnSpc>
+                <a:spcPct val="100000"/>
+              </a:lnSpc>
+              <a:spcBef>
+                <a:spcPts val="0"/>
+              </a:spcBef>
+              <a:spcAft>
+                <a:spcPts val="0"/>
+              </a:spcAft>
+              <a:buClrTx/>
+              <a:buSzTx/>
+              <a:buFontTx/>
+              <a:buNone/>
+              <a:tabLst/>
+              <a:defRPr sz="3000" b="1">
+                <a:solidFill>
+                  <a:srgbClr val="FFFFFF"/>
+                </a:solidFill>
+              </a:defRPr>
+            </a:pPr>
+            <a:endParaRPr kumimoji="0" lang="en-US" sz="1200" b="1" i="0" u="none" strike="noStrike" kern="0" cap="none" spc="0" normalizeH="0" baseline="0" noProof="0" dirty="0">
+              <a:ln>
+                <a:noFill/>
+              </a:ln>
+              <a:solidFill>
+                <a:srgbClr val="44546A"/>
+              </a:solidFill>
+              <a:effectLst/>
+              <a:uLnTx/>
+              <a:uFillTx/>
+              <a:ea typeface="+mn-ea"/>
+              <a:cs typeface="Segoe UI"/>
+              <a:sym typeface="Segoe UI"/>
+            </a:endParaRPr>
+          </a:p>
+        </p:txBody>
+      </p:sp>
+    </p:spTree>
+    <p:extLst>
+      <p:ext uri="{BB962C8B-B14F-4D97-AF65-F5344CB8AC3E}">
+        <p14:creationId xmlns:p14="http://schemas.microsoft.com/office/powerpoint/2010/main" val="2741167990"/>
       </p:ext>
     </p:extLst>
   </p:cSld>
@@ -22442,6 +25951,23 @@
 </file>
 
 <file path=customXml/item1.xml><?xml version="1.0" encoding="utf-8"?>
+<p:properties xmlns:p="http://schemas.microsoft.com/office/2006/metadata/properties" xmlns:xsi="http://www.w3.org/2001/XMLSchema-instance" xmlns:pc="http://schemas.microsoft.com/office/infopath/2007/PartnerControls">
+  <documentManagement>
+    <MediaServiceKeyPoints xmlns="71af3243-3dd4-4a8d-8c0d-dd76da1f02a5" xsi:nil="true"/>
+  </documentManagement>
+</p:properties>
+</file>
+
+<file path=customXml/item2.xml><?xml version="1.0" encoding="utf-8"?>
+<?mso-contentType ?>
+<FormTemplates xmlns="http://schemas.microsoft.com/sharepoint/v3/contenttype/forms">
+  <Display>DocumentLibraryForm</Display>
+  <Edit>DocumentLibraryForm</Edit>
+  <New>DocumentLibraryForm</New>
+</FormTemplates>
+</file>
+
+<file path=customXml/item3.xml><?xml version="1.0" encoding="utf-8"?>
 <ct:contentTypeSchema xmlns:ct="http://schemas.microsoft.com/office/2006/metadata/contentType" xmlns:ma="http://schemas.microsoft.com/office/2006/metadata/properties/metaAttributes" ct:_="" ma:_="" ma:contentTypeName="Document" ma:contentTypeID="0x01010079F111ED35F8CC479449609E8A0923A6" ma:contentTypeVersion="10" ma:contentTypeDescription="Create a new document." ma:contentTypeScope="" ma:versionID="e39e7e9e36de66d473ce04bb4ab2dbb8">
   <xsd:schema xmlns:xsd="http://www.w3.org/2001/XMLSchema" xmlns:xs="http://www.w3.org/2001/XMLSchema" xmlns:p="http://schemas.microsoft.com/office/2006/metadata/properties" xmlns:ns2="71af3243-3dd4-4a8d-8c0d-dd76da1f02a5" xmlns:ns3="16c05727-aa75-4e4a-9b5f-8a80a1165891" targetNamespace="http://schemas.microsoft.com/office/2006/metadata/properties" ma:root="true" ma:fieldsID="19dc5994665da46609c24125788630d8" ns2:_="" ns3:_="">
     <xsd:import namespace="71af3243-3dd4-4a8d-8c0d-dd76da1f02a5"/>
@@ -22646,24 +26172,25 @@
 </ct:contentTypeSchema>
 </file>
 
-<file path=customXml/item2.xml><?xml version="1.0" encoding="utf-8"?>
-<?mso-contentType ?>
-<FormTemplates xmlns="http://schemas.microsoft.com/sharepoint/v3/contenttype/forms">
-  <Display>DocumentLibraryForm</Display>
-  <Edit>DocumentLibraryForm</Edit>
-  <New>DocumentLibraryForm</New>
-</FormTemplates>
+<file path=customXml/itemProps1.xml><?xml version="1.0" encoding="utf-8"?>
+<ds:datastoreItem xmlns:ds="http://schemas.openxmlformats.org/officeDocument/2006/customXml" ds:itemID="{2519797F-2510-4681-A59B-FCD8F3733FE0}">
+  <ds:schemaRefs>
+    <ds:schemaRef ds:uri="http://schemas.microsoft.com/office/2006/metadata/properties"/>
+    <ds:schemaRef ds:uri="http://schemas.microsoft.com/office/infopath/2007/PartnerControls"/>
+    <ds:schemaRef ds:uri="71af3243-3dd4-4a8d-8c0d-dd76da1f02a5"/>
+  </ds:schemaRefs>
+</ds:datastoreItem>
 </file>
 
-<file path=customXml/item3.xml><?xml version="1.0" encoding="utf-8"?>
-<p:properties xmlns:p="http://schemas.microsoft.com/office/2006/metadata/properties" xmlns:xsi="http://www.w3.org/2001/XMLSchema-instance" xmlns:pc="http://schemas.microsoft.com/office/infopath/2007/PartnerControls">
-  <documentManagement>
-    <MediaServiceKeyPoints xmlns="71af3243-3dd4-4a8d-8c0d-dd76da1f02a5" xsi:nil="true"/>
-  </documentManagement>
-</p:properties>
+<file path=customXml/itemProps2.xml><?xml version="1.0" encoding="utf-8"?>
+<ds:datastoreItem xmlns:ds="http://schemas.openxmlformats.org/officeDocument/2006/customXml" ds:itemID="{A4C31332-3081-4BD9-AD6F-078B4521F357}">
+  <ds:schemaRefs>
+    <ds:schemaRef ds:uri="http://schemas.microsoft.com/sharepoint/v3/contenttype/forms"/>
+  </ds:schemaRefs>
+</ds:datastoreItem>
 </file>
 
-<file path=customXml/itemProps1.xml><?xml version="1.0" encoding="utf-8"?>
+<file path=customXml/itemProps3.xml><?xml version="1.0" encoding="utf-8"?>
 <ds:datastoreItem xmlns:ds="http://schemas.openxmlformats.org/officeDocument/2006/customXml" ds:itemID="{1FF4E1AF-DB5E-4764-961C-6F82B33E9E6E}">
   <ds:schemaRefs>
     <ds:schemaRef ds:uri="http://schemas.microsoft.com/office/2006/metadata/contentType"/>
@@ -22680,22 +26207,4 @@
     <ds:schemaRef ds:uri="http://schemas.microsoft.com/internal/obd"/>
   </ds:schemaRefs>
 </ds:datastoreItem>
-</file>
-
-<file path=customXml/itemProps2.xml><?xml version="1.0" encoding="utf-8"?>
-<ds:datastoreItem xmlns:ds="http://schemas.openxmlformats.org/officeDocument/2006/customXml" ds:itemID="{A4C31332-3081-4BD9-AD6F-078B4521F357}">
-  <ds:schemaRefs>
-    <ds:schemaRef ds:uri="http://schemas.microsoft.com/sharepoint/v3/contenttype/forms"/>
-  </ds:schemaRefs>
-</ds:datastoreItem>
-</file>
-
-<file path=customXml/itemProps3.xml><?xml version="1.0" encoding="utf-8"?>
-<ds:datastoreItem xmlns:ds="http://schemas.openxmlformats.org/officeDocument/2006/customXml" ds:itemID="{2519797F-2510-4681-A59B-FCD8F3733FE0}">
-  <ds:schemaRefs>
-    <ds:schemaRef ds:uri="http://schemas.microsoft.com/office/2006/metadata/properties"/>
-    <ds:schemaRef ds:uri="http://schemas.microsoft.com/office/infopath/2007/PartnerControls"/>
-    <ds:schemaRef ds:uri="71af3243-3dd4-4a8d-8c0d-dd76da1f02a5"/>
-  </ds:schemaRefs>
-</ds:datastoreItem>
 </file>
</xml_diff>

<commit_message>
front end agent react
</commit_message>
<xml_diff>
--- a/deck/03. Immobweb - Deployment.pptx
+++ b/deck/03. Immobweb - Deployment.pptx
@@ -13,8 +13,8 @@
   <p:sldIdLst>
     <p:sldId id="257" r:id="rId5"/>
     <p:sldId id="413" r:id="rId6"/>
-    <p:sldId id="415" r:id="rId7"/>
-    <p:sldId id="411" r:id="rId8"/>
+    <p:sldId id="411" r:id="rId7"/>
+    <p:sldId id="415" r:id="rId8"/>
     <p:sldId id="408" r:id="rId9"/>
     <p:sldId id="409" r:id="rId10"/>
     <p:sldId id="412" r:id="rId11"/>
@@ -1166,7 +1166,7 @@
             <a:pPr rtl="0"/>
             <a:fld id="{6336304E-FDE3-4B4F-A3B7-EBE87F3FA5E2}" type="slidenum">
               <a:rPr lang="fr-FR" noProof="0" smtClean="0"/>
-              <a:t>3</a:t>
+              <a:t>4</a:t>
             </a:fld>
             <a:endParaRPr lang="fr-FR" noProof="0" dirty="0"/>
           </a:p>
@@ -15860,7 +15860,7 @@
           <a:effectLst/>
           <a:extLst>
             <a:ext uri="{C572A759-6A51-4108-AA02-DFA0A04FC94B}">
-              <ma14:wrappingTextBoxFlag xmlns="" xmlns:m="http://schemas.openxmlformats.org/officeDocument/2006/math" xmlns:a14="http://schemas.microsoft.com/office/drawing/2010/main" xmlns:ma14="http://schemas.microsoft.com/office/mac/drawingml/2011/main" xmlns:lc="http://schemas.openxmlformats.org/drawingml/2006/lockedCanvas" val="1"/>
+              <ma14:wrappingTextBoxFlag xmlns:lc="http://schemas.openxmlformats.org/drawingml/2006/lockedCanvas" xmlns:ma14="http://schemas.microsoft.com/office/mac/drawingml/2011/main" xmlns:a14="http://schemas.microsoft.com/office/drawing/2010/main" xmlns:m="http://schemas.openxmlformats.org/officeDocument/2006/math" xmlns="" val="1"/>
             </a:ext>
           </a:extLst>
         </p:spPr>
@@ -16015,7 +16015,7 @@
           <a:effectLst/>
           <a:extLst>
             <a:ext uri="{C572A759-6A51-4108-AA02-DFA0A04FC94B}">
-              <ma14:wrappingTextBoxFlag xmlns="" xmlns:m="http://schemas.openxmlformats.org/officeDocument/2006/math" xmlns:a14="http://schemas.microsoft.com/office/drawing/2010/main" xmlns:ma14="http://schemas.microsoft.com/office/mac/drawingml/2011/main" xmlns:lc="http://schemas.openxmlformats.org/drawingml/2006/lockedCanvas" val="1"/>
+              <ma14:wrappingTextBoxFlag xmlns:lc="http://schemas.openxmlformats.org/drawingml/2006/lockedCanvas" xmlns:ma14="http://schemas.microsoft.com/office/mac/drawingml/2011/main" xmlns:a14="http://schemas.microsoft.com/office/drawing/2010/main" xmlns:m="http://schemas.openxmlformats.org/officeDocument/2006/math" xmlns="" val="1"/>
             </a:ext>
           </a:extLst>
         </p:spPr>
@@ -16338,7 +16338,7 @@
           <a:effectLst/>
           <a:extLst>
             <a:ext uri="{C572A759-6A51-4108-AA02-DFA0A04FC94B}">
-              <ma14:wrappingTextBoxFlag xmlns="" xmlns:m="http://schemas.openxmlformats.org/officeDocument/2006/math" xmlns:a14="http://schemas.microsoft.com/office/drawing/2010/main" xmlns:ma14="http://schemas.microsoft.com/office/mac/drawingml/2011/main" xmlns:lc="http://schemas.openxmlformats.org/drawingml/2006/lockedCanvas" val="1"/>
+              <ma14:wrappingTextBoxFlag xmlns:lc="http://schemas.openxmlformats.org/drawingml/2006/lockedCanvas" xmlns:ma14="http://schemas.microsoft.com/office/mac/drawingml/2011/main" xmlns:a14="http://schemas.microsoft.com/office/drawing/2010/main" xmlns:m="http://schemas.openxmlformats.org/officeDocument/2006/math" xmlns="" val="1"/>
             </a:ext>
           </a:extLst>
         </p:spPr>
@@ -16669,7 +16669,7 @@
           <a:effectLst/>
           <a:extLst>
             <a:ext uri="{C572A759-6A51-4108-AA02-DFA0A04FC94B}">
-              <ma14:wrappingTextBoxFlag xmlns="" xmlns:m="http://schemas.openxmlformats.org/officeDocument/2006/math" xmlns:a14="http://schemas.microsoft.com/office/drawing/2010/main" xmlns:ma14="http://schemas.microsoft.com/office/mac/drawingml/2011/main" xmlns:lc="http://schemas.openxmlformats.org/drawingml/2006/lockedCanvas" val="1"/>
+              <ma14:wrappingTextBoxFlag xmlns:lc="http://schemas.openxmlformats.org/drawingml/2006/lockedCanvas" xmlns:ma14="http://schemas.microsoft.com/office/mac/drawingml/2011/main" xmlns:a14="http://schemas.microsoft.com/office/drawing/2010/main" xmlns:m="http://schemas.openxmlformats.org/officeDocument/2006/math" xmlns="" val="1"/>
             </a:ext>
           </a:extLst>
         </p:spPr>
@@ -17243,7 +17243,7 @@
           <a:effectLst/>
           <a:extLst>
             <a:ext uri="{C572A759-6A51-4108-AA02-DFA0A04FC94B}">
-              <ma14:wrappingTextBoxFlag xmlns="" xmlns:m="http://schemas.openxmlformats.org/officeDocument/2006/math" xmlns:a14="http://schemas.microsoft.com/office/drawing/2010/main" xmlns:ma14="http://schemas.microsoft.com/office/mac/drawingml/2011/main" xmlns:lc="http://schemas.openxmlformats.org/drawingml/2006/lockedCanvas" val="1"/>
+              <ma14:wrappingTextBoxFlag xmlns:lc="http://schemas.openxmlformats.org/drawingml/2006/lockedCanvas" xmlns:ma14="http://schemas.microsoft.com/office/mac/drawingml/2011/main" xmlns:a14="http://schemas.microsoft.com/office/drawing/2010/main" xmlns:m="http://schemas.openxmlformats.org/officeDocument/2006/math" xmlns="" val="1"/>
             </a:ext>
           </a:extLst>
         </p:spPr>
@@ -17743,7 +17743,7 @@
           <a:effectLst/>
           <a:extLst>
             <a:ext uri="{C572A759-6A51-4108-AA02-DFA0A04FC94B}">
-              <ma14:wrappingTextBoxFlag xmlns="" xmlns:m="http://schemas.openxmlformats.org/officeDocument/2006/math" xmlns:a14="http://schemas.microsoft.com/office/drawing/2010/main" xmlns:ma14="http://schemas.microsoft.com/office/mac/drawingml/2011/main" xmlns:lc="http://schemas.openxmlformats.org/drawingml/2006/lockedCanvas" val="1"/>
+              <ma14:wrappingTextBoxFlag xmlns:lc="http://schemas.openxmlformats.org/drawingml/2006/lockedCanvas" xmlns:ma14="http://schemas.microsoft.com/office/mac/drawingml/2011/main" xmlns:a14="http://schemas.microsoft.com/office/drawing/2010/main" xmlns:m="http://schemas.openxmlformats.org/officeDocument/2006/math" xmlns="" val="1"/>
             </a:ext>
           </a:extLst>
         </p:spPr>
@@ -17885,7 +17885,7 @@
         <p:spPr>
           <a:xfrm>
             <a:off x="6375527" y="4521275"/>
-            <a:ext cx="5040000" cy="1141621"/>
+            <a:ext cx="5040000" cy="1947258"/>
           </a:xfrm>
           <a:prstGeom prst="rect">
             <a:avLst/>
@@ -17898,7 +17898,7 @@
           <a:effectLst/>
           <a:extLst>
             <a:ext uri="{C572A759-6A51-4108-AA02-DFA0A04FC94B}">
-              <ma14:wrappingTextBoxFlag xmlns="" xmlns:m="http://schemas.openxmlformats.org/officeDocument/2006/math" xmlns:a14="http://schemas.microsoft.com/office/drawing/2010/main" xmlns:ma14="http://schemas.microsoft.com/office/mac/drawingml/2011/main" xmlns:lc="http://schemas.openxmlformats.org/drawingml/2006/lockedCanvas" val="1"/>
+              <ma14:wrappingTextBoxFlag xmlns:lc="http://schemas.openxmlformats.org/drawingml/2006/lockedCanvas" xmlns:ma14="http://schemas.microsoft.com/office/mac/drawingml/2011/main" xmlns:a14="http://schemas.microsoft.com/office/drawing/2010/main" xmlns:m="http://schemas.openxmlformats.org/officeDocument/2006/math" xmlns="" val="1"/>
             </a:ext>
           </a:extLst>
         </p:spPr>
@@ -18103,7 +18103,25 @@
                 </a:solidFill>
                 <a:cs typeface="Segoe UI Light" panose="020B0502040204020203" pitchFamily="34" charset="0"/>
               </a:rPr>
-              <a:t>Stable and scalable infrastructure, with support for production-grade workloads</a:t>
+              <a:t>Stable and </a:t>
+            </a:r>
+            <a:r>
+              <a:rPr lang="en-US" sz="1500" b="1" dirty="0">
+                <a:solidFill>
+                  <a:schemeClr val="accent1"/>
+                </a:solidFill>
+                <a:cs typeface="Segoe UI Light" panose="020B0502040204020203" pitchFamily="34" charset="0"/>
+              </a:rPr>
+              <a:t>scalable infrastructure</a:t>
+            </a:r>
+            <a:r>
+              <a:rPr lang="en-US" sz="1500" dirty="0">
+                <a:solidFill>
+                  <a:schemeClr val="accent1"/>
+                </a:solidFill>
+                <a:cs typeface="Segoe UI Light" panose="020B0502040204020203" pitchFamily="34" charset="0"/>
+              </a:rPr>
+              <a:t>, with support for production-grade workloads</a:t>
             </a:r>
           </a:p>
           <a:p>
@@ -18112,13 +18130,22 @@
               <a:buChar char="•"/>
             </a:pPr>
             <a:r>
-              <a:rPr lang="en-US" sz="1500" dirty="0">
+              <a:rPr lang="en-US" sz="1500" b="1" dirty="0">
                 <a:solidFill>
                   <a:schemeClr val="accent1"/>
                 </a:solidFill>
                 <a:cs typeface="Segoe UI Light" panose="020B0502040204020203" pitchFamily="34" charset="0"/>
               </a:rPr>
-              <a:t>Azure Container Registry (ACR) to host Docker images securely.</a:t>
+              <a:t>Azure Container Registry (ACR)</a:t>
+            </a:r>
+            <a:r>
+              <a:rPr lang="en-US" sz="1500" dirty="0">
+                <a:solidFill>
+                  <a:schemeClr val="accent1"/>
+                </a:solidFill>
+                <a:cs typeface="Segoe UI Light" panose="020B0502040204020203" pitchFamily="34" charset="0"/>
+              </a:rPr>
+              <a:t> to host Docker images securely.</a:t>
             </a:r>
             <a:endParaRPr lang="fr-BE" sz="1500" dirty="0">
               <a:solidFill>
@@ -18337,7 +18364,7 @@
           <a:effectLst/>
           <a:extLst>
             <a:ext uri="{C572A759-6A51-4108-AA02-DFA0A04FC94B}">
-              <ma14:wrappingTextBoxFlag xmlns="" xmlns:m="http://schemas.openxmlformats.org/officeDocument/2006/math" xmlns:a14="http://schemas.microsoft.com/office/drawing/2010/main" xmlns:ma14="http://schemas.microsoft.com/office/mac/drawingml/2011/main" xmlns:lc="http://schemas.openxmlformats.org/drawingml/2006/lockedCanvas" val="1"/>
+              <ma14:wrappingTextBoxFlag xmlns:lc="http://schemas.openxmlformats.org/drawingml/2006/lockedCanvas" xmlns:ma14="http://schemas.microsoft.com/office/mac/drawingml/2011/main" xmlns:a14="http://schemas.microsoft.com/office/drawing/2010/main" xmlns:m="http://schemas.openxmlformats.org/officeDocument/2006/math" xmlns="" val="1"/>
             </a:ext>
           </a:extLst>
         </p:spPr>
@@ -18540,6 +18567,1536 @@
 </file>
 
 <file path=ppt/slides/slide3.xml><?xml version="1.0" encoding="utf-8"?>
+<p:sld xmlns:a="http://schemas.openxmlformats.org/drawingml/2006/main" xmlns:r="http://schemas.openxmlformats.org/officeDocument/2006/relationships" xmlns:p="http://schemas.openxmlformats.org/presentationml/2006/main">
+  <p:cSld>
+    <p:spTree>
+      <p:nvGrpSpPr>
+        <p:cNvPr id="1" name=""/>
+        <p:cNvGrpSpPr/>
+        <p:nvPr/>
+      </p:nvGrpSpPr>
+      <p:grpSpPr>
+        <a:xfrm>
+          <a:off x="0" y="0"/>
+          <a:ext cx="0" cy="0"/>
+          <a:chOff x="0" y="0"/>
+          <a:chExt cx="0" cy="0"/>
+        </a:xfrm>
+      </p:grpSpPr>
+      <p:sp>
+        <p:nvSpPr>
+          <p:cNvPr id="2" name="Title 1">
+            <a:extLst>
+              <a:ext uri="{FF2B5EF4-FFF2-40B4-BE49-F238E27FC236}">
+                <a16:creationId xmlns:a16="http://schemas.microsoft.com/office/drawing/2014/main" id="{C3719F9F-3A80-9C62-8C83-36A8D3648506}"/>
+              </a:ext>
+            </a:extLst>
+          </p:cNvPr>
+          <p:cNvSpPr>
+            <a:spLocks noGrp="1"/>
+          </p:cNvSpPr>
+          <p:nvPr>
+            <p:ph type="title"/>
+          </p:nvPr>
+        </p:nvSpPr>
+        <p:spPr>
+          <a:xfrm>
+            <a:off x="515938" y="246621"/>
+            <a:ext cx="2852102" cy="612746"/>
+          </a:xfrm>
+        </p:spPr>
+        <p:txBody>
+          <a:bodyPr/>
+          <a:lstStyle/>
+          <a:p>
+            <a:r>
+              <a:rPr lang="en-US" dirty="0">
+                <a:solidFill>
+                  <a:schemeClr val="accent2"/>
+                </a:solidFill>
+              </a:rPr>
+              <a:t>Demo</a:t>
+            </a:r>
+          </a:p>
+        </p:txBody>
+      </p:sp>
+      <p:pic>
+        <p:nvPicPr>
+          <p:cNvPr id="6" name="Picture 5">
+            <a:extLst>
+              <a:ext uri="{FF2B5EF4-FFF2-40B4-BE49-F238E27FC236}">
+                <a16:creationId xmlns:a16="http://schemas.microsoft.com/office/drawing/2014/main" id="{9E233DAD-8357-704B-8905-F662BC82E1D7}"/>
+              </a:ext>
+            </a:extLst>
+          </p:cNvPr>
+          <p:cNvPicPr>
+            <a:picLocks noChangeAspect="1"/>
+          </p:cNvPicPr>
+          <p:nvPr/>
+        </p:nvPicPr>
+        <p:blipFill>
+          <a:blip r:embed="rId2"/>
+          <a:stretch>
+            <a:fillRect/>
+          </a:stretch>
+        </p:blipFill>
+        <p:spPr>
+          <a:xfrm>
+            <a:off x="4436829" y="109437"/>
+            <a:ext cx="4000617" cy="6466382"/>
+          </a:xfrm>
+          <a:prstGeom prst="rect">
+            <a:avLst/>
+          </a:prstGeom>
+        </p:spPr>
+      </p:pic>
+      <p:pic>
+        <p:nvPicPr>
+          <p:cNvPr id="17" name="Picture 16">
+            <a:extLst>
+              <a:ext uri="{FF2B5EF4-FFF2-40B4-BE49-F238E27FC236}">
+                <a16:creationId xmlns:a16="http://schemas.microsoft.com/office/drawing/2014/main" id="{8374262E-65CC-72AE-1AE5-AE7E8C32B6C2}"/>
+              </a:ext>
+            </a:extLst>
+          </p:cNvPr>
+          <p:cNvPicPr>
+            <a:picLocks noChangeAspect="1"/>
+          </p:cNvPicPr>
+          <p:nvPr/>
+        </p:nvPicPr>
+        <p:blipFill>
+          <a:blip r:embed="rId3"/>
+          <a:stretch>
+            <a:fillRect/>
+          </a:stretch>
+        </p:blipFill>
+        <p:spPr>
+          <a:xfrm>
+            <a:off x="8493325" y="190741"/>
+            <a:ext cx="3236394" cy="5136626"/>
+          </a:xfrm>
+          <a:prstGeom prst="rect">
+            <a:avLst/>
+          </a:prstGeom>
+        </p:spPr>
+      </p:pic>
+      <p:sp>
+        <p:nvSpPr>
+          <p:cNvPr id="18" name="Rounded Rectangle">
+            <a:extLst>
+              <a:ext uri="{FF2B5EF4-FFF2-40B4-BE49-F238E27FC236}">
+                <a16:creationId xmlns:a16="http://schemas.microsoft.com/office/drawing/2014/main" id="{7FDBD02B-FE4F-D658-ADEF-BA4E7D6A85E3}"/>
+              </a:ext>
+            </a:extLst>
+          </p:cNvPr>
+          <p:cNvSpPr/>
+          <p:nvPr/>
+        </p:nvSpPr>
+        <p:spPr>
+          <a:xfrm>
+            <a:off x="515938" y="1720654"/>
+            <a:ext cx="3554412" cy="1176288"/>
+          </a:xfrm>
+          <a:prstGeom prst="roundRect">
+            <a:avLst>
+              <a:gd name="adj" fmla="val 3067"/>
+            </a:avLst>
+          </a:prstGeom>
+          <a:solidFill>
+            <a:schemeClr val="bg1">
+              <a:alpha val="87000"/>
+            </a:schemeClr>
+          </a:solidFill>
+          <a:ln w="12700" cap="flat">
+            <a:noFill/>
+            <a:miter lim="400000"/>
+          </a:ln>
+          <a:effectLst>
+            <a:outerShdw blurRad="952500" dist="444500" dir="5400000" rotWithShape="0">
+              <a:srgbClr val="000000">
+                <a:alpha val="15000"/>
+              </a:srgbClr>
+            </a:outerShdw>
+          </a:effectLst>
+        </p:spPr>
+        <p:txBody>
+          <a:bodyPr wrap="square" lIns="0" tIns="0" rIns="0" bIns="0" numCol="1" anchor="ctr">
+            <a:noAutofit/>
+          </a:bodyPr>
+          <a:lstStyle>
+            <a:defPPr>
+              <a:defRPr lang="en-US"/>
+            </a:defPPr>
+            <a:lvl1pPr marL="0" algn="l" defTabSz="914400" rtl="0" eaLnBrk="1" latinLnBrk="0" hangingPunct="1">
+              <a:defRPr sz="1800" kern="1200">
+                <a:solidFill>
+                  <a:schemeClr val="tx1"/>
+                </a:solidFill>
+                <a:latin typeface="+mn-lt"/>
+                <a:ea typeface="+mn-ea"/>
+                <a:cs typeface="+mn-cs"/>
+              </a:defRPr>
+            </a:lvl1pPr>
+            <a:lvl2pPr marL="457200" algn="l" defTabSz="914400" rtl="0" eaLnBrk="1" latinLnBrk="0" hangingPunct="1">
+              <a:defRPr sz="1800" kern="1200">
+                <a:solidFill>
+                  <a:schemeClr val="tx1"/>
+                </a:solidFill>
+                <a:latin typeface="+mn-lt"/>
+                <a:ea typeface="+mn-ea"/>
+                <a:cs typeface="+mn-cs"/>
+              </a:defRPr>
+            </a:lvl2pPr>
+            <a:lvl3pPr marL="914400" algn="l" defTabSz="914400" rtl="0" eaLnBrk="1" latinLnBrk="0" hangingPunct="1">
+              <a:defRPr sz="1800" kern="1200">
+                <a:solidFill>
+                  <a:schemeClr val="tx1"/>
+                </a:solidFill>
+                <a:latin typeface="+mn-lt"/>
+                <a:ea typeface="+mn-ea"/>
+                <a:cs typeface="+mn-cs"/>
+              </a:defRPr>
+            </a:lvl3pPr>
+            <a:lvl4pPr marL="1371600" algn="l" defTabSz="914400" rtl="0" eaLnBrk="1" latinLnBrk="0" hangingPunct="1">
+              <a:defRPr sz="1800" kern="1200">
+                <a:solidFill>
+                  <a:schemeClr val="tx1"/>
+                </a:solidFill>
+                <a:latin typeface="+mn-lt"/>
+                <a:ea typeface="+mn-ea"/>
+                <a:cs typeface="+mn-cs"/>
+              </a:defRPr>
+            </a:lvl4pPr>
+            <a:lvl5pPr marL="1828800" algn="l" defTabSz="914400" rtl="0" eaLnBrk="1" latinLnBrk="0" hangingPunct="1">
+              <a:defRPr sz="1800" kern="1200">
+                <a:solidFill>
+                  <a:schemeClr val="tx1"/>
+                </a:solidFill>
+                <a:latin typeface="+mn-lt"/>
+                <a:ea typeface="+mn-ea"/>
+                <a:cs typeface="+mn-cs"/>
+              </a:defRPr>
+            </a:lvl5pPr>
+            <a:lvl6pPr marL="2286000" algn="l" defTabSz="914400" rtl="0" eaLnBrk="1" latinLnBrk="0" hangingPunct="1">
+              <a:defRPr sz="1800" kern="1200">
+                <a:solidFill>
+                  <a:schemeClr val="tx1"/>
+                </a:solidFill>
+                <a:latin typeface="+mn-lt"/>
+                <a:ea typeface="+mn-ea"/>
+                <a:cs typeface="+mn-cs"/>
+              </a:defRPr>
+            </a:lvl6pPr>
+            <a:lvl7pPr marL="2743200" algn="l" defTabSz="914400" rtl="0" eaLnBrk="1" latinLnBrk="0" hangingPunct="1">
+              <a:defRPr sz="1800" kern="1200">
+                <a:solidFill>
+                  <a:schemeClr val="tx1"/>
+                </a:solidFill>
+                <a:latin typeface="+mn-lt"/>
+                <a:ea typeface="+mn-ea"/>
+                <a:cs typeface="+mn-cs"/>
+              </a:defRPr>
+            </a:lvl7pPr>
+            <a:lvl8pPr marL="3200400" algn="l" defTabSz="914400" rtl="0" eaLnBrk="1" latinLnBrk="0" hangingPunct="1">
+              <a:defRPr sz="1800" kern="1200">
+                <a:solidFill>
+                  <a:schemeClr val="tx1"/>
+                </a:solidFill>
+                <a:latin typeface="+mn-lt"/>
+                <a:ea typeface="+mn-ea"/>
+                <a:cs typeface="+mn-cs"/>
+              </a:defRPr>
+            </a:lvl8pPr>
+            <a:lvl9pPr marL="3657600" algn="l" defTabSz="914400" rtl="0" eaLnBrk="1" latinLnBrk="0" hangingPunct="1">
+              <a:defRPr sz="1800" kern="1200">
+                <a:solidFill>
+                  <a:schemeClr val="tx1"/>
+                </a:solidFill>
+                <a:latin typeface="+mn-lt"/>
+                <a:ea typeface="+mn-ea"/>
+                <a:cs typeface="+mn-cs"/>
+              </a:defRPr>
+            </a:lvl9pPr>
+          </a:lstStyle>
+          <a:p>
+            <a:pPr marL="0" marR="0" lvl="0" indent="0" algn="ctr" defTabSz="410766" rtl="0" eaLnBrk="1" fontAlgn="auto" latinLnBrk="0" hangingPunct="0">
+              <a:lnSpc>
+                <a:spcPct val="100000"/>
+              </a:lnSpc>
+              <a:spcBef>
+                <a:spcPts val="0"/>
+              </a:spcBef>
+              <a:spcAft>
+                <a:spcPts val="0"/>
+              </a:spcAft>
+              <a:buClrTx/>
+              <a:buSzTx/>
+              <a:buFontTx/>
+              <a:buNone/>
+              <a:tabLst/>
+              <a:defRPr sz="3000" b="1">
+                <a:solidFill>
+                  <a:srgbClr val="FFFFFF"/>
+                </a:solidFill>
+              </a:defRPr>
+            </a:pPr>
+            <a:endParaRPr kumimoji="0" lang="fr-BE" sz="1500" b="1" i="0" u="none" strike="noStrike" kern="0" cap="none" spc="0" normalizeH="0" baseline="0" noProof="0" dirty="0">
+              <a:ln>
+                <a:noFill/>
+              </a:ln>
+              <a:solidFill>
+                <a:srgbClr val="44546A"/>
+              </a:solidFill>
+              <a:effectLst/>
+              <a:uLnTx/>
+              <a:uFillTx/>
+              <a:ea typeface="+mn-ea"/>
+              <a:cs typeface="Segoe UI"/>
+              <a:sym typeface="Segoe UI"/>
+            </a:endParaRPr>
+          </a:p>
+        </p:txBody>
+      </p:sp>
+      <p:sp>
+        <p:nvSpPr>
+          <p:cNvPr id="19" name="Mobilisation &amp; Inputs Gathering">
+            <a:extLst>
+              <a:ext uri="{FF2B5EF4-FFF2-40B4-BE49-F238E27FC236}">
+                <a16:creationId xmlns:a16="http://schemas.microsoft.com/office/drawing/2014/main" id="{E2F21825-3163-64F2-FA92-2DBC00DFE8DA}"/>
+              </a:ext>
+            </a:extLst>
+          </p:cNvPr>
+          <p:cNvSpPr txBox="1"/>
+          <p:nvPr/>
+        </p:nvSpPr>
+        <p:spPr>
+          <a:xfrm>
+            <a:off x="515937" y="1798739"/>
+            <a:ext cx="3554411" cy="377910"/>
+          </a:xfrm>
+          <a:prstGeom prst="rect">
+            <a:avLst/>
+          </a:prstGeom>
+          <a:noFill/>
+          <a:ln w="12700" cap="flat">
+            <a:noFill/>
+            <a:miter lim="400000"/>
+          </a:ln>
+          <a:effectLst/>
+          <a:extLst>
+            <a:ext uri="{C572A759-6A51-4108-AA02-DFA0A04FC94B}">
+              <ma14:wrappingTextBoxFlag xmlns="" xmlns:m="http://schemas.openxmlformats.org/officeDocument/2006/math" xmlns:a14="http://schemas.microsoft.com/office/drawing/2010/main" xmlns:ma14="http://schemas.microsoft.com/office/mac/drawingml/2011/main" xmlns:lc="http://schemas.openxmlformats.org/drawingml/2006/lockedCanvas" val="1"/>
+            </a:ext>
+          </a:extLst>
+        </p:spPr>
+        <p:txBody>
+          <a:bodyPr wrap="square" lIns="35719" tIns="35719" rIns="35719" bIns="35719" numCol="1" anchor="t">
+            <a:noAutofit/>
+          </a:bodyPr>
+          <a:lstStyle>
+            <a:defPPr>
+              <a:defRPr lang="en-US"/>
+            </a:defPPr>
+            <a:lvl1pPr marL="0" algn="l" defTabSz="914400" rtl="0" eaLnBrk="1" latinLnBrk="0" hangingPunct="1">
+              <a:defRPr sz="1800" kern="1200">
+                <a:solidFill>
+                  <a:schemeClr val="tx1"/>
+                </a:solidFill>
+                <a:latin typeface="+mn-lt"/>
+                <a:ea typeface="+mn-ea"/>
+                <a:cs typeface="+mn-cs"/>
+              </a:defRPr>
+            </a:lvl1pPr>
+            <a:lvl2pPr marL="457200" algn="l" defTabSz="914400" rtl="0" eaLnBrk="1" latinLnBrk="0" hangingPunct="1">
+              <a:defRPr sz="1800" kern="1200">
+                <a:solidFill>
+                  <a:schemeClr val="tx1"/>
+                </a:solidFill>
+                <a:latin typeface="+mn-lt"/>
+                <a:ea typeface="+mn-ea"/>
+                <a:cs typeface="+mn-cs"/>
+              </a:defRPr>
+            </a:lvl2pPr>
+            <a:lvl3pPr marL="914400" algn="l" defTabSz="914400" rtl="0" eaLnBrk="1" latinLnBrk="0" hangingPunct="1">
+              <a:defRPr sz="1800" kern="1200">
+                <a:solidFill>
+                  <a:schemeClr val="tx1"/>
+                </a:solidFill>
+                <a:latin typeface="+mn-lt"/>
+                <a:ea typeface="+mn-ea"/>
+                <a:cs typeface="+mn-cs"/>
+              </a:defRPr>
+            </a:lvl3pPr>
+            <a:lvl4pPr marL="1371600" algn="l" defTabSz="914400" rtl="0" eaLnBrk="1" latinLnBrk="0" hangingPunct="1">
+              <a:defRPr sz="1800" kern="1200">
+                <a:solidFill>
+                  <a:schemeClr val="tx1"/>
+                </a:solidFill>
+                <a:latin typeface="+mn-lt"/>
+                <a:ea typeface="+mn-ea"/>
+                <a:cs typeface="+mn-cs"/>
+              </a:defRPr>
+            </a:lvl4pPr>
+            <a:lvl5pPr marL="1828800" algn="l" defTabSz="914400" rtl="0" eaLnBrk="1" latinLnBrk="0" hangingPunct="1">
+              <a:defRPr sz="1800" kern="1200">
+                <a:solidFill>
+                  <a:schemeClr val="tx1"/>
+                </a:solidFill>
+                <a:latin typeface="+mn-lt"/>
+                <a:ea typeface="+mn-ea"/>
+                <a:cs typeface="+mn-cs"/>
+              </a:defRPr>
+            </a:lvl5pPr>
+            <a:lvl6pPr marL="2286000" algn="l" defTabSz="914400" rtl="0" eaLnBrk="1" latinLnBrk="0" hangingPunct="1">
+              <a:defRPr sz="1800" kern="1200">
+                <a:solidFill>
+                  <a:schemeClr val="tx1"/>
+                </a:solidFill>
+                <a:latin typeface="+mn-lt"/>
+                <a:ea typeface="+mn-ea"/>
+                <a:cs typeface="+mn-cs"/>
+              </a:defRPr>
+            </a:lvl6pPr>
+            <a:lvl7pPr marL="2743200" algn="l" defTabSz="914400" rtl="0" eaLnBrk="1" latinLnBrk="0" hangingPunct="1">
+              <a:defRPr sz="1800" kern="1200">
+                <a:solidFill>
+                  <a:schemeClr val="tx1"/>
+                </a:solidFill>
+                <a:latin typeface="+mn-lt"/>
+                <a:ea typeface="+mn-ea"/>
+                <a:cs typeface="+mn-cs"/>
+              </a:defRPr>
+            </a:lvl7pPr>
+            <a:lvl8pPr marL="3200400" algn="l" defTabSz="914400" rtl="0" eaLnBrk="1" latinLnBrk="0" hangingPunct="1">
+              <a:defRPr sz="1800" kern="1200">
+                <a:solidFill>
+                  <a:schemeClr val="tx1"/>
+                </a:solidFill>
+                <a:latin typeface="+mn-lt"/>
+                <a:ea typeface="+mn-ea"/>
+                <a:cs typeface="+mn-cs"/>
+              </a:defRPr>
+            </a:lvl8pPr>
+            <a:lvl9pPr marL="3657600" algn="l" defTabSz="914400" rtl="0" eaLnBrk="1" latinLnBrk="0" hangingPunct="1">
+              <a:defRPr sz="1800" kern="1200">
+                <a:solidFill>
+                  <a:schemeClr val="tx1"/>
+                </a:solidFill>
+                <a:latin typeface="+mn-lt"/>
+                <a:ea typeface="+mn-ea"/>
+                <a:cs typeface="+mn-cs"/>
+              </a:defRPr>
+            </a:lvl9pPr>
+          </a:lstStyle>
+          <a:p>
+            <a:pPr algn="ctr" defTabSz="533400">
+              <a:lnSpc>
+                <a:spcPct val="90000"/>
+              </a:lnSpc>
+              <a:spcBef>
+                <a:spcPct val="0"/>
+              </a:spcBef>
+              <a:spcAft>
+                <a:spcPct val="35000"/>
+              </a:spcAft>
+            </a:pPr>
+            <a:r>
+              <a:rPr lang="en-US" b="1" dirty="0">
+                <a:solidFill>
+                  <a:srgbClr val="44546A"/>
+                </a:solidFill>
+                <a:cs typeface="Segoe UI Light" panose="020B0502040204020203" pitchFamily="34" charset="0"/>
+              </a:rPr>
+              <a:t>Frontend</a:t>
+            </a:r>
+            <a:endParaRPr lang="en-US" b="1" noProof="0" dirty="0">
+              <a:solidFill>
+                <a:srgbClr val="44546A"/>
+              </a:solidFill>
+              <a:cs typeface="Segoe UI Light" panose="020B0502040204020203" pitchFamily="34" charset="0"/>
+            </a:endParaRPr>
+          </a:p>
+        </p:txBody>
+      </p:sp>
+      <p:sp>
+        <p:nvSpPr>
+          <p:cNvPr id="20" name="Line">
+            <a:extLst>
+              <a:ext uri="{FF2B5EF4-FFF2-40B4-BE49-F238E27FC236}">
+                <a16:creationId xmlns:a16="http://schemas.microsoft.com/office/drawing/2014/main" id="{D594B898-1FD0-751A-7D70-11322EF83D9E}"/>
+              </a:ext>
+            </a:extLst>
+          </p:cNvPr>
+          <p:cNvSpPr/>
+          <p:nvPr/>
+        </p:nvSpPr>
+        <p:spPr>
+          <a:xfrm>
+            <a:off x="515939" y="2182751"/>
+            <a:ext cx="3554412" cy="0"/>
+          </a:xfrm>
+          <a:prstGeom prst="line">
+            <a:avLst/>
+          </a:prstGeom>
+          <a:noFill/>
+          <a:ln w="50800" cap="flat">
+            <a:solidFill>
+              <a:srgbClr val="F94F00"/>
+            </a:solidFill>
+            <a:prstDash val="solid"/>
+            <a:miter lim="400000"/>
+          </a:ln>
+          <a:effectLst/>
+        </p:spPr>
+        <p:txBody>
+          <a:bodyPr wrap="square" lIns="0" tIns="0" rIns="0" bIns="0" numCol="1" anchor="ctr">
+            <a:noAutofit/>
+          </a:bodyPr>
+          <a:lstStyle>
+            <a:defPPr>
+              <a:defRPr lang="en-US"/>
+            </a:defPPr>
+            <a:lvl1pPr marL="0" algn="l" defTabSz="914400" rtl="0" eaLnBrk="1" latinLnBrk="0" hangingPunct="1">
+              <a:defRPr sz="1800" kern="1200">
+                <a:solidFill>
+                  <a:schemeClr val="tx1"/>
+                </a:solidFill>
+                <a:latin typeface="+mn-lt"/>
+                <a:ea typeface="+mn-ea"/>
+                <a:cs typeface="+mn-cs"/>
+              </a:defRPr>
+            </a:lvl1pPr>
+            <a:lvl2pPr marL="457200" algn="l" defTabSz="914400" rtl="0" eaLnBrk="1" latinLnBrk="0" hangingPunct="1">
+              <a:defRPr sz="1800" kern="1200">
+                <a:solidFill>
+                  <a:schemeClr val="tx1"/>
+                </a:solidFill>
+                <a:latin typeface="+mn-lt"/>
+                <a:ea typeface="+mn-ea"/>
+                <a:cs typeface="+mn-cs"/>
+              </a:defRPr>
+            </a:lvl2pPr>
+            <a:lvl3pPr marL="914400" algn="l" defTabSz="914400" rtl="0" eaLnBrk="1" latinLnBrk="0" hangingPunct="1">
+              <a:defRPr sz="1800" kern="1200">
+                <a:solidFill>
+                  <a:schemeClr val="tx1"/>
+                </a:solidFill>
+                <a:latin typeface="+mn-lt"/>
+                <a:ea typeface="+mn-ea"/>
+                <a:cs typeface="+mn-cs"/>
+              </a:defRPr>
+            </a:lvl3pPr>
+            <a:lvl4pPr marL="1371600" algn="l" defTabSz="914400" rtl="0" eaLnBrk="1" latinLnBrk="0" hangingPunct="1">
+              <a:defRPr sz="1800" kern="1200">
+                <a:solidFill>
+                  <a:schemeClr val="tx1"/>
+                </a:solidFill>
+                <a:latin typeface="+mn-lt"/>
+                <a:ea typeface="+mn-ea"/>
+                <a:cs typeface="+mn-cs"/>
+              </a:defRPr>
+            </a:lvl4pPr>
+            <a:lvl5pPr marL="1828800" algn="l" defTabSz="914400" rtl="0" eaLnBrk="1" latinLnBrk="0" hangingPunct="1">
+              <a:defRPr sz="1800" kern="1200">
+                <a:solidFill>
+                  <a:schemeClr val="tx1"/>
+                </a:solidFill>
+                <a:latin typeface="+mn-lt"/>
+                <a:ea typeface="+mn-ea"/>
+                <a:cs typeface="+mn-cs"/>
+              </a:defRPr>
+            </a:lvl5pPr>
+            <a:lvl6pPr marL="2286000" algn="l" defTabSz="914400" rtl="0" eaLnBrk="1" latinLnBrk="0" hangingPunct="1">
+              <a:defRPr sz="1800" kern="1200">
+                <a:solidFill>
+                  <a:schemeClr val="tx1"/>
+                </a:solidFill>
+                <a:latin typeface="+mn-lt"/>
+                <a:ea typeface="+mn-ea"/>
+                <a:cs typeface="+mn-cs"/>
+              </a:defRPr>
+            </a:lvl6pPr>
+            <a:lvl7pPr marL="2743200" algn="l" defTabSz="914400" rtl="0" eaLnBrk="1" latinLnBrk="0" hangingPunct="1">
+              <a:defRPr sz="1800" kern="1200">
+                <a:solidFill>
+                  <a:schemeClr val="tx1"/>
+                </a:solidFill>
+                <a:latin typeface="+mn-lt"/>
+                <a:ea typeface="+mn-ea"/>
+                <a:cs typeface="+mn-cs"/>
+              </a:defRPr>
+            </a:lvl7pPr>
+            <a:lvl8pPr marL="3200400" algn="l" defTabSz="914400" rtl="0" eaLnBrk="1" latinLnBrk="0" hangingPunct="1">
+              <a:defRPr sz="1800" kern="1200">
+                <a:solidFill>
+                  <a:schemeClr val="tx1"/>
+                </a:solidFill>
+                <a:latin typeface="+mn-lt"/>
+                <a:ea typeface="+mn-ea"/>
+                <a:cs typeface="+mn-cs"/>
+              </a:defRPr>
+            </a:lvl8pPr>
+            <a:lvl9pPr marL="3657600" algn="l" defTabSz="914400" rtl="0" eaLnBrk="1" latinLnBrk="0" hangingPunct="1">
+              <a:defRPr sz="1800" kern="1200">
+                <a:solidFill>
+                  <a:schemeClr val="tx1"/>
+                </a:solidFill>
+                <a:latin typeface="+mn-lt"/>
+                <a:ea typeface="+mn-ea"/>
+                <a:cs typeface="+mn-cs"/>
+              </a:defRPr>
+            </a:lvl9pPr>
+          </a:lstStyle>
+          <a:p>
+            <a:pPr marL="0" marR="0" lvl="0" indent="0" algn="ctr" defTabSz="410766" rtl="0" eaLnBrk="1" fontAlgn="auto" latinLnBrk="0" hangingPunct="0">
+              <a:lnSpc>
+                <a:spcPct val="100000"/>
+              </a:lnSpc>
+              <a:spcBef>
+                <a:spcPts val="0"/>
+              </a:spcBef>
+              <a:spcAft>
+                <a:spcPts val="0"/>
+              </a:spcAft>
+              <a:buClrTx/>
+              <a:buSzTx/>
+              <a:buFontTx/>
+              <a:buNone/>
+              <a:tabLst/>
+              <a:defRPr sz="3000" b="1">
+                <a:solidFill>
+                  <a:srgbClr val="FFFFFF"/>
+                </a:solidFill>
+              </a:defRPr>
+            </a:pPr>
+            <a:endParaRPr kumimoji="0" lang="en-US" sz="1200" b="1" i="0" u="none" strike="noStrike" kern="0" cap="none" spc="0" normalizeH="0" baseline="0" noProof="0" dirty="0">
+              <a:ln>
+                <a:noFill/>
+              </a:ln>
+              <a:solidFill>
+                <a:schemeClr val="accent1"/>
+              </a:solidFill>
+              <a:effectLst/>
+              <a:uLnTx/>
+              <a:uFillTx/>
+              <a:ea typeface="+mn-ea"/>
+              <a:cs typeface="Segoe UI"/>
+              <a:sym typeface="Segoe UI"/>
+            </a:endParaRPr>
+          </a:p>
+        </p:txBody>
+      </p:sp>
+      <p:sp>
+        <p:nvSpPr>
+          <p:cNvPr id="21" name="Mobilisation &amp; Inputs Gathering">
+            <a:extLst>
+              <a:ext uri="{FF2B5EF4-FFF2-40B4-BE49-F238E27FC236}">
+                <a16:creationId xmlns:a16="http://schemas.microsoft.com/office/drawing/2014/main" id="{726176D3-F4FD-5806-DD1B-E6472B6A924C}"/>
+              </a:ext>
+            </a:extLst>
+          </p:cNvPr>
+          <p:cNvSpPr txBox="1"/>
+          <p:nvPr/>
+        </p:nvSpPr>
+        <p:spPr>
+          <a:xfrm>
+            <a:off x="678266" y="2353543"/>
+            <a:ext cx="3448683" cy="441800"/>
+          </a:xfrm>
+          <a:prstGeom prst="rect">
+            <a:avLst/>
+          </a:prstGeom>
+          <a:noFill/>
+          <a:ln w="12700" cap="flat">
+            <a:noFill/>
+            <a:miter lim="400000"/>
+          </a:ln>
+          <a:effectLst/>
+          <a:extLst>
+            <a:ext uri="{C572A759-6A51-4108-AA02-DFA0A04FC94B}">
+              <ma14:wrappingTextBoxFlag xmlns="" xmlns:m="http://schemas.openxmlformats.org/officeDocument/2006/math" xmlns:a14="http://schemas.microsoft.com/office/drawing/2010/main" xmlns:ma14="http://schemas.microsoft.com/office/mac/drawingml/2011/main" xmlns:lc="http://schemas.openxmlformats.org/drawingml/2006/lockedCanvas" val="1"/>
+            </a:ext>
+          </a:extLst>
+        </p:spPr>
+        <p:txBody>
+          <a:bodyPr wrap="square" lIns="35719" tIns="35719" rIns="35719" bIns="35719" numCol="1" anchor="t">
+            <a:noAutofit/>
+          </a:bodyPr>
+          <a:lstStyle>
+            <a:defPPr>
+              <a:defRPr lang="en-US"/>
+            </a:defPPr>
+            <a:lvl1pPr marL="0" algn="l" defTabSz="914400" rtl="0" eaLnBrk="1" latinLnBrk="0" hangingPunct="1">
+              <a:defRPr sz="1800" kern="1200">
+                <a:solidFill>
+                  <a:schemeClr val="tx1"/>
+                </a:solidFill>
+                <a:latin typeface="+mn-lt"/>
+                <a:ea typeface="+mn-ea"/>
+                <a:cs typeface="+mn-cs"/>
+              </a:defRPr>
+            </a:lvl1pPr>
+            <a:lvl2pPr marL="457200" algn="l" defTabSz="914400" rtl="0" eaLnBrk="1" latinLnBrk="0" hangingPunct="1">
+              <a:defRPr sz="1800" kern="1200">
+                <a:solidFill>
+                  <a:schemeClr val="tx1"/>
+                </a:solidFill>
+                <a:latin typeface="+mn-lt"/>
+                <a:ea typeface="+mn-ea"/>
+                <a:cs typeface="+mn-cs"/>
+              </a:defRPr>
+            </a:lvl2pPr>
+            <a:lvl3pPr marL="914400" algn="l" defTabSz="914400" rtl="0" eaLnBrk="1" latinLnBrk="0" hangingPunct="1">
+              <a:defRPr sz="1800" kern="1200">
+                <a:solidFill>
+                  <a:schemeClr val="tx1"/>
+                </a:solidFill>
+                <a:latin typeface="+mn-lt"/>
+                <a:ea typeface="+mn-ea"/>
+                <a:cs typeface="+mn-cs"/>
+              </a:defRPr>
+            </a:lvl3pPr>
+            <a:lvl4pPr marL="1371600" algn="l" defTabSz="914400" rtl="0" eaLnBrk="1" latinLnBrk="0" hangingPunct="1">
+              <a:defRPr sz="1800" kern="1200">
+                <a:solidFill>
+                  <a:schemeClr val="tx1"/>
+                </a:solidFill>
+                <a:latin typeface="+mn-lt"/>
+                <a:ea typeface="+mn-ea"/>
+                <a:cs typeface="+mn-cs"/>
+              </a:defRPr>
+            </a:lvl4pPr>
+            <a:lvl5pPr marL="1828800" algn="l" defTabSz="914400" rtl="0" eaLnBrk="1" latinLnBrk="0" hangingPunct="1">
+              <a:defRPr sz="1800" kern="1200">
+                <a:solidFill>
+                  <a:schemeClr val="tx1"/>
+                </a:solidFill>
+                <a:latin typeface="+mn-lt"/>
+                <a:ea typeface="+mn-ea"/>
+                <a:cs typeface="+mn-cs"/>
+              </a:defRPr>
+            </a:lvl5pPr>
+            <a:lvl6pPr marL="2286000" algn="l" defTabSz="914400" rtl="0" eaLnBrk="1" latinLnBrk="0" hangingPunct="1">
+              <a:defRPr sz="1800" kern="1200">
+                <a:solidFill>
+                  <a:schemeClr val="tx1"/>
+                </a:solidFill>
+                <a:latin typeface="+mn-lt"/>
+                <a:ea typeface="+mn-ea"/>
+                <a:cs typeface="+mn-cs"/>
+              </a:defRPr>
+            </a:lvl6pPr>
+            <a:lvl7pPr marL="2743200" algn="l" defTabSz="914400" rtl="0" eaLnBrk="1" latinLnBrk="0" hangingPunct="1">
+              <a:defRPr sz="1800" kern="1200">
+                <a:solidFill>
+                  <a:schemeClr val="tx1"/>
+                </a:solidFill>
+                <a:latin typeface="+mn-lt"/>
+                <a:ea typeface="+mn-ea"/>
+                <a:cs typeface="+mn-cs"/>
+              </a:defRPr>
+            </a:lvl7pPr>
+            <a:lvl8pPr marL="3200400" algn="l" defTabSz="914400" rtl="0" eaLnBrk="1" latinLnBrk="0" hangingPunct="1">
+              <a:defRPr sz="1800" kern="1200">
+                <a:solidFill>
+                  <a:schemeClr val="tx1"/>
+                </a:solidFill>
+                <a:latin typeface="+mn-lt"/>
+                <a:ea typeface="+mn-ea"/>
+                <a:cs typeface="+mn-cs"/>
+              </a:defRPr>
+            </a:lvl8pPr>
+            <a:lvl9pPr marL="3657600" algn="l" defTabSz="914400" rtl="0" eaLnBrk="1" latinLnBrk="0" hangingPunct="1">
+              <a:defRPr sz="1800" kern="1200">
+                <a:solidFill>
+                  <a:schemeClr val="tx1"/>
+                </a:solidFill>
+                <a:latin typeface="+mn-lt"/>
+                <a:ea typeface="+mn-ea"/>
+                <a:cs typeface="+mn-cs"/>
+              </a:defRPr>
+            </a:lvl9pPr>
+          </a:lstStyle>
+          <a:p>
+            <a:endParaRPr lang="fr-BE" sz="1500" b="1" dirty="0">
+              <a:solidFill>
+                <a:schemeClr val="accent1"/>
+              </a:solidFill>
+              <a:cs typeface="Segoe UI Light" panose="020B0502040204020203" pitchFamily="34" charset="0"/>
+            </a:endParaRPr>
+          </a:p>
+        </p:txBody>
+      </p:sp>
+      <p:sp>
+        <p:nvSpPr>
+          <p:cNvPr id="8" name="TextBox 7">
+            <a:extLst>
+              <a:ext uri="{FF2B5EF4-FFF2-40B4-BE49-F238E27FC236}">
+                <a16:creationId xmlns:a16="http://schemas.microsoft.com/office/drawing/2014/main" id="{0ADCA5BF-5D7C-0A21-E9A1-09912E76D2C3}"/>
+              </a:ext>
+            </a:extLst>
+          </p:cNvPr>
+          <p:cNvSpPr txBox="1"/>
+          <p:nvPr/>
+        </p:nvSpPr>
+        <p:spPr>
+          <a:xfrm>
+            <a:off x="678267" y="2146790"/>
+            <a:ext cx="3131733" cy="861774"/>
+          </a:xfrm>
+          <a:prstGeom prst="rect">
+            <a:avLst/>
+          </a:prstGeom>
+          <a:noFill/>
+        </p:spPr>
+        <p:txBody>
+          <a:bodyPr wrap="square">
+            <a:spAutoFit/>
+          </a:bodyPr>
+          <a:lstStyle/>
+          <a:p>
+            <a:endParaRPr lang="en-US" sz="1600" dirty="0">
+              <a:solidFill>
+                <a:srgbClr val="0563C1"/>
+              </a:solidFill>
+              <a:hlinkClick r:id="rId4">
+                <a:extLst>
+                  <a:ext uri="{A12FA001-AC4F-418D-AE19-62706E023703}">
+                    <ahyp:hlinkClr xmlns:ahyp="http://schemas.microsoft.com/office/drawing/2018/hyperlinkcolor" val="tx"/>
+                  </a:ext>
+                </a:extLst>
+              </a:hlinkClick>
+            </a:endParaRPr>
+          </a:p>
+          <a:p>
+            <a:r>
+              <a:rPr lang="en-US" sz="1400" dirty="0">
+                <a:solidFill>
+                  <a:srgbClr val="0563C1"/>
+                </a:solidFill>
+                <a:hlinkClick r:id="rId4">
+                  <a:extLst>
+                    <a:ext uri="{A12FA001-AC4F-418D-AE19-62706E023703}">
+                      <ahyp:hlinkClr xmlns:ahyp="http://schemas.microsoft.com/office/drawing/2018/hyperlinkcolor" val="tx"/>
+                    </a:ext>
+                  </a:extLst>
+                </a:hlinkClick>
+              </a:rPr>
+              <a:t>https://realestate-ui.azurewebsites.net/</a:t>
+            </a:r>
+            <a:endParaRPr lang="en-US" sz="1400" dirty="0"/>
+          </a:p>
+          <a:p>
+            <a:endParaRPr lang="en-US" dirty="0"/>
+          </a:p>
+        </p:txBody>
+      </p:sp>
+      <p:sp>
+        <p:nvSpPr>
+          <p:cNvPr id="22" name="Rounded Rectangle">
+            <a:extLst>
+              <a:ext uri="{FF2B5EF4-FFF2-40B4-BE49-F238E27FC236}">
+                <a16:creationId xmlns:a16="http://schemas.microsoft.com/office/drawing/2014/main" id="{9FB6A6A6-5195-0E41-E0C6-B386108D8019}"/>
+              </a:ext>
+            </a:extLst>
+          </p:cNvPr>
+          <p:cNvSpPr/>
+          <p:nvPr/>
+        </p:nvSpPr>
+        <p:spPr>
+          <a:xfrm>
+            <a:off x="540703" y="3758229"/>
+            <a:ext cx="3554412" cy="1494631"/>
+          </a:xfrm>
+          <a:prstGeom prst="roundRect">
+            <a:avLst>
+              <a:gd name="adj" fmla="val 3067"/>
+            </a:avLst>
+          </a:prstGeom>
+          <a:solidFill>
+            <a:schemeClr val="bg1">
+              <a:alpha val="87000"/>
+            </a:schemeClr>
+          </a:solidFill>
+          <a:ln w="12700" cap="flat">
+            <a:noFill/>
+            <a:miter lim="400000"/>
+          </a:ln>
+          <a:effectLst>
+            <a:outerShdw blurRad="952500" dist="444500" dir="5400000" rotWithShape="0">
+              <a:srgbClr val="000000">
+                <a:alpha val="15000"/>
+              </a:srgbClr>
+            </a:outerShdw>
+          </a:effectLst>
+        </p:spPr>
+        <p:txBody>
+          <a:bodyPr wrap="square" lIns="0" tIns="0" rIns="0" bIns="0" numCol="1" anchor="ctr">
+            <a:noAutofit/>
+          </a:bodyPr>
+          <a:lstStyle>
+            <a:defPPr>
+              <a:defRPr lang="en-US"/>
+            </a:defPPr>
+            <a:lvl1pPr marL="0" algn="l" defTabSz="914400" rtl="0" eaLnBrk="1" latinLnBrk="0" hangingPunct="1">
+              <a:defRPr sz="1800" kern="1200">
+                <a:solidFill>
+                  <a:schemeClr val="tx1"/>
+                </a:solidFill>
+                <a:latin typeface="+mn-lt"/>
+                <a:ea typeface="+mn-ea"/>
+                <a:cs typeface="+mn-cs"/>
+              </a:defRPr>
+            </a:lvl1pPr>
+            <a:lvl2pPr marL="457200" algn="l" defTabSz="914400" rtl="0" eaLnBrk="1" latinLnBrk="0" hangingPunct="1">
+              <a:defRPr sz="1800" kern="1200">
+                <a:solidFill>
+                  <a:schemeClr val="tx1"/>
+                </a:solidFill>
+                <a:latin typeface="+mn-lt"/>
+                <a:ea typeface="+mn-ea"/>
+                <a:cs typeface="+mn-cs"/>
+              </a:defRPr>
+            </a:lvl2pPr>
+            <a:lvl3pPr marL="914400" algn="l" defTabSz="914400" rtl="0" eaLnBrk="1" latinLnBrk="0" hangingPunct="1">
+              <a:defRPr sz="1800" kern="1200">
+                <a:solidFill>
+                  <a:schemeClr val="tx1"/>
+                </a:solidFill>
+                <a:latin typeface="+mn-lt"/>
+                <a:ea typeface="+mn-ea"/>
+                <a:cs typeface="+mn-cs"/>
+              </a:defRPr>
+            </a:lvl3pPr>
+            <a:lvl4pPr marL="1371600" algn="l" defTabSz="914400" rtl="0" eaLnBrk="1" latinLnBrk="0" hangingPunct="1">
+              <a:defRPr sz="1800" kern="1200">
+                <a:solidFill>
+                  <a:schemeClr val="tx1"/>
+                </a:solidFill>
+                <a:latin typeface="+mn-lt"/>
+                <a:ea typeface="+mn-ea"/>
+                <a:cs typeface="+mn-cs"/>
+              </a:defRPr>
+            </a:lvl4pPr>
+            <a:lvl5pPr marL="1828800" algn="l" defTabSz="914400" rtl="0" eaLnBrk="1" latinLnBrk="0" hangingPunct="1">
+              <a:defRPr sz="1800" kern="1200">
+                <a:solidFill>
+                  <a:schemeClr val="tx1"/>
+                </a:solidFill>
+                <a:latin typeface="+mn-lt"/>
+                <a:ea typeface="+mn-ea"/>
+                <a:cs typeface="+mn-cs"/>
+              </a:defRPr>
+            </a:lvl5pPr>
+            <a:lvl6pPr marL="2286000" algn="l" defTabSz="914400" rtl="0" eaLnBrk="1" latinLnBrk="0" hangingPunct="1">
+              <a:defRPr sz="1800" kern="1200">
+                <a:solidFill>
+                  <a:schemeClr val="tx1"/>
+                </a:solidFill>
+                <a:latin typeface="+mn-lt"/>
+                <a:ea typeface="+mn-ea"/>
+                <a:cs typeface="+mn-cs"/>
+              </a:defRPr>
+            </a:lvl6pPr>
+            <a:lvl7pPr marL="2743200" algn="l" defTabSz="914400" rtl="0" eaLnBrk="1" latinLnBrk="0" hangingPunct="1">
+              <a:defRPr sz="1800" kern="1200">
+                <a:solidFill>
+                  <a:schemeClr val="tx1"/>
+                </a:solidFill>
+                <a:latin typeface="+mn-lt"/>
+                <a:ea typeface="+mn-ea"/>
+                <a:cs typeface="+mn-cs"/>
+              </a:defRPr>
+            </a:lvl7pPr>
+            <a:lvl8pPr marL="3200400" algn="l" defTabSz="914400" rtl="0" eaLnBrk="1" latinLnBrk="0" hangingPunct="1">
+              <a:defRPr sz="1800" kern="1200">
+                <a:solidFill>
+                  <a:schemeClr val="tx1"/>
+                </a:solidFill>
+                <a:latin typeface="+mn-lt"/>
+                <a:ea typeface="+mn-ea"/>
+                <a:cs typeface="+mn-cs"/>
+              </a:defRPr>
+            </a:lvl8pPr>
+            <a:lvl9pPr marL="3657600" algn="l" defTabSz="914400" rtl="0" eaLnBrk="1" latinLnBrk="0" hangingPunct="1">
+              <a:defRPr sz="1800" kern="1200">
+                <a:solidFill>
+                  <a:schemeClr val="tx1"/>
+                </a:solidFill>
+                <a:latin typeface="+mn-lt"/>
+                <a:ea typeface="+mn-ea"/>
+                <a:cs typeface="+mn-cs"/>
+              </a:defRPr>
+            </a:lvl9pPr>
+          </a:lstStyle>
+          <a:p>
+            <a:pPr marL="0" marR="0" lvl="0" indent="0" algn="ctr" defTabSz="410766" rtl="0" eaLnBrk="1" fontAlgn="auto" latinLnBrk="0" hangingPunct="0">
+              <a:lnSpc>
+                <a:spcPct val="100000"/>
+              </a:lnSpc>
+              <a:spcBef>
+                <a:spcPts val="0"/>
+              </a:spcBef>
+              <a:spcAft>
+                <a:spcPts val="0"/>
+              </a:spcAft>
+              <a:buClrTx/>
+              <a:buSzTx/>
+              <a:buFontTx/>
+              <a:buNone/>
+              <a:tabLst/>
+              <a:defRPr sz="3000" b="1">
+                <a:solidFill>
+                  <a:srgbClr val="FFFFFF"/>
+                </a:solidFill>
+              </a:defRPr>
+            </a:pPr>
+            <a:endParaRPr kumimoji="0" lang="fr-BE" sz="1500" b="1" i="0" u="none" strike="noStrike" kern="0" cap="none" spc="0" normalizeH="0" baseline="0" noProof="0" dirty="0">
+              <a:ln>
+                <a:noFill/>
+              </a:ln>
+              <a:solidFill>
+                <a:srgbClr val="44546A"/>
+              </a:solidFill>
+              <a:effectLst/>
+              <a:uLnTx/>
+              <a:uFillTx/>
+              <a:ea typeface="+mn-ea"/>
+              <a:cs typeface="Segoe UI"/>
+              <a:sym typeface="Segoe UI"/>
+            </a:endParaRPr>
+          </a:p>
+        </p:txBody>
+      </p:sp>
+      <p:sp>
+        <p:nvSpPr>
+          <p:cNvPr id="23" name="Mobilisation &amp; Inputs Gathering">
+            <a:extLst>
+              <a:ext uri="{FF2B5EF4-FFF2-40B4-BE49-F238E27FC236}">
+                <a16:creationId xmlns:a16="http://schemas.microsoft.com/office/drawing/2014/main" id="{B8F42CA3-C059-BCEB-A5D4-686F5F8C8EED}"/>
+              </a:ext>
+            </a:extLst>
+          </p:cNvPr>
+          <p:cNvSpPr txBox="1"/>
+          <p:nvPr/>
+        </p:nvSpPr>
+        <p:spPr>
+          <a:xfrm>
+            <a:off x="540703" y="3836315"/>
+            <a:ext cx="3554412" cy="377910"/>
+          </a:xfrm>
+          <a:prstGeom prst="rect">
+            <a:avLst/>
+          </a:prstGeom>
+          <a:noFill/>
+          <a:ln w="12700" cap="flat">
+            <a:noFill/>
+            <a:miter lim="400000"/>
+          </a:ln>
+          <a:effectLst/>
+          <a:extLst>
+            <a:ext uri="{C572A759-6A51-4108-AA02-DFA0A04FC94B}">
+              <ma14:wrappingTextBoxFlag xmlns="" xmlns:m="http://schemas.openxmlformats.org/officeDocument/2006/math" xmlns:a14="http://schemas.microsoft.com/office/drawing/2010/main" xmlns:ma14="http://schemas.microsoft.com/office/mac/drawingml/2011/main" xmlns:lc="http://schemas.openxmlformats.org/drawingml/2006/lockedCanvas" val="1"/>
+            </a:ext>
+          </a:extLst>
+        </p:spPr>
+        <p:txBody>
+          <a:bodyPr wrap="square" lIns="35719" tIns="35719" rIns="35719" bIns="35719" numCol="1" anchor="t">
+            <a:noAutofit/>
+          </a:bodyPr>
+          <a:lstStyle>
+            <a:defPPr>
+              <a:defRPr lang="en-US"/>
+            </a:defPPr>
+            <a:lvl1pPr marL="0" algn="l" defTabSz="914400" rtl="0" eaLnBrk="1" latinLnBrk="0" hangingPunct="1">
+              <a:defRPr sz="1800" kern="1200">
+                <a:solidFill>
+                  <a:schemeClr val="tx1"/>
+                </a:solidFill>
+                <a:latin typeface="+mn-lt"/>
+                <a:ea typeface="+mn-ea"/>
+                <a:cs typeface="+mn-cs"/>
+              </a:defRPr>
+            </a:lvl1pPr>
+            <a:lvl2pPr marL="457200" algn="l" defTabSz="914400" rtl="0" eaLnBrk="1" latinLnBrk="0" hangingPunct="1">
+              <a:defRPr sz="1800" kern="1200">
+                <a:solidFill>
+                  <a:schemeClr val="tx1"/>
+                </a:solidFill>
+                <a:latin typeface="+mn-lt"/>
+                <a:ea typeface="+mn-ea"/>
+                <a:cs typeface="+mn-cs"/>
+              </a:defRPr>
+            </a:lvl2pPr>
+            <a:lvl3pPr marL="914400" algn="l" defTabSz="914400" rtl="0" eaLnBrk="1" latinLnBrk="0" hangingPunct="1">
+              <a:defRPr sz="1800" kern="1200">
+                <a:solidFill>
+                  <a:schemeClr val="tx1"/>
+                </a:solidFill>
+                <a:latin typeface="+mn-lt"/>
+                <a:ea typeface="+mn-ea"/>
+                <a:cs typeface="+mn-cs"/>
+              </a:defRPr>
+            </a:lvl3pPr>
+            <a:lvl4pPr marL="1371600" algn="l" defTabSz="914400" rtl="0" eaLnBrk="1" latinLnBrk="0" hangingPunct="1">
+              <a:defRPr sz="1800" kern="1200">
+                <a:solidFill>
+                  <a:schemeClr val="tx1"/>
+                </a:solidFill>
+                <a:latin typeface="+mn-lt"/>
+                <a:ea typeface="+mn-ea"/>
+                <a:cs typeface="+mn-cs"/>
+              </a:defRPr>
+            </a:lvl4pPr>
+            <a:lvl5pPr marL="1828800" algn="l" defTabSz="914400" rtl="0" eaLnBrk="1" latinLnBrk="0" hangingPunct="1">
+              <a:defRPr sz="1800" kern="1200">
+                <a:solidFill>
+                  <a:schemeClr val="tx1"/>
+                </a:solidFill>
+                <a:latin typeface="+mn-lt"/>
+                <a:ea typeface="+mn-ea"/>
+                <a:cs typeface="+mn-cs"/>
+              </a:defRPr>
+            </a:lvl5pPr>
+            <a:lvl6pPr marL="2286000" algn="l" defTabSz="914400" rtl="0" eaLnBrk="1" latinLnBrk="0" hangingPunct="1">
+              <a:defRPr sz="1800" kern="1200">
+                <a:solidFill>
+                  <a:schemeClr val="tx1"/>
+                </a:solidFill>
+                <a:latin typeface="+mn-lt"/>
+                <a:ea typeface="+mn-ea"/>
+                <a:cs typeface="+mn-cs"/>
+              </a:defRPr>
+            </a:lvl6pPr>
+            <a:lvl7pPr marL="2743200" algn="l" defTabSz="914400" rtl="0" eaLnBrk="1" latinLnBrk="0" hangingPunct="1">
+              <a:defRPr sz="1800" kern="1200">
+                <a:solidFill>
+                  <a:schemeClr val="tx1"/>
+                </a:solidFill>
+                <a:latin typeface="+mn-lt"/>
+                <a:ea typeface="+mn-ea"/>
+                <a:cs typeface="+mn-cs"/>
+              </a:defRPr>
+            </a:lvl7pPr>
+            <a:lvl8pPr marL="3200400" algn="l" defTabSz="914400" rtl="0" eaLnBrk="1" latinLnBrk="0" hangingPunct="1">
+              <a:defRPr sz="1800" kern="1200">
+                <a:solidFill>
+                  <a:schemeClr val="tx1"/>
+                </a:solidFill>
+                <a:latin typeface="+mn-lt"/>
+                <a:ea typeface="+mn-ea"/>
+                <a:cs typeface="+mn-cs"/>
+              </a:defRPr>
+            </a:lvl8pPr>
+            <a:lvl9pPr marL="3657600" algn="l" defTabSz="914400" rtl="0" eaLnBrk="1" latinLnBrk="0" hangingPunct="1">
+              <a:defRPr sz="1800" kern="1200">
+                <a:solidFill>
+                  <a:schemeClr val="tx1"/>
+                </a:solidFill>
+                <a:latin typeface="+mn-lt"/>
+                <a:ea typeface="+mn-ea"/>
+                <a:cs typeface="+mn-cs"/>
+              </a:defRPr>
+            </a:lvl9pPr>
+          </a:lstStyle>
+          <a:p>
+            <a:pPr algn="ctr" defTabSz="533400">
+              <a:lnSpc>
+                <a:spcPct val="90000"/>
+              </a:lnSpc>
+              <a:spcBef>
+                <a:spcPct val="0"/>
+              </a:spcBef>
+              <a:spcAft>
+                <a:spcPct val="35000"/>
+              </a:spcAft>
+            </a:pPr>
+            <a:r>
+              <a:rPr lang="en-US" b="1" dirty="0">
+                <a:solidFill>
+                  <a:srgbClr val="44546A"/>
+                </a:solidFill>
+                <a:cs typeface="Segoe UI Light" panose="020B0502040204020203" pitchFamily="34" charset="0"/>
+              </a:rPr>
+              <a:t>Backend</a:t>
+            </a:r>
+            <a:endParaRPr lang="en-US" b="1" noProof="0" dirty="0">
+              <a:solidFill>
+                <a:srgbClr val="44546A"/>
+              </a:solidFill>
+              <a:cs typeface="Segoe UI Light" panose="020B0502040204020203" pitchFamily="34" charset="0"/>
+            </a:endParaRPr>
+          </a:p>
+        </p:txBody>
+      </p:sp>
+      <p:sp>
+        <p:nvSpPr>
+          <p:cNvPr id="25" name="Mobilisation &amp; Inputs Gathering">
+            <a:extLst>
+              <a:ext uri="{FF2B5EF4-FFF2-40B4-BE49-F238E27FC236}">
+                <a16:creationId xmlns:a16="http://schemas.microsoft.com/office/drawing/2014/main" id="{D49C4E0E-E805-D74D-B852-65ABA4066821}"/>
+              </a:ext>
+            </a:extLst>
+          </p:cNvPr>
+          <p:cNvSpPr txBox="1"/>
+          <p:nvPr/>
+        </p:nvSpPr>
+        <p:spPr>
+          <a:xfrm>
+            <a:off x="703031" y="4391119"/>
+            <a:ext cx="3448683" cy="441800"/>
+          </a:xfrm>
+          <a:prstGeom prst="rect">
+            <a:avLst/>
+          </a:prstGeom>
+          <a:noFill/>
+          <a:ln w="12700" cap="flat">
+            <a:noFill/>
+            <a:miter lim="400000"/>
+          </a:ln>
+          <a:effectLst/>
+          <a:extLst>
+            <a:ext uri="{C572A759-6A51-4108-AA02-DFA0A04FC94B}">
+              <ma14:wrappingTextBoxFlag xmlns="" xmlns:m="http://schemas.openxmlformats.org/officeDocument/2006/math" xmlns:a14="http://schemas.microsoft.com/office/drawing/2010/main" xmlns:ma14="http://schemas.microsoft.com/office/mac/drawingml/2011/main" xmlns:lc="http://schemas.openxmlformats.org/drawingml/2006/lockedCanvas" val="1"/>
+            </a:ext>
+          </a:extLst>
+        </p:spPr>
+        <p:txBody>
+          <a:bodyPr wrap="square" lIns="35719" tIns="35719" rIns="35719" bIns="35719" numCol="1" anchor="t">
+            <a:noAutofit/>
+          </a:bodyPr>
+          <a:lstStyle>
+            <a:defPPr>
+              <a:defRPr lang="en-US"/>
+            </a:defPPr>
+            <a:lvl1pPr marL="0" algn="l" defTabSz="914400" rtl="0" eaLnBrk="1" latinLnBrk="0" hangingPunct="1">
+              <a:defRPr sz="1800" kern="1200">
+                <a:solidFill>
+                  <a:schemeClr val="tx1"/>
+                </a:solidFill>
+                <a:latin typeface="+mn-lt"/>
+                <a:ea typeface="+mn-ea"/>
+                <a:cs typeface="+mn-cs"/>
+              </a:defRPr>
+            </a:lvl1pPr>
+            <a:lvl2pPr marL="457200" algn="l" defTabSz="914400" rtl="0" eaLnBrk="1" latinLnBrk="0" hangingPunct="1">
+              <a:defRPr sz="1800" kern="1200">
+                <a:solidFill>
+                  <a:schemeClr val="tx1"/>
+                </a:solidFill>
+                <a:latin typeface="+mn-lt"/>
+                <a:ea typeface="+mn-ea"/>
+                <a:cs typeface="+mn-cs"/>
+              </a:defRPr>
+            </a:lvl2pPr>
+            <a:lvl3pPr marL="914400" algn="l" defTabSz="914400" rtl="0" eaLnBrk="1" latinLnBrk="0" hangingPunct="1">
+              <a:defRPr sz="1800" kern="1200">
+                <a:solidFill>
+                  <a:schemeClr val="tx1"/>
+                </a:solidFill>
+                <a:latin typeface="+mn-lt"/>
+                <a:ea typeface="+mn-ea"/>
+                <a:cs typeface="+mn-cs"/>
+              </a:defRPr>
+            </a:lvl3pPr>
+            <a:lvl4pPr marL="1371600" algn="l" defTabSz="914400" rtl="0" eaLnBrk="1" latinLnBrk="0" hangingPunct="1">
+              <a:defRPr sz="1800" kern="1200">
+                <a:solidFill>
+                  <a:schemeClr val="tx1"/>
+                </a:solidFill>
+                <a:latin typeface="+mn-lt"/>
+                <a:ea typeface="+mn-ea"/>
+                <a:cs typeface="+mn-cs"/>
+              </a:defRPr>
+            </a:lvl4pPr>
+            <a:lvl5pPr marL="1828800" algn="l" defTabSz="914400" rtl="0" eaLnBrk="1" latinLnBrk="0" hangingPunct="1">
+              <a:defRPr sz="1800" kern="1200">
+                <a:solidFill>
+                  <a:schemeClr val="tx1"/>
+                </a:solidFill>
+                <a:latin typeface="+mn-lt"/>
+                <a:ea typeface="+mn-ea"/>
+                <a:cs typeface="+mn-cs"/>
+              </a:defRPr>
+            </a:lvl5pPr>
+            <a:lvl6pPr marL="2286000" algn="l" defTabSz="914400" rtl="0" eaLnBrk="1" latinLnBrk="0" hangingPunct="1">
+              <a:defRPr sz="1800" kern="1200">
+                <a:solidFill>
+                  <a:schemeClr val="tx1"/>
+                </a:solidFill>
+                <a:latin typeface="+mn-lt"/>
+                <a:ea typeface="+mn-ea"/>
+                <a:cs typeface="+mn-cs"/>
+              </a:defRPr>
+            </a:lvl6pPr>
+            <a:lvl7pPr marL="2743200" algn="l" defTabSz="914400" rtl="0" eaLnBrk="1" latinLnBrk="0" hangingPunct="1">
+              <a:defRPr sz="1800" kern="1200">
+                <a:solidFill>
+                  <a:schemeClr val="tx1"/>
+                </a:solidFill>
+                <a:latin typeface="+mn-lt"/>
+                <a:ea typeface="+mn-ea"/>
+                <a:cs typeface="+mn-cs"/>
+              </a:defRPr>
+            </a:lvl7pPr>
+            <a:lvl8pPr marL="3200400" algn="l" defTabSz="914400" rtl="0" eaLnBrk="1" latinLnBrk="0" hangingPunct="1">
+              <a:defRPr sz="1800" kern="1200">
+                <a:solidFill>
+                  <a:schemeClr val="tx1"/>
+                </a:solidFill>
+                <a:latin typeface="+mn-lt"/>
+                <a:ea typeface="+mn-ea"/>
+                <a:cs typeface="+mn-cs"/>
+              </a:defRPr>
+            </a:lvl8pPr>
+            <a:lvl9pPr marL="3657600" algn="l" defTabSz="914400" rtl="0" eaLnBrk="1" latinLnBrk="0" hangingPunct="1">
+              <a:defRPr sz="1800" kern="1200">
+                <a:solidFill>
+                  <a:schemeClr val="tx1"/>
+                </a:solidFill>
+                <a:latin typeface="+mn-lt"/>
+                <a:ea typeface="+mn-ea"/>
+                <a:cs typeface="+mn-cs"/>
+              </a:defRPr>
+            </a:lvl9pPr>
+          </a:lstStyle>
+          <a:p>
+            <a:endParaRPr lang="fr-BE" sz="1500" b="1" dirty="0">
+              <a:solidFill>
+                <a:schemeClr val="accent1"/>
+              </a:solidFill>
+              <a:cs typeface="Segoe UI Light" panose="020B0502040204020203" pitchFamily="34" charset="0"/>
+            </a:endParaRPr>
+          </a:p>
+        </p:txBody>
+      </p:sp>
+      <p:sp>
+        <p:nvSpPr>
+          <p:cNvPr id="9" name="TextBox 8">
+            <a:extLst>
+              <a:ext uri="{FF2B5EF4-FFF2-40B4-BE49-F238E27FC236}">
+                <a16:creationId xmlns:a16="http://schemas.microsoft.com/office/drawing/2014/main" id="{8AE4E8BE-4F65-20E1-F50F-8EB6DF745B54}"/>
+              </a:ext>
+            </a:extLst>
+          </p:cNvPr>
+          <p:cNvSpPr txBox="1"/>
+          <p:nvPr/>
+        </p:nvSpPr>
+        <p:spPr>
+          <a:xfrm>
+            <a:off x="713189" y="4443009"/>
+            <a:ext cx="3723639" cy="584775"/>
+          </a:xfrm>
+          <a:prstGeom prst="rect">
+            <a:avLst/>
+          </a:prstGeom>
+          <a:noFill/>
+        </p:spPr>
+        <p:txBody>
+          <a:bodyPr wrap="square">
+            <a:spAutoFit/>
+          </a:bodyPr>
+          <a:lstStyle/>
+          <a:p>
+            <a:r>
+              <a:rPr lang="en-US" sz="1600" dirty="0">
+                <a:solidFill>
+                  <a:srgbClr val="0563C1"/>
+                </a:solidFill>
+                <a:hlinkClick r:id="rId5"/>
+              </a:rPr>
+              <a:t>https://realestate-api.azurewebsites.net/docs</a:t>
+            </a:r>
+            <a:endParaRPr lang="en-US" sz="1600" dirty="0">
+              <a:solidFill>
+                <a:srgbClr val="0563C1"/>
+              </a:solidFill>
+            </a:endParaRPr>
+          </a:p>
+        </p:txBody>
+      </p:sp>
+      <p:sp>
+        <p:nvSpPr>
+          <p:cNvPr id="27" name="Line">
+            <a:extLst>
+              <a:ext uri="{FF2B5EF4-FFF2-40B4-BE49-F238E27FC236}">
+                <a16:creationId xmlns:a16="http://schemas.microsoft.com/office/drawing/2014/main" id="{07D47131-2D5B-60E5-F721-4AF05730FECD}"/>
+              </a:ext>
+            </a:extLst>
+          </p:cNvPr>
+          <p:cNvSpPr/>
+          <p:nvPr/>
+        </p:nvSpPr>
+        <p:spPr>
+          <a:xfrm>
+            <a:off x="540703" y="4245938"/>
+            <a:ext cx="3554412" cy="0"/>
+          </a:xfrm>
+          <a:prstGeom prst="line">
+            <a:avLst/>
+          </a:prstGeom>
+          <a:noFill/>
+          <a:ln w="50800" cap="flat">
+            <a:solidFill>
+              <a:srgbClr val="FFB310"/>
+            </a:solidFill>
+            <a:prstDash val="solid"/>
+            <a:miter lim="400000"/>
+          </a:ln>
+          <a:effectLst/>
+        </p:spPr>
+        <p:txBody>
+          <a:bodyPr wrap="square" lIns="0" tIns="0" rIns="0" bIns="0" numCol="1" anchor="ctr">
+            <a:noAutofit/>
+          </a:bodyPr>
+          <a:lstStyle>
+            <a:defPPr>
+              <a:defRPr lang="en-US"/>
+            </a:defPPr>
+            <a:lvl1pPr marL="0" algn="l" defTabSz="914400" rtl="0" eaLnBrk="1" latinLnBrk="0" hangingPunct="1">
+              <a:defRPr sz="1800" kern="1200">
+                <a:solidFill>
+                  <a:schemeClr val="tx1"/>
+                </a:solidFill>
+                <a:latin typeface="+mn-lt"/>
+                <a:ea typeface="+mn-ea"/>
+                <a:cs typeface="+mn-cs"/>
+              </a:defRPr>
+            </a:lvl1pPr>
+            <a:lvl2pPr marL="457200" algn="l" defTabSz="914400" rtl="0" eaLnBrk="1" latinLnBrk="0" hangingPunct="1">
+              <a:defRPr sz="1800" kern="1200">
+                <a:solidFill>
+                  <a:schemeClr val="tx1"/>
+                </a:solidFill>
+                <a:latin typeface="+mn-lt"/>
+                <a:ea typeface="+mn-ea"/>
+                <a:cs typeface="+mn-cs"/>
+              </a:defRPr>
+            </a:lvl2pPr>
+            <a:lvl3pPr marL="914400" algn="l" defTabSz="914400" rtl="0" eaLnBrk="1" latinLnBrk="0" hangingPunct="1">
+              <a:defRPr sz="1800" kern="1200">
+                <a:solidFill>
+                  <a:schemeClr val="tx1"/>
+                </a:solidFill>
+                <a:latin typeface="+mn-lt"/>
+                <a:ea typeface="+mn-ea"/>
+                <a:cs typeface="+mn-cs"/>
+              </a:defRPr>
+            </a:lvl3pPr>
+            <a:lvl4pPr marL="1371600" algn="l" defTabSz="914400" rtl="0" eaLnBrk="1" latinLnBrk="0" hangingPunct="1">
+              <a:defRPr sz="1800" kern="1200">
+                <a:solidFill>
+                  <a:schemeClr val="tx1"/>
+                </a:solidFill>
+                <a:latin typeface="+mn-lt"/>
+                <a:ea typeface="+mn-ea"/>
+                <a:cs typeface="+mn-cs"/>
+              </a:defRPr>
+            </a:lvl4pPr>
+            <a:lvl5pPr marL="1828800" algn="l" defTabSz="914400" rtl="0" eaLnBrk="1" latinLnBrk="0" hangingPunct="1">
+              <a:defRPr sz="1800" kern="1200">
+                <a:solidFill>
+                  <a:schemeClr val="tx1"/>
+                </a:solidFill>
+                <a:latin typeface="+mn-lt"/>
+                <a:ea typeface="+mn-ea"/>
+                <a:cs typeface="+mn-cs"/>
+              </a:defRPr>
+            </a:lvl5pPr>
+            <a:lvl6pPr marL="2286000" algn="l" defTabSz="914400" rtl="0" eaLnBrk="1" latinLnBrk="0" hangingPunct="1">
+              <a:defRPr sz="1800" kern="1200">
+                <a:solidFill>
+                  <a:schemeClr val="tx1"/>
+                </a:solidFill>
+                <a:latin typeface="+mn-lt"/>
+                <a:ea typeface="+mn-ea"/>
+                <a:cs typeface="+mn-cs"/>
+              </a:defRPr>
+            </a:lvl6pPr>
+            <a:lvl7pPr marL="2743200" algn="l" defTabSz="914400" rtl="0" eaLnBrk="1" latinLnBrk="0" hangingPunct="1">
+              <a:defRPr sz="1800" kern="1200">
+                <a:solidFill>
+                  <a:schemeClr val="tx1"/>
+                </a:solidFill>
+                <a:latin typeface="+mn-lt"/>
+                <a:ea typeface="+mn-ea"/>
+                <a:cs typeface="+mn-cs"/>
+              </a:defRPr>
+            </a:lvl7pPr>
+            <a:lvl8pPr marL="3200400" algn="l" defTabSz="914400" rtl="0" eaLnBrk="1" latinLnBrk="0" hangingPunct="1">
+              <a:defRPr sz="1800" kern="1200">
+                <a:solidFill>
+                  <a:schemeClr val="tx1"/>
+                </a:solidFill>
+                <a:latin typeface="+mn-lt"/>
+                <a:ea typeface="+mn-ea"/>
+                <a:cs typeface="+mn-cs"/>
+              </a:defRPr>
+            </a:lvl8pPr>
+            <a:lvl9pPr marL="3657600" algn="l" defTabSz="914400" rtl="0" eaLnBrk="1" latinLnBrk="0" hangingPunct="1">
+              <a:defRPr sz="1800" kern="1200">
+                <a:solidFill>
+                  <a:schemeClr val="tx1"/>
+                </a:solidFill>
+                <a:latin typeface="+mn-lt"/>
+                <a:ea typeface="+mn-ea"/>
+                <a:cs typeface="+mn-cs"/>
+              </a:defRPr>
+            </a:lvl9pPr>
+          </a:lstStyle>
+          <a:p>
+            <a:pPr marL="0" marR="0" lvl="0" indent="0" algn="ctr" defTabSz="410766" rtl="0" eaLnBrk="1" fontAlgn="auto" latinLnBrk="0" hangingPunct="0">
+              <a:lnSpc>
+                <a:spcPct val="100000"/>
+              </a:lnSpc>
+              <a:spcBef>
+                <a:spcPts val="0"/>
+              </a:spcBef>
+              <a:spcAft>
+                <a:spcPts val="0"/>
+              </a:spcAft>
+              <a:buClrTx/>
+              <a:buSzTx/>
+              <a:buFontTx/>
+              <a:buNone/>
+              <a:tabLst/>
+              <a:defRPr sz="3000" b="1">
+                <a:solidFill>
+                  <a:srgbClr val="FFFFFF"/>
+                </a:solidFill>
+              </a:defRPr>
+            </a:pPr>
+            <a:endParaRPr kumimoji="0" lang="en-US" sz="1200" b="1" i="0" u="none" strike="noStrike" kern="0" cap="none" spc="0" normalizeH="0" baseline="0" noProof="0" dirty="0">
+              <a:ln>
+                <a:noFill/>
+              </a:ln>
+              <a:solidFill>
+                <a:srgbClr val="44546A"/>
+              </a:solidFill>
+              <a:effectLst/>
+              <a:uLnTx/>
+              <a:uFillTx/>
+              <a:ea typeface="+mn-ea"/>
+              <a:cs typeface="Segoe UI"/>
+              <a:sym typeface="Segoe UI"/>
+            </a:endParaRPr>
+          </a:p>
+        </p:txBody>
+      </p:sp>
+    </p:spTree>
+    <p:extLst>
+      <p:ext uri="{BB962C8B-B14F-4D97-AF65-F5344CB8AC3E}">
+        <p14:creationId xmlns:p14="http://schemas.microsoft.com/office/powerpoint/2010/main" val="480256601"/>
+      </p:ext>
+    </p:extLst>
+  </p:cSld>
+  <p:clrMapOvr>
+    <a:masterClrMapping/>
+  </p:clrMapOvr>
+</p:sld>
+</file>
+
+<file path=ppt/slides/slide4.xml><?xml version="1.0" encoding="utf-8"?>
 <p:sld xmlns:a="http://schemas.openxmlformats.org/drawingml/2006/main" xmlns:r="http://schemas.openxmlformats.org/officeDocument/2006/relationships" xmlns:p="http://schemas.openxmlformats.org/presentationml/2006/main">
   <p:cSld>
     <p:spTree>
@@ -18804,7 +20361,7 @@
           <a:effectLst/>
           <a:extLst>
             <a:ext uri="{C572A759-6A51-4108-AA02-DFA0A04FC94B}">
-              <ma14:wrappingTextBoxFlag xmlns:lc="http://schemas.openxmlformats.org/drawingml/2006/lockedCanvas" xmlns:ma14="http://schemas.microsoft.com/office/mac/drawingml/2011/main" xmlns:a14="http://schemas.microsoft.com/office/drawing/2010/main" xmlns:m="http://schemas.openxmlformats.org/officeDocument/2006/math" xmlns="" val="1"/>
+              <ma14:wrappingTextBoxFlag xmlns="" xmlns:m="http://schemas.openxmlformats.org/officeDocument/2006/math" xmlns:a14="http://schemas.microsoft.com/office/drawing/2010/main" xmlns:ma14="http://schemas.microsoft.com/office/mac/drawingml/2011/main" xmlns:lc="http://schemas.openxmlformats.org/drawingml/2006/lockedCanvas" val="1"/>
             </a:ext>
           </a:extLst>
         </p:spPr>
@@ -19127,7 +20684,7 @@
           <a:effectLst/>
           <a:extLst>
             <a:ext uri="{C572A759-6A51-4108-AA02-DFA0A04FC94B}">
-              <ma14:wrappingTextBoxFlag xmlns:lc="http://schemas.openxmlformats.org/drawingml/2006/lockedCanvas" xmlns:ma14="http://schemas.microsoft.com/office/mac/drawingml/2011/main" xmlns:a14="http://schemas.microsoft.com/office/drawing/2010/main" xmlns:m="http://schemas.openxmlformats.org/officeDocument/2006/math" xmlns="" val="1"/>
+              <ma14:wrappingTextBoxFlag xmlns="" xmlns:m="http://schemas.openxmlformats.org/officeDocument/2006/math" xmlns:a14="http://schemas.microsoft.com/office/drawing/2010/main" xmlns:ma14="http://schemas.microsoft.com/office/mac/drawingml/2011/main" xmlns:lc="http://schemas.openxmlformats.org/drawingml/2006/lockedCanvas" val="1"/>
             </a:ext>
           </a:extLst>
         </p:spPr>
@@ -19299,1536 +20856,6 @@
     <p:extLst>
       <p:ext uri="{BB962C8B-B14F-4D97-AF65-F5344CB8AC3E}">
         <p14:creationId xmlns:p14="http://schemas.microsoft.com/office/powerpoint/2010/main" val="170492021"/>
-      </p:ext>
-    </p:extLst>
-  </p:cSld>
-  <p:clrMapOvr>
-    <a:masterClrMapping/>
-  </p:clrMapOvr>
-</p:sld>
-</file>
-
-<file path=ppt/slides/slide4.xml><?xml version="1.0" encoding="utf-8"?>
-<p:sld xmlns:a="http://schemas.openxmlformats.org/drawingml/2006/main" xmlns:r="http://schemas.openxmlformats.org/officeDocument/2006/relationships" xmlns:p="http://schemas.openxmlformats.org/presentationml/2006/main">
-  <p:cSld>
-    <p:spTree>
-      <p:nvGrpSpPr>
-        <p:cNvPr id="1" name=""/>
-        <p:cNvGrpSpPr/>
-        <p:nvPr/>
-      </p:nvGrpSpPr>
-      <p:grpSpPr>
-        <a:xfrm>
-          <a:off x="0" y="0"/>
-          <a:ext cx="0" cy="0"/>
-          <a:chOff x="0" y="0"/>
-          <a:chExt cx="0" cy="0"/>
-        </a:xfrm>
-      </p:grpSpPr>
-      <p:sp>
-        <p:nvSpPr>
-          <p:cNvPr id="2" name="Title 1">
-            <a:extLst>
-              <a:ext uri="{FF2B5EF4-FFF2-40B4-BE49-F238E27FC236}">
-                <a16:creationId xmlns:a16="http://schemas.microsoft.com/office/drawing/2014/main" id="{C3719F9F-3A80-9C62-8C83-36A8D3648506}"/>
-              </a:ext>
-            </a:extLst>
-          </p:cNvPr>
-          <p:cNvSpPr>
-            <a:spLocks noGrp="1"/>
-          </p:cNvSpPr>
-          <p:nvPr>
-            <p:ph type="title"/>
-          </p:nvPr>
-        </p:nvSpPr>
-        <p:spPr>
-          <a:xfrm>
-            <a:off x="515938" y="246621"/>
-            <a:ext cx="2852102" cy="612746"/>
-          </a:xfrm>
-        </p:spPr>
-        <p:txBody>
-          <a:bodyPr/>
-          <a:lstStyle/>
-          <a:p>
-            <a:r>
-              <a:rPr lang="en-US" dirty="0">
-                <a:solidFill>
-                  <a:schemeClr val="accent2"/>
-                </a:solidFill>
-              </a:rPr>
-              <a:t>Demo</a:t>
-            </a:r>
-          </a:p>
-        </p:txBody>
-      </p:sp>
-      <p:pic>
-        <p:nvPicPr>
-          <p:cNvPr id="6" name="Picture 5">
-            <a:extLst>
-              <a:ext uri="{FF2B5EF4-FFF2-40B4-BE49-F238E27FC236}">
-                <a16:creationId xmlns:a16="http://schemas.microsoft.com/office/drawing/2014/main" id="{9E233DAD-8357-704B-8905-F662BC82E1D7}"/>
-              </a:ext>
-            </a:extLst>
-          </p:cNvPr>
-          <p:cNvPicPr>
-            <a:picLocks noChangeAspect="1"/>
-          </p:cNvPicPr>
-          <p:nvPr/>
-        </p:nvPicPr>
-        <p:blipFill>
-          <a:blip r:embed="rId2"/>
-          <a:stretch>
-            <a:fillRect/>
-          </a:stretch>
-        </p:blipFill>
-        <p:spPr>
-          <a:xfrm>
-            <a:off x="4436829" y="109437"/>
-            <a:ext cx="4000617" cy="6466382"/>
-          </a:xfrm>
-          <a:prstGeom prst="rect">
-            <a:avLst/>
-          </a:prstGeom>
-        </p:spPr>
-      </p:pic>
-      <p:pic>
-        <p:nvPicPr>
-          <p:cNvPr id="17" name="Picture 16">
-            <a:extLst>
-              <a:ext uri="{FF2B5EF4-FFF2-40B4-BE49-F238E27FC236}">
-                <a16:creationId xmlns:a16="http://schemas.microsoft.com/office/drawing/2014/main" id="{8374262E-65CC-72AE-1AE5-AE7E8C32B6C2}"/>
-              </a:ext>
-            </a:extLst>
-          </p:cNvPr>
-          <p:cNvPicPr>
-            <a:picLocks noChangeAspect="1"/>
-          </p:cNvPicPr>
-          <p:nvPr/>
-        </p:nvPicPr>
-        <p:blipFill>
-          <a:blip r:embed="rId3"/>
-          <a:stretch>
-            <a:fillRect/>
-          </a:stretch>
-        </p:blipFill>
-        <p:spPr>
-          <a:xfrm>
-            <a:off x="8493325" y="190741"/>
-            <a:ext cx="3236394" cy="5136626"/>
-          </a:xfrm>
-          <a:prstGeom prst="rect">
-            <a:avLst/>
-          </a:prstGeom>
-        </p:spPr>
-      </p:pic>
-      <p:sp>
-        <p:nvSpPr>
-          <p:cNvPr id="18" name="Rounded Rectangle">
-            <a:extLst>
-              <a:ext uri="{FF2B5EF4-FFF2-40B4-BE49-F238E27FC236}">
-                <a16:creationId xmlns:a16="http://schemas.microsoft.com/office/drawing/2014/main" id="{7FDBD02B-FE4F-D658-ADEF-BA4E7D6A85E3}"/>
-              </a:ext>
-            </a:extLst>
-          </p:cNvPr>
-          <p:cNvSpPr/>
-          <p:nvPr/>
-        </p:nvSpPr>
-        <p:spPr>
-          <a:xfrm>
-            <a:off x="515938" y="1720654"/>
-            <a:ext cx="3554412" cy="1176288"/>
-          </a:xfrm>
-          <a:prstGeom prst="roundRect">
-            <a:avLst>
-              <a:gd name="adj" fmla="val 3067"/>
-            </a:avLst>
-          </a:prstGeom>
-          <a:solidFill>
-            <a:schemeClr val="bg1">
-              <a:alpha val="87000"/>
-            </a:schemeClr>
-          </a:solidFill>
-          <a:ln w="12700" cap="flat">
-            <a:noFill/>
-            <a:miter lim="400000"/>
-          </a:ln>
-          <a:effectLst>
-            <a:outerShdw blurRad="952500" dist="444500" dir="5400000" rotWithShape="0">
-              <a:srgbClr val="000000">
-                <a:alpha val="15000"/>
-              </a:srgbClr>
-            </a:outerShdw>
-          </a:effectLst>
-        </p:spPr>
-        <p:txBody>
-          <a:bodyPr wrap="square" lIns="0" tIns="0" rIns="0" bIns="0" numCol="1" anchor="ctr">
-            <a:noAutofit/>
-          </a:bodyPr>
-          <a:lstStyle>
-            <a:defPPr>
-              <a:defRPr lang="en-US"/>
-            </a:defPPr>
-            <a:lvl1pPr marL="0" algn="l" defTabSz="914400" rtl="0" eaLnBrk="1" latinLnBrk="0" hangingPunct="1">
-              <a:defRPr sz="1800" kern="1200">
-                <a:solidFill>
-                  <a:schemeClr val="tx1"/>
-                </a:solidFill>
-                <a:latin typeface="+mn-lt"/>
-                <a:ea typeface="+mn-ea"/>
-                <a:cs typeface="+mn-cs"/>
-              </a:defRPr>
-            </a:lvl1pPr>
-            <a:lvl2pPr marL="457200" algn="l" defTabSz="914400" rtl="0" eaLnBrk="1" latinLnBrk="0" hangingPunct="1">
-              <a:defRPr sz="1800" kern="1200">
-                <a:solidFill>
-                  <a:schemeClr val="tx1"/>
-                </a:solidFill>
-                <a:latin typeface="+mn-lt"/>
-                <a:ea typeface="+mn-ea"/>
-                <a:cs typeface="+mn-cs"/>
-              </a:defRPr>
-            </a:lvl2pPr>
-            <a:lvl3pPr marL="914400" algn="l" defTabSz="914400" rtl="0" eaLnBrk="1" latinLnBrk="0" hangingPunct="1">
-              <a:defRPr sz="1800" kern="1200">
-                <a:solidFill>
-                  <a:schemeClr val="tx1"/>
-                </a:solidFill>
-                <a:latin typeface="+mn-lt"/>
-                <a:ea typeface="+mn-ea"/>
-                <a:cs typeface="+mn-cs"/>
-              </a:defRPr>
-            </a:lvl3pPr>
-            <a:lvl4pPr marL="1371600" algn="l" defTabSz="914400" rtl="0" eaLnBrk="1" latinLnBrk="0" hangingPunct="1">
-              <a:defRPr sz="1800" kern="1200">
-                <a:solidFill>
-                  <a:schemeClr val="tx1"/>
-                </a:solidFill>
-                <a:latin typeface="+mn-lt"/>
-                <a:ea typeface="+mn-ea"/>
-                <a:cs typeface="+mn-cs"/>
-              </a:defRPr>
-            </a:lvl4pPr>
-            <a:lvl5pPr marL="1828800" algn="l" defTabSz="914400" rtl="0" eaLnBrk="1" latinLnBrk="0" hangingPunct="1">
-              <a:defRPr sz="1800" kern="1200">
-                <a:solidFill>
-                  <a:schemeClr val="tx1"/>
-                </a:solidFill>
-                <a:latin typeface="+mn-lt"/>
-                <a:ea typeface="+mn-ea"/>
-                <a:cs typeface="+mn-cs"/>
-              </a:defRPr>
-            </a:lvl5pPr>
-            <a:lvl6pPr marL="2286000" algn="l" defTabSz="914400" rtl="0" eaLnBrk="1" latinLnBrk="0" hangingPunct="1">
-              <a:defRPr sz="1800" kern="1200">
-                <a:solidFill>
-                  <a:schemeClr val="tx1"/>
-                </a:solidFill>
-                <a:latin typeface="+mn-lt"/>
-                <a:ea typeface="+mn-ea"/>
-                <a:cs typeface="+mn-cs"/>
-              </a:defRPr>
-            </a:lvl6pPr>
-            <a:lvl7pPr marL="2743200" algn="l" defTabSz="914400" rtl="0" eaLnBrk="1" latinLnBrk="0" hangingPunct="1">
-              <a:defRPr sz="1800" kern="1200">
-                <a:solidFill>
-                  <a:schemeClr val="tx1"/>
-                </a:solidFill>
-                <a:latin typeface="+mn-lt"/>
-                <a:ea typeface="+mn-ea"/>
-                <a:cs typeface="+mn-cs"/>
-              </a:defRPr>
-            </a:lvl7pPr>
-            <a:lvl8pPr marL="3200400" algn="l" defTabSz="914400" rtl="0" eaLnBrk="1" latinLnBrk="0" hangingPunct="1">
-              <a:defRPr sz="1800" kern="1200">
-                <a:solidFill>
-                  <a:schemeClr val="tx1"/>
-                </a:solidFill>
-                <a:latin typeface="+mn-lt"/>
-                <a:ea typeface="+mn-ea"/>
-                <a:cs typeface="+mn-cs"/>
-              </a:defRPr>
-            </a:lvl8pPr>
-            <a:lvl9pPr marL="3657600" algn="l" defTabSz="914400" rtl="0" eaLnBrk="1" latinLnBrk="0" hangingPunct="1">
-              <a:defRPr sz="1800" kern="1200">
-                <a:solidFill>
-                  <a:schemeClr val="tx1"/>
-                </a:solidFill>
-                <a:latin typeface="+mn-lt"/>
-                <a:ea typeface="+mn-ea"/>
-                <a:cs typeface="+mn-cs"/>
-              </a:defRPr>
-            </a:lvl9pPr>
-          </a:lstStyle>
-          <a:p>
-            <a:pPr marL="0" marR="0" lvl="0" indent="0" algn="ctr" defTabSz="410766" rtl="0" eaLnBrk="1" fontAlgn="auto" latinLnBrk="0" hangingPunct="0">
-              <a:lnSpc>
-                <a:spcPct val="100000"/>
-              </a:lnSpc>
-              <a:spcBef>
-                <a:spcPts val="0"/>
-              </a:spcBef>
-              <a:spcAft>
-                <a:spcPts val="0"/>
-              </a:spcAft>
-              <a:buClrTx/>
-              <a:buSzTx/>
-              <a:buFontTx/>
-              <a:buNone/>
-              <a:tabLst/>
-              <a:defRPr sz="3000" b="1">
-                <a:solidFill>
-                  <a:srgbClr val="FFFFFF"/>
-                </a:solidFill>
-              </a:defRPr>
-            </a:pPr>
-            <a:endParaRPr kumimoji="0" lang="fr-BE" sz="1500" b="1" i="0" u="none" strike="noStrike" kern="0" cap="none" spc="0" normalizeH="0" baseline="0" noProof="0" dirty="0">
-              <a:ln>
-                <a:noFill/>
-              </a:ln>
-              <a:solidFill>
-                <a:srgbClr val="44546A"/>
-              </a:solidFill>
-              <a:effectLst/>
-              <a:uLnTx/>
-              <a:uFillTx/>
-              <a:ea typeface="+mn-ea"/>
-              <a:cs typeface="Segoe UI"/>
-              <a:sym typeface="Segoe UI"/>
-            </a:endParaRPr>
-          </a:p>
-        </p:txBody>
-      </p:sp>
-      <p:sp>
-        <p:nvSpPr>
-          <p:cNvPr id="19" name="Mobilisation &amp; Inputs Gathering">
-            <a:extLst>
-              <a:ext uri="{FF2B5EF4-FFF2-40B4-BE49-F238E27FC236}">
-                <a16:creationId xmlns:a16="http://schemas.microsoft.com/office/drawing/2014/main" id="{E2F21825-3163-64F2-FA92-2DBC00DFE8DA}"/>
-              </a:ext>
-            </a:extLst>
-          </p:cNvPr>
-          <p:cNvSpPr txBox="1"/>
-          <p:nvPr/>
-        </p:nvSpPr>
-        <p:spPr>
-          <a:xfrm>
-            <a:off x="515937" y="1798739"/>
-            <a:ext cx="3554411" cy="377910"/>
-          </a:xfrm>
-          <a:prstGeom prst="rect">
-            <a:avLst/>
-          </a:prstGeom>
-          <a:noFill/>
-          <a:ln w="12700" cap="flat">
-            <a:noFill/>
-            <a:miter lim="400000"/>
-          </a:ln>
-          <a:effectLst/>
-          <a:extLst>
-            <a:ext uri="{C572A759-6A51-4108-AA02-DFA0A04FC94B}">
-              <ma14:wrappingTextBoxFlag xmlns:lc="http://schemas.openxmlformats.org/drawingml/2006/lockedCanvas" xmlns:ma14="http://schemas.microsoft.com/office/mac/drawingml/2011/main" xmlns:a14="http://schemas.microsoft.com/office/drawing/2010/main" xmlns:m="http://schemas.openxmlformats.org/officeDocument/2006/math" xmlns="" val="1"/>
-            </a:ext>
-          </a:extLst>
-        </p:spPr>
-        <p:txBody>
-          <a:bodyPr wrap="square" lIns="35719" tIns="35719" rIns="35719" bIns="35719" numCol="1" anchor="t">
-            <a:noAutofit/>
-          </a:bodyPr>
-          <a:lstStyle>
-            <a:defPPr>
-              <a:defRPr lang="en-US"/>
-            </a:defPPr>
-            <a:lvl1pPr marL="0" algn="l" defTabSz="914400" rtl="0" eaLnBrk="1" latinLnBrk="0" hangingPunct="1">
-              <a:defRPr sz="1800" kern="1200">
-                <a:solidFill>
-                  <a:schemeClr val="tx1"/>
-                </a:solidFill>
-                <a:latin typeface="+mn-lt"/>
-                <a:ea typeface="+mn-ea"/>
-                <a:cs typeface="+mn-cs"/>
-              </a:defRPr>
-            </a:lvl1pPr>
-            <a:lvl2pPr marL="457200" algn="l" defTabSz="914400" rtl="0" eaLnBrk="1" latinLnBrk="0" hangingPunct="1">
-              <a:defRPr sz="1800" kern="1200">
-                <a:solidFill>
-                  <a:schemeClr val="tx1"/>
-                </a:solidFill>
-                <a:latin typeface="+mn-lt"/>
-                <a:ea typeface="+mn-ea"/>
-                <a:cs typeface="+mn-cs"/>
-              </a:defRPr>
-            </a:lvl2pPr>
-            <a:lvl3pPr marL="914400" algn="l" defTabSz="914400" rtl="0" eaLnBrk="1" latinLnBrk="0" hangingPunct="1">
-              <a:defRPr sz="1800" kern="1200">
-                <a:solidFill>
-                  <a:schemeClr val="tx1"/>
-                </a:solidFill>
-                <a:latin typeface="+mn-lt"/>
-                <a:ea typeface="+mn-ea"/>
-                <a:cs typeface="+mn-cs"/>
-              </a:defRPr>
-            </a:lvl3pPr>
-            <a:lvl4pPr marL="1371600" algn="l" defTabSz="914400" rtl="0" eaLnBrk="1" latinLnBrk="0" hangingPunct="1">
-              <a:defRPr sz="1800" kern="1200">
-                <a:solidFill>
-                  <a:schemeClr val="tx1"/>
-                </a:solidFill>
-                <a:latin typeface="+mn-lt"/>
-                <a:ea typeface="+mn-ea"/>
-                <a:cs typeface="+mn-cs"/>
-              </a:defRPr>
-            </a:lvl4pPr>
-            <a:lvl5pPr marL="1828800" algn="l" defTabSz="914400" rtl="0" eaLnBrk="1" latinLnBrk="0" hangingPunct="1">
-              <a:defRPr sz="1800" kern="1200">
-                <a:solidFill>
-                  <a:schemeClr val="tx1"/>
-                </a:solidFill>
-                <a:latin typeface="+mn-lt"/>
-                <a:ea typeface="+mn-ea"/>
-                <a:cs typeface="+mn-cs"/>
-              </a:defRPr>
-            </a:lvl5pPr>
-            <a:lvl6pPr marL="2286000" algn="l" defTabSz="914400" rtl="0" eaLnBrk="1" latinLnBrk="0" hangingPunct="1">
-              <a:defRPr sz="1800" kern="1200">
-                <a:solidFill>
-                  <a:schemeClr val="tx1"/>
-                </a:solidFill>
-                <a:latin typeface="+mn-lt"/>
-                <a:ea typeface="+mn-ea"/>
-                <a:cs typeface="+mn-cs"/>
-              </a:defRPr>
-            </a:lvl6pPr>
-            <a:lvl7pPr marL="2743200" algn="l" defTabSz="914400" rtl="0" eaLnBrk="1" latinLnBrk="0" hangingPunct="1">
-              <a:defRPr sz="1800" kern="1200">
-                <a:solidFill>
-                  <a:schemeClr val="tx1"/>
-                </a:solidFill>
-                <a:latin typeface="+mn-lt"/>
-                <a:ea typeface="+mn-ea"/>
-                <a:cs typeface="+mn-cs"/>
-              </a:defRPr>
-            </a:lvl7pPr>
-            <a:lvl8pPr marL="3200400" algn="l" defTabSz="914400" rtl="0" eaLnBrk="1" latinLnBrk="0" hangingPunct="1">
-              <a:defRPr sz="1800" kern="1200">
-                <a:solidFill>
-                  <a:schemeClr val="tx1"/>
-                </a:solidFill>
-                <a:latin typeface="+mn-lt"/>
-                <a:ea typeface="+mn-ea"/>
-                <a:cs typeface="+mn-cs"/>
-              </a:defRPr>
-            </a:lvl8pPr>
-            <a:lvl9pPr marL="3657600" algn="l" defTabSz="914400" rtl="0" eaLnBrk="1" latinLnBrk="0" hangingPunct="1">
-              <a:defRPr sz="1800" kern="1200">
-                <a:solidFill>
-                  <a:schemeClr val="tx1"/>
-                </a:solidFill>
-                <a:latin typeface="+mn-lt"/>
-                <a:ea typeface="+mn-ea"/>
-                <a:cs typeface="+mn-cs"/>
-              </a:defRPr>
-            </a:lvl9pPr>
-          </a:lstStyle>
-          <a:p>
-            <a:pPr algn="ctr" defTabSz="533400">
-              <a:lnSpc>
-                <a:spcPct val="90000"/>
-              </a:lnSpc>
-              <a:spcBef>
-                <a:spcPct val="0"/>
-              </a:spcBef>
-              <a:spcAft>
-                <a:spcPct val="35000"/>
-              </a:spcAft>
-            </a:pPr>
-            <a:r>
-              <a:rPr lang="en-US" b="1" dirty="0">
-                <a:solidFill>
-                  <a:srgbClr val="44546A"/>
-                </a:solidFill>
-                <a:cs typeface="Segoe UI Light" panose="020B0502040204020203" pitchFamily="34" charset="0"/>
-              </a:rPr>
-              <a:t>Frontend</a:t>
-            </a:r>
-            <a:endParaRPr lang="en-US" b="1" noProof="0" dirty="0">
-              <a:solidFill>
-                <a:srgbClr val="44546A"/>
-              </a:solidFill>
-              <a:cs typeface="Segoe UI Light" panose="020B0502040204020203" pitchFamily="34" charset="0"/>
-            </a:endParaRPr>
-          </a:p>
-        </p:txBody>
-      </p:sp>
-      <p:sp>
-        <p:nvSpPr>
-          <p:cNvPr id="20" name="Line">
-            <a:extLst>
-              <a:ext uri="{FF2B5EF4-FFF2-40B4-BE49-F238E27FC236}">
-                <a16:creationId xmlns:a16="http://schemas.microsoft.com/office/drawing/2014/main" id="{D594B898-1FD0-751A-7D70-11322EF83D9E}"/>
-              </a:ext>
-            </a:extLst>
-          </p:cNvPr>
-          <p:cNvSpPr/>
-          <p:nvPr/>
-        </p:nvSpPr>
-        <p:spPr>
-          <a:xfrm>
-            <a:off x="515939" y="2182751"/>
-            <a:ext cx="3554412" cy="0"/>
-          </a:xfrm>
-          <a:prstGeom prst="line">
-            <a:avLst/>
-          </a:prstGeom>
-          <a:noFill/>
-          <a:ln w="50800" cap="flat">
-            <a:solidFill>
-              <a:srgbClr val="F94F00"/>
-            </a:solidFill>
-            <a:prstDash val="solid"/>
-            <a:miter lim="400000"/>
-          </a:ln>
-          <a:effectLst/>
-        </p:spPr>
-        <p:txBody>
-          <a:bodyPr wrap="square" lIns="0" tIns="0" rIns="0" bIns="0" numCol="1" anchor="ctr">
-            <a:noAutofit/>
-          </a:bodyPr>
-          <a:lstStyle>
-            <a:defPPr>
-              <a:defRPr lang="en-US"/>
-            </a:defPPr>
-            <a:lvl1pPr marL="0" algn="l" defTabSz="914400" rtl="0" eaLnBrk="1" latinLnBrk="0" hangingPunct="1">
-              <a:defRPr sz="1800" kern="1200">
-                <a:solidFill>
-                  <a:schemeClr val="tx1"/>
-                </a:solidFill>
-                <a:latin typeface="+mn-lt"/>
-                <a:ea typeface="+mn-ea"/>
-                <a:cs typeface="+mn-cs"/>
-              </a:defRPr>
-            </a:lvl1pPr>
-            <a:lvl2pPr marL="457200" algn="l" defTabSz="914400" rtl="0" eaLnBrk="1" latinLnBrk="0" hangingPunct="1">
-              <a:defRPr sz="1800" kern="1200">
-                <a:solidFill>
-                  <a:schemeClr val="tx1"/>
-                </a:solidFill>
-                <a:latin typeface="+mn-lt"/>
-                <a:ea typeface="+mn-ea"/>
-                <a:cs typeface="+mn-cs"/>
-              </a:defRPr>
-            </a:lvl2pPr>
-            <a:lvl3pPr marL="914400" algn="l" defTabSz="914400" rtl="0" eaLnBrk="1" latinLnBrk="0" hangingPunct="1">
-              <a:defRPr sz="1800" kern="1200">
-                <a:solidFill>
-                  <a:schemeClr val="tx1"/>
-                </a:solidFill>
-                <a:latin typeface="+mn-lt"/>
-                <a:ea typeface="+mn-ea"/>
-                <a:cs typeface="+mn-cs"/>
-              </a:defRPr>
-            </a:lvl3pPr>
-            <a:lvl4pPr marL="1371600" algn="l" defTabSz="914400" rtl="0" eaLnBrk="1" latinLnBrk="0" hangingPunct="1">
-              <a:defRPr sz="1800" kern="1200">
-                <a:solidFill>
-                  <a:schemeClr val="tx1"/>
-                </a:solidFill>
-                <a:latin typeface="+mn-lt"/>
-                <a:ea typeface="+mn-ea"/>
-                <a:cs typeface="+mn-cs"/>
-              </a:defRPr>
-            </a:lvl4pPr>
-            <a:lvl5pPr marL="1828800" algn="l" defTabSz="914400" rtl="0" eaLnBrk="1" latinLnBrk="0" hangingPunct="1">
-              <a:defRPr sz="1800" kern="1200">
-                <a:solidFill>
-                  <a:schemeClr val="tx1"/>
-                </a:solidFill>
-                <a:latin typeface="+mn-lt"/>
-                <a:ea typeface="+mn-ea"/>
-                <a:cs typeface="+mn-cs"/>
-              </a:defRPr>
-            </a:lvl5pPr>
-            <a:lvl6pPr marL="2286000" algn="l" defTabSz="914400" rtl="0" eaLnBrk="1" latinLnBrk="0" hangingPunct="1">
-              <a:defRPr sz="1800" kern="1200">
-                <a:solidFill>
-                  <a:schemeClr val="tx1"/>
-                </a:solidFill>
-                <a:latin typeface="+mn-lt"/>
-                <a:ea typeface="+mn-ea"/>
-                <a:cs typeface="+mn-cs"/>
-              </a:defRPr>
-            </a:lvl6pPr>
-            <a:lvl7pPr marL="2743200" algn="l" defTabSz="914400" rtl="0" eaLnBrk="1" latinLnBrk="0" hangingPunct="1">
-              <a:defRPr sz="1800" kern="1200">
-                <a:solidFill>
-                  <a:schemeClr val="tx1"/>
-                </a:solidFill>
-                <a:latin typeface="+mn-lt"/>
-                <a:ea typeface="+mn-ea"/>
-                <a:cs typeface="+mn-cs"/>
-              </a:defRPr>
-            </a:lvl7pPr>
-            <a:lvl8pPr marL="3200400" algn="l" defTabSz="914400" rtl="0" eaLnBrk="1" latinLnBrk="0" hangingPunct="1">
-              <a:defRPr sz="1800" kern="1200">
-                <a:solidFill>
-                  <a:schemeClr val="tx1"/>
-                </a:solidFill>
-                <a:latin typeface="+mn-lt"/>
-                <a:ea typeface="+mn-ea"/>
-                <a:cs typeface="+mn-cs"/>
-              </a:defRPr>
-            </a:lvl8pPr>
-            <a:lvl9pPr marL="3657600" algn="l" defTabSz="914400" rtl="0" eaLnBrk="1" latinLnBrk="0" hangingPunct="1">
-              <a:defRPr sz="1800" kern="1200">
-                <a:solidFill>
-                  <a:schemeClr val="tx1"/>
-                </a:solidFill>
-                <a:latin typeface="+mn-lt"/>
-                <a:ea typeface="+mn-ea"/>
-                <a:cs typeface="+mn-cs"/>
-              </a:defRPr>
-            </a:lvl9pPr>
-          </a:lstStyle>
-          <a:p>
-            <a:pPr marL="0" marR="0" lvl="0" indent="0" algn="ctr" defTabSz="410766" rtl="0" eaLnBrk="1" fontAlgn="auto" latinLnBrk="0" hangingPunct="0">
-              <a:lnSpc>
-                <a:spcPct val="100000"/>
-              </a:lnSpc>
-              <a:spcBef>
-                <a:spcPts val="0"/>
-              </a:spcBef>
-              <a:spcAft>
-                <a:spcPts val="0"/>
-              </a:spcAft>
-              <a:buClrTx/>
-              <a:buSzTx/>
-              <a:buFontTx/>
-              <a:buNone/>
-              <a:tabLst/>
-              <a:defRPr sz="3000" b="1">
-                <a:solidFill>
-                  <a:srgbClr val="FFFFFF"/>
-                </a:solidFill>
-              </a:defRPr>
-            </a:pPr>
-            <a:endParaRPr kumimoji="0" lang="en-US" sz="1200" b="1" i="0" u="none" strike="noStrike" kern="0" cap="none" spc="0" normalizeH="0" baseline="0" noProof="0" dirty="0">
-              <a:ln>
-                <a:noFill/>
-              </a:ln>
-              <a:solidFill>
-                <a:schemeClr val="accent1"/>
-              </a:solidFill>
-              <a:effectLst/>
-              <a:uLnTx/>
-              <a:uFillTx/>
-              <a:ea typeface="+mn-ea"/>
-              <a:cs typeface="Segoe UI"/>
-              <a:sym typeface="Segoe UI"/>
-            </a:endParaRPr>
-          </a:p>
-        </p:txBody>
-      </p:sp>
-      <p:sp>
-        <p:nvSpPr>
-          <p:cNvPr id="21" name="Mobilisation &amp; Inputs Gathering">
-            <a:extLst>
-              <a:ext uri="{FF2B5EF4-FFF2-40B4-BE49-F238E27FC236}">
-                <a16:creationId xmlns:a16="http://schemas.microsoft.com/office/drawing/2014/main" id="{726176D3-F4FD-5806-DD1B-E6472B6A924C}"/>
-              </a:ext>
-            </a:extLst>
-          </p:cNvPr>
-          <p:cNvSpPr txBox="1"/>
-          <p:nvPr/>
-        </p:nvSpPr>
-        <p:spPr>
-          <a:xfrm>
-            <a:off x="678266" y="2353543"/>
-            <a:ext cx="3448683" cy="441800"/>
-          </a:xfrm>
-          <a:prstGeom prst="rect">
-            <a:avLst/>
-          </a:prstGeom>
-          <a:noFill/>
-          <a:ln w="12700" cap="flat">
-            <a:noFill/>
-            <a:miter lim="400000"/>
-          </a:ln>
-          <a:effectLst/>
-          <a:extLst>
-            <a:ext uri="{C572A759-6A51-4108-AA02-DFA0A04FC94B}">
-              <ma14:wrappingTextBoxFlag xmlns:lc="http://schemas.openxmlformats.org/drawingml/2006/lockedCanvas" xmlns:ma14="http://schemas.microsoft.com/office/mac/drawingml/2011/main" xmlns:a14="http://schemas.microsoft.com/office/drawing/2010/main" xmlns:m="http://schemas.openxmlformats.org/officeDocument/2006/math" xmlns="" val="1"/>
-            </a:ext>
-          </a:extLst>
-        </p:spPr>
-        <p:txBody>
-          <a:bodyPr wrap="square" lIns="35719" tIns="35719" rIns="35719" bIns="35719" numCol="1" anchor="t">
-            <a:noAutofit/>
-          </a:bodyPr>
-          <a:lstStyle>
-            <a:defPPr>
-              <a:defRPr lang="en-US"/>
-            </a:defPPr>
-            <a:lvl1pPr marL="0" algn="l" defTabSz="914400" rtl="0" eaLnBrk="1" latinLnBrk="0" hangingPunct="1">
-              <a:defRPr sz="1800" kern="1200">
-                <a:solidFill>
-                  <a:schemeClr val="tx1"/>
-                </a:solidFill>
-                <a:latin typeface="+mn-lt"/>
-                <a:ea typeface="+mn-ea"/>
-                <a:cs typeface="+mn-cs"/>
-              </a:defRPr>
-            </a:lvl1pPr>
-            <a:lvl2pPr marL="457200" algn="l" defTabSz="914400" rtl="0" eaLnBrk="1" latinLnBrk="0" hangingPunct="1">
-              <a:defRPr sz="1800" kern="1200">
-                <a:solidFill>
-                  <a:schemeClr val="tx1"/>
-                </a:solidFill>
-                <a:latin typeface="+mn-lt"/>
-                <a:ea typeface="+mn-ea"/>
-                <a:cs typeface="+mn-cs"/>
-              </a:defRPr>
-            </a:lvl2pPr>
-            <a:lvl3pPr marL="914400" algn="l" defTabSz="914400" rtl="0" eaLnBrk="1" latinLnBrk="0" hangingPunct="1">
-              <a:defRPr sz="1800" kern="1200">
-                <a:solidFill>
-                  <a:schemeClr val="tx1"/>
-                </a:solidFill>
-                <a:latin typeface="+mn-lt"/>
-                <a:ea typeface="+mn-ea"/>
-                <a:cs typeface="+mn-cs"/>
-              </a:defRPr>
-            </a:lvl3pPr>
-            <a:lvl4pPr marL="1371600" algn="l" defTabSz="914400" rtl="0" eaLnBrk="1" latinLnBrk="0" hangingPunct="1">
-              <a:defRPr sz="1800" kern="1200">
-                <a:solidFill>
-                  <a:schemeClr val="tx1"/>
-                </a:solidFill>
-                <a:latin typeface="+mn-lt"/>
-                <a:ea typeface="+mn-ea"/>
-                <a:cs typeface="+mn-cs"/>
-              </a:defRPr>
-            </a:lvl4pPr>
-            <a:lvl5pPr marL="1828800" algn="l" defTabSz="914400" rtl="0" eaLnBrk="1" latinLnBrk="0" hangingPunct="1">
-              <a:defRPr sz="1800" kern="1200">
-                <a:solidFill>
-                  <a:schemeClr val="tx1"/>
-                </a:solidFill>
-                <a:latin typeface="+mn-lt"/>
-                <a:ea typeface="+mn-ea"/>
-                <a:cs typeface="+mn-cs"/>
-              </a:defRPr>
-            </a:lvl5pPr>
-            <a:lvl6pPr marL="2286000" algn="l" defTabSz="914400" rtl="0" eaLnBrk="1" latinLnBrk="0" hangingPunct="1">
-              <a:defRPr sz="1800" kern="1200">
-                <a:solidFill>
-                  <a:schemeClr val="tx1"/>
-                </a:solidFill>
-                <a:latin typeface="+mn-lt"/>
-                <a:ea typeface="+mn-ea"/>
-                <a:cs typeface="+mn-cs"/>
-              </a:defRPr>
-            </a:lvl6pPr>
-            <a:lvl7pPr marL="2743200" algn="l" defTabSz="914400" rtl="0" eaLnBrk="1" latinLnBrk="0" hangingPunct="1">
-              <a:defRPr sz="1800" kern="1200">
-                <a:solidFill>
-                  <a:schemeClr val="tx1"/>
-                </a:solidFill>
-                <a:latin typeface="+mn-lt"/>
-                <a:ea typeface="+mn-ea"/>
-                <a:cs typeface="+mn-cs"/>
-              </a:defRPr>
-            </a:lvl7pPr>
-            <a:lvl8pPr marL="3200400" algn="l" defTabSz="914400" rtl="0" eaLnBrk="1" latinLnBrk="0" hangingPunct="1">
-              <a:defRPr sz="1800" kern="1200">
-                <a:solidFill>
-                  <a:schemeClr val="tx1"/>
-                </a:solidFill>
-                <a:latin typeface="+mn-lt"/>
-                <a:ea typeface="+mn-ea"/>
-                <a:cs typeface="+mn-cs"/>
-              </a:defRPr>
-            </a:lvl8pPr>
-            <a:lvl9pPr marL="3657600" algn="l" defTabSz="914400" rtl="0" eaLnBrk="1" latinLnBrk="0" hangingPunct="1">
-              <a:defRPr sz="1800" kern="1200">
-                <a:solidFill>
-                  <a:schemeClr val="tx1"/>
-                </a:solidFill>
-                <a:latin typeface="+mn-lt"/>
-                <a:ea typeface="+mn-ea"/>
-                <a:cs typeface="+mn-cs"/>
-              </a:defRPr>
-            </a:lvl9pPr>
-          </a:lstStyle>
-          <a:p>
-            <a:endParaRPr lang="fr-BE" sz="1500" b="1" dirty="0">
-              <a:solidFill>
-                <a:schemeClr val="accent1"/>
-              </a:solidFill>
-              <a:cs typeface="Segoe UI Light" panose="020B0502040204020203" pitchFamily="34" charset="0"/>
-            </a:endParaRPr>
-          </a:p>
-        </p:txBody>
-      </p:sp>
-      <p:sp>
-        <p:nvSpPr>
-          <p:cNvPr id="8" name="TextBox 7">
-            <a:extLst>
-              <a:ext uri="{FF2B5EF4-FFF2-40B4-BE49-F238E27FC236}">
-                <a16:creationId xmlns:a16="http://schemas.microsoft.com/office/drawing/2014/main" id="{0ADCA5BF-5D7C-0A21-E9A1-09912E76D2C3}"/>
-              </a:ext>
-            </a:extLst>
-          </p:cNvPr>
-          <p:cNvSpPr txBox="1"/>
-          <p:nvPr/>
-        </p:nvSpPr>
-        <p:spPr>
-          <a:xfrm>
-            <a:off x="678267" y="2146790"/>
-            <a:ext cx="3131733" cy="861774"/>
-          </a:xfrm>
-          <a:prstGeom prst="rect">
-            <a:avLst/>
-          </a:prstGeom>
-          <a:noFill/>
-        </p:spPr>
-        <p:txBody>
-          <a:bodyPr wrap="square">
-            <a:spAutoFit/>
-          </a:bodyPr>
-          <a:lstStyle/>
-          <a:p>
-            <a:endParaRPr lang="en-US" sz="1600" dirty="0">
-              <a:solidFill>
-                <a:srgbClr val="0563C1"/>
-              </a:solidFill>
-              <a:hlinkClick r:id="rId4">
-                <a:extLst>
-                  <a:ext uri="{A12FA001-AC4F-418D-AE19-62706E023703}">
-                    <ahyp:hlinkClr xmlns:ahyp="http://schemas.microsoft.com/office/drawing/2018/hyperlinkcolor" val="tx"/>
-                  </a:ext>
-                </a:extLst>
-              </a:hlinkClick>
-            </a:endParaRPr>
-          </a:p>
-          <a:p>
-            <a:r>
-              <a:rPr lang="en-US" sz="1400" dirty="0">
-                <a:solidFill>
-                  <a:srgbClr val="0563C1"/>
-                </a:solidFill>
-                <a:hlinkClick r:id="rId4">
-                  <a:extLst>
-                    <a:ext uri="{A12FA001-AC4F-418D-AE19-62706E023703}">
-                      <ahyp:hlinkClr xmlns:ahyp="http://schemas.microsoft.com/office/drawing/2018/hyperlinkcolor" val="tx"/>
-                    </a:ext>
-                  </a:extLst>
-                </a:hlinkClick>
-              </a:rPr>
-              <a:t>https://realestate-ui.azurewebsites.net/</a:t>
-            </a:r>
-            <a:endParaRPr lang="en-US" sz="1400" dirty="0"/>
-          </a:p>
-          <a:p>
-            <a:endParaRPr lang="en-US" dirty="0"/>
-          </a:p>
-        </p:txBody>
-      </p:sp>
-      <p:sp>
-        <p:nvSpPr>
-          <p:cNvPr id="22" name="Rounded Rectangle">
-            <a:extLst>
-              <a:ext uri="{FF2B5EF4-FFF2-40B4-BE49-F238E27FC236}">
-                <a16:creationId xmlns:a16="http://schemas.microsoft.com/office/drawing/2014/main" id="{9FB6A6A6-5195-0E41-E0C6-B386108D8019}"/>
-              </a:ext>
-            </a:extLst>
-          </p:cNvPr>
-          <p:cNvSpPr/>
-          <p:nvPr/>
-        </p:nvSpPr>
-        <p:spPr>
-          <a:xfrm>
-            <a:off x="540703" y="3179354"/>
-            <a:ext cx="3554412" cy="1494631"/>
-          </a:xfrm>
-          <a:prstGeom prst="roundRect">
-            <a:avLst>
-              <a:gd name="adj" fmla="val 3067"/>
-            </a:avLst>
-          </a:prstGeom>
-          <a:solidFill>
-            <a:schemeClr val="bg1">
-              <a:alpha val="87000"/>
-            </a:schemeClr>
-          </a:solidFill>
-          <a:ln w="12700" cap="flat">
-            <a:noFill/>
-            <a:miter lim="400000"/>
-          </a:ln>
-          <a:effectLst>
-            <a:outerShdw blurRad="952500" dist="444500" dir="5400000" rotWithShape="0">
-              <a:srgbClr val="000000">
-                <a:alpha val="15000"/>
-              </a:srgbClr>
-            </a:outerShdw>
-          </a:effectLst>
-        </p:spPr>
-        <p:txBody>
-          <a:bodyPr wrap="square" lIns="0" tIns="0" rIns="0" bIns="0" numCol="1" anchor="ctr">
-            <a:noAutofit/>
-          </a:bodyPr>
-          <a:lstStyle>
-            <a:defPPr>
-              <a:defRPr lang="en-US"/>
-            </a:defPPr>
-            <a:lvl1pPr marL="0" algn="l" defTabSz="914400" rtl="0" eaLnBrk="1" latinLnBrk="0" hangingPunct="1">
-              <a:defRPr sz="1800" kern="1200">
-                <a:solidFill>
-                  <a:schemeClr val="tx1"/>
-                </a:solidFill>
-                <a:latin typeface="+mn-lt"/>
-                <a:ea typeface="+mn-ea"/>
-                <a:cs typeface="+mn-cs"/>
-              </a:defRPr>
-            </a:lvl1pPr>
-            <a:lvl2pPr marL="457200" algn="l" defTabSz="914400" rtl="0" eaLnBrk="1" latinLnBrk="0" hangingPunct="1">
-              <a:defRPr sz="1800" kern="1200">
-                <a:solidFill>
-                  <a:schemeClr val="tx1"/>
-                </a:solidFill>
-                <a:latin typeface="+mn-lt"/>
-                <a:ea typeface="+mn-ea"/>
-                <a:cs typeface="+mn-cs"/>
-              </a:defRPr>
-            </a:lvl2pPr>
-            <a:lvl3pPr marL="914400" algn="l" defTabSz="914400" rtl="0" eaLnBrk="1" latinLnBrk="0" hangingPunct="1">
-              <a:defRPr sz="1800" kern="1200">
-                <a:solidFill>
-                  <a:schemeClr val="tx1"/>
-                </a:solidFill>
-                <a:latin typeface="+mn-lt"/>
-                <a:ea typeface="+mn-ea"/>
-                <a:cs typeface="+mn-cs"/>
-              </a:defRPr>
-            </a:lvl3pPr>
-            <a:lvl4pPr marL="1371600" algn="l" defTabSz="914400" rtl="0" eaLnBrk="1" latinLnBrk="0" hangingPunct="1">
-              <a:defRPr sz="1800" kern="1200">
-                <a:solidFill>
-                  <a:schemeClr val="tx1"/>
-                </a:solidFill>
-                <a:latin typeface="+mn-lt"/>
-                <a:ea typeface="+mn-ea"/>
-                <a:cs typeface="+mn-cs"/>
-              </a:defRPr>
-            </a:lvl4pPr>
-            <a:lvl5pPr marL="1828800" algn="l" defTabSz="914400" rtl="0" eaLnBrk="1" latinLnBrk="0" hangingPunct="1">
-              <a:defRPr sz="1800" kern="1200">
-                <a:solidFill>
-                  <a:schemeClr val="tx1"/>
-                </a:solidFill>
-                <a:latin typeface="+mn-lt"/>
-                <a:ea typeface="+mn-ea"/>
-                <a:cs typeface="+mn-cs"/>
-              </a:defRPr>
-            </a:lvl5pPr>
-            <a:lvl6pPr marL="2286000" algn="l" defTabSz="914400" rtl="0" eaLnBrk="1" latinLnBrk="0" hangingPunct="1">
-              <a:defRPr sz="1800" kern="1200">
-                <a:solidFill>
-                  <a:schemeClr val="tx1"/>
-                </a:solidFill>
-                <a:latin typeface="+mn-lt"/>
-                <a:ea typeface="+mn-ea"/>
-                <a:cs typeface="+mn-cs"/>
-              </a:defRPr>
-            </a:lvl6pPr>
-            <a:lvl7pPr marL="2743200" algn="l" defTabSz="914400" rtl="0" eaLnBrk="1" latinLnBrk="0" hangingPunct="1">
-              <a:defRPr sz="1800" kern="1200">
-                <a:solidFill>
-                  <a:schemeClr val="tx1"/>
-                </a:solidFill>
-                <a:latin typeface="+mn-lt"/>
-                <a:ea typeface="+mn-ea"/>
-                <a:cs typeface="+mn-cs"/>
-              </a:defRPr>
-            </a:lvl7pPr>
-            <a:lvl8pPr marL="3200400" algn="l" defTabSz="914400" rtl="0" eaLnBrk="1" latinLnBrk="0" hangingPunct="1">
-              <a:defRPr sz="1800" kern="1200">
-                <a:solidFill>
-                  <a:schemeClr val="tx1"/>
-                </a:solidFill>
-                <a:latin typeface="+mn-lt"/>
-                <a:ea typeface="+mn-ea"/>
-                <a:cs typeface="+mn-cs"/>
-              </a:defRPr>
-            </a:lvl8pPr>
-            <a:lvl9pPr marL="3657600" algn="l" defTabSz="914400" rtl="0" eaLnBrk="1" latinLnBrk="0" hangingPunct="1">
-              <a:defRPr sz="1800" kern="1200">
-                <a:solidFill>
-                  <a:schemeClr val="tx1"/>
-                </a:solidFill>
-                <a:latin typeface="+mn-lt"/>
-                <a:ea typeface="+mn-ea"/>
-                <a:cs typeface="+mn-cs"/>
-              </a:defRPr>
-            </a:lvl9pPr>
-          </a:lstStyle>
-          <a:p>
-            <a:pPr marL="0" marR="0" lvl="0" indent="0" algn="ctr" defTabSz="410766" rtl="0" eaLnBrk="1" fontAlgn="auto" latinLnBrk="0" hangingPunct="0">
-              <a:lnSpc>
-                <a:spcPct val="100000"/>
-              </a:lnSpc>
-              <a:spcBef>
-                <a:spcPts val="0"/>
-              </a:spcBef>
-              <a:spcAft>
-                <a:spcPts val="0"/>
-              </a:spcAft>
-              <a:buClrTx/>
-              <a:buSzTx/>
-              <a:buFontTx/>
-              <a:buNone/>
-              <a:tabLst/>
-              <a:defRPr sz="3000" b="1">
-                <a:solidFill>
-                  <a:srgbClr val="FFFFFF"/>
-                </a:solidFill>
-              </a:defRPr>
-            </a:pPr>
-            <a:endParaRPr kumimoji="0" lang="fr-BE" sz="1500" b="1" i="0" u="none" strike="noStrike" kern="0" cap="none" spc="0" normalizeH="0" baseline="0" noProof="0" dirty="0">
-              <a:ln>
-                <a:noFill/>
-              </a:ln>
-              <a:solidFill>
-                <a:srgbClr val="44546A"/>
-              </a:solidFill>
-              <a:effectLst/>
-              <a:uLnTx/>
-              <a:uFillTx/>
-              <a:ea typeface="+mn-ea"/>
-              <a:cs typeface="Segoe UI"/>
-              <a:sym typeface="Segoe UI"/>
-            </a:endParaRPr>
-          </a:p>
-        </p:txBody>
-      </p:sp>
-      <p:sp>
-        <p:nvSpPr>
-          <p:cNvPr id="23" name="Mobilisation &amp; Inputs Gathering">
-            <a:extLst>
-              <a:ext uri="{FF2B5EF4-FFF2-40B4-BE49-F238E27FC236}">
-                <a16:creationId xmlns:a16="http://schemas.microsoft.com/office/drawing/2014/main" id="{B8F42CA3-C059-BCEB-A5D4-686F5F8C8EED}"/>
-              </a:ext>
-            </a:extLst>
-          </p:cNvPr>
-          <p:cNvSpPr txBox="1"/>
-          <p:nvPr/>
-        </p:nvSpPr>
-        <p:spPr>
-          <a:xfrm>
-            <a:off x="540703" y="3257440"/>
-            <a:ext cx="3554412" cy="377910"/>
-          </a:xfrm>
-          <a:prstGeom prst="rect">
-            <a:avLst/>
-          </a:prstGeom>
-          <a:noFill/>
-          <a:ln w="12700" cap="flat">
-            <a:noFill/>
-            <a:miter lim="400000"/>
-          </a:ln>
-          <a:effectLst/>
-          <a:extLst>
-            <a:ext uri="{C572A759-6A51-4108-AA02-DFA0A04FC94B}">
-              <ma14:wrappingTextBoxFlag xmlns:lc="http://schemas.openxmlformats.org/drawingml/2006/lockedCanvas" xmlns:ma14="http://schemas.microsoft.com/office/mac/drawingml/2011/main" xmlns:a14="http://schemas.microsoft.com/office/drawing/2010/main" xmlns:m="http://schemas.openxmlformats.org/officeDocument/2006/math" xmlns="" val="1"/>
-            </a:ext>
-          </a:extLst>
-        </p:spPr>
-        <p:txBody>
-          <a:bodyPr wrap="square" lIns="35719" tIns="35719" rIns="35719" bIns="35719" numCol="1" anchor="t">
-            <a:noAutofit/>
-          </a:bodyPr>
-          <a:lstStyle>
-            <a:defPPr>
-              <a:defRPr lang="en-US"/>
-            </a:defPPr>
-            <a:lvl1pPr marL="0" algn="l" defTabSz="914400" rtl="0" eaLnBrk="1" latinLnBrk="0" hangingPunct="1">
-              <a:defRPr sz="1800" kern="1200">
-                <a:solidFill>
-                  <a:schemeClr val="tx1"/>
-                </a:solidFill>
-                <a:latin typeface="+mn-lt"/>
-                <a:ea typeface="+mn-ea"/>
-                <a:cs typeface="+mn-cs"/>
-              </a:defRPr>
-            </a:lvl1pPr>
-            <a:lvl2pPr marL="457200" algn="l" defTabSz="914400" rtl="0" eaLnBrk="1" latinLnBrk="0" hangingPunct="1">
-              <a:defRPr sz="1800" kern="1200">
-                <a:solidFill>
-                  <a:schemeClr val="tx1"/>
-                </a:solidFill>
-                <a:latin typeface="+mn-lt"/>
-                <a:ea typeface="+mn-ea"/>
-                <a:cs typeface="+mn-cs"/>
-              </a:defRPr>
-            </a:lvl2pPr>
-            <a:lvl3pPr marL="914400" algn="l" defTabSz="914400" rtl="0" eaLnBrk="1" latinLnBrk="0" hangingPunct="1">
-              <a:defRPr sz="1800" kern="1200">
-                <a:solidFill>
-                  <a:schemeClr val="tx1"/>
-                </a:solidFill>
-                <a:latin typeface="+mn-lt"/>
-                <a:ea typeface="+mn-ea"/>
-                <a:cs typeface="+mn-cs"/>
-              </a:defRPr>
-            </a:lvl3pPr>
-            <a:lvl4pPr marL="1371600" algn="l" defTabSz="914400" rtl="0" eaLnBrk="1" latinLnBrk="0" hangingPunct="1">
-              <a:defRPr sz="1800" kern="1200">
-                <a:solidFill>
-                  <a:schemeClr val="tx1"/>
-                </a:solidFill>
-                <a:latin typeface="+mn-lt"/>
-                <a:ea typeface="+mn-ea"/>
-                <a:cs typeface="+mn-cs"/>
-              </a:defRPr>
-            </a:lvl4pPr>
-            <a:lvl5pPr marL="1828800" algn="l" defTabSz="914400" rtl="0" eaLnBrk="1" latinLnBrk="0" hangingPunct="1">
-              <a:defRPr sz="1800" kern="1200">
-                <a:solidFill>
-                  <a:schemeClr val="tx1"/>
-                </a:solidFill>
-                <a:latin typeface="+mn-lt"/>
-                <a:ea typeface="+mn-ea"/>
-                <a:cs typeface="+mn-cs"/>
-              </a:defRPr>
-            </a:lvl5pPr>
-            <a:lvl6pPr marL="2286000" algn="l" defTabSz="914400" rtl="0" eaLnBrk="1" latinLnBrk="0" hangingPunct="1">
-              <a:defRPr sz="1800" kern="1200">
-                <a:solidFill>
-                  <a:schemeClr val="tx1"/>
-                </a:solidFill>
-                <a:latin typeface="+mn-lt"/>
-                <a:ea typeface="+mn-ea"/>
-                <a:cs typeface="+mn-cs"/>
-              </a:defRPr>
-            </a:lvl6pPr>
-            <a:lvl7pPr marL="2743200" algn="l" defTabSz="914400" rtl="0" eaLnBrk="1" latinLnBrk="0" hangingPunct="1">
-              <a:defRPr sz="1800" kern="1200">
-                <a:solidFill>
-                  <a:schemeClr val="tx1"/>
-                </a:solidFill>
-                <a:latin typeface="+mn-lt"/>
-                <a:ea typeface="+mn-ea"/>
-                <a:cs typeface="+mn-cs"/>
-              </a:defRPr>
-            </a:lvl7pPr>
-            <a:lvl8pPr marL="3200400" algn="l" defTabSz="914400" rtl="0" eaLnBrk="1" latinLnBrk="0" hangingPunct="1">
-              <a:defRPr sz="1800" kern="1200">
-                <a:solidFill>
-                  <a:schemeClr val="tx1"/>
-                </a:solidFill>
-                <a:latin typeface="+mn-lt"/>
-                <a:ea typeface="+mn-ea"/>
-                <a:cs typeface="+mn-cs"/>
-              </a:defRPr>
-            </a:lvl8pPr>
-            <a:lvl9pPr marL="3657600" algn="l" defTabSz="914400" rtl="0" eaLnBrk="1" latinLnBrk="0" hangingPunct="1">
-              <a:defRPr sz="1800" kern="1200">
-                <a:solidFill>
-                  <a:schemeClr val="tx1"/>
-                </a:solidFill>
-                <a:latin typeface="+mn-lt"/>
-                <a:ea typeface="+mn-ea"/>
-                <a:cs typeface="+mn-cs"/>
-              </a:defRPr>
-            </a:lvl9pPr>
-          </a:lstStyle>
-          <a:p>
-            <a:pPr algn="ctr" defTabSz="533400">
-              <a:lnSpc>
-                <a:spcPct val="90000"/>
-              </a:lnSpc>
-              <a:spcBef>
-                <a:spcPct val="0"/>
-              </a:spcBef>
-              <a:spcAft>
-                <a:spcPct val="35000"/>
-              </a:spcAft>
-            </a:pPr>
-            <a:r>
-              <a:rPr lang="en-US" b="1" dirty="0">
-                <a:solidFill>
-                  <a:srgbClr val="44546A"/>
-                </a:solidFill>
-                <a:cs typeface="Segoe UI Light" panose="020B0502040204020203" pitchFamily="34" charset="0"/>
-              </a:rPr>
-              <a:t>Backend</a:t>
-            </a:r>
-            <a:endParaRPr lang="en-US" b="1" noProof="0" dirty="0">
-              <a:solidFill>
-                <a:srgbClr val="44546A"/>
-              </a:solidFill>
-              <a:cs typeface="Segoe UI Light" panose="020B0502040204020203" pitchFamily="34" charset="0"/>
-            </a:endParaRPr>
-          </a:p>
-        </p:txBody>
-      </p:sp>
-      <p:sp>
-        <p:nvSpPr>
-          <p:cNvPr id="25" name="Mobilisation &amp; Inputs Gathering">
-            <a:extLst>
-              <a:ext uri="{FF2B5EF4-FFF2-40B4-BE49-F238E27FC236}">
-                <a16:creationId xmlns:a16="http://schemas.microsoft.com/office/drawing/2014/main" id="{D49C4E0E-E805-D74D-B852-65ABA4066821}"/>
-              </a:ext>
-            </a:extLst>
-          </p:cNvPr>
-          <p:cNvSpPr txBox="1"/>
-          <p:nvPr/>
-        </p:nvSpPr>
-        <p:spPr>
-          <a:xfrm>
-            <a:off x="703031" y="3812244"/>
-            <a:ext cx="3448683" cy="441800"/>
-          </a:xfrm>
-          <a:prstGeom prst="rect">
-            <a:avLst/>
-          </a:prstGeom>
-          <a:noFill/>
-          <a:ln w="12700" cap="flat">
-            <a:noFill/>
-            <a:miter lim="400000"/>
-          </a:ln>
-          <a:effectLst/>
-          <a:extLst>
-            <a:ext uri="{C572A759-6A51-4108-AA02-DFA0A04FC94B}">
-              <ma14:wrappingTextBoxFlag xmlns:lc="http://schemas.openxmlformats.org/drawingml/2006/lockedCanvas" xmlns:ma14="http://schemas.microsoft.com/office/mac/drawingml/2011/main" xmlns:a14="http://schemas.microsoft.com/office/drawing/2010/main" xmlns:m="http://schemas.openxmlformats.org/officeDocument/2006/math" xmlns="" val="1"/>
-            </a:ext>
-          </a:extLst>
-        </p:spPr>
-        <p:txBody>
-          <a:bodyPr wrap="square" lIns="35719" tIns="35719" rIns="35719" bIns="35719" numCol="1" anchor="t">
-            <a:noAutofit/>
-          </a:bodyPr>
-          <a:lstStyle>
-            <a:defPPr>
-              <a:defRPr lang="en-US"/>
-            </a:defPPr>
-            <a:lvl1pPr marL="0" algn="l" defTabSz="914400" rtl="0" eaLnBrk="1" latinLnBrk="0" hangingPunct="1">
-              <a:defRPr sz="1800" kern="1200">
-                <a:solidFill>
-                  <a:schemeClr val="tx1"/>
-                </a:solidFill>
-                <a:latin typeface="+mn-lt"/>
-                <a:ea typeface="+mn-ea"/>
-                <a:cs typeface="+mn-cs"/>
-              </a:defRPr>
-            </a:lvl1pPr>
-            <a:lvl2pPr marL="457200" algn="l" defTabSz="914400" rtl="0" eaLnBrk="1" latinLnBrk="0" hangingPunct="1">
-              <a:defRPr sz="1800" kern="1200">
-                <a:solidFill>
-                  <a:schemeClr val="tx1"/>
-                </a:solidFill>
-                <a:latin typeface="+mn-lt"/>
-                <a:ea typeface="+mn-ea"/>
-                <a:cs typeface="+mn-cs"/>
-              </a:defRPr>
-            </a:lvl2pPr>
-            <a:lvl3pPr marL="914400" algn="l" defTabSz="914400" rtl="0" eaLnBrk="1" latinLnBrk="0" hangingPunct="1">
-              <a:defRPr sz="1800" kern="1200">
-                <a:solidFill>
-                  <a:schemeClr val="tx1"/>
-                </a:solidFill>
-                <a:latin typeface="+mn-lt"/>
-                <a:ea typeface="+mn-ea"/>
-                <a:cs typeface="+mn-cs"/>
-              </a:defRPr>
-            </a:lvl3pPr>
-            <a:lvl4pPr marL="1371600" algn="l" defTabSz="914400" rtl="0" eaLnBrk="1" latinLnBrk="0" hangingPunct="1">
-              <a:defRPr sz="1800" kern="1200">
-                <a:solidFill>
-                  <a:schemeClr val="tx1"/>
-                </a:solidFill>
-                <a:latin typeface="+mn-lt"/>
-                <a:ea typeface="+mn-ea"/>
-                <a:cs typeface="+mn-cs"/>
-              </a:defRPr>
-            </a:lvl4pPr>
-            <a:lvl5pPr marL="1828800" algn="l" defTabSz="914400" rtl="0" eaLnBrk="1" latinLnBrk="0" hangingPunct="1">
-              <a:defRPr sz="1800" kern="1200">
-                <a:solidFill>
-                  <a:schemeClr val="tx1"/>
-                </a:solidFill>
-                <a:latin typeface="+mn-lt"/>
-                <a:ea typeface="+mn-ea"/>
-                <a:cs typeface="+mn-cs"/>
-              </a:defRPr>
-            </a:lvl5pPr>
-            <a:lvl6pPr marL="2286000" algn="l" defTabSz="914400" rtl="0" eaLnBrk="1" latinLnBrk="0" hangingPunct="1">
-              <a:defRPr sz="1800" kern="1200">
-                <a:solidFill>
-                  <a:schemeClr val="tx1"/>
-                </a:solidFill>
-                <a:latin typeface="+mn-lt"/>
-                <a:ea typeface="+mn-ea"/>
-                <a:cs typeface="+mn-cs"/>
-              </a:defRPr>
-            </a:lvl6pPr>
-            <a:lvl7pPr marL="2743200" algn="l" defTabSz="914400" rtl="0" eaLnBrk="1" latinLnBrk="0" hangingPunct="1">
-              <a:defRPr sz="1800" kern="1200">
-                <a:solidFill>
-                  <a:schemeClr val="tx1"/>
-                </a:solidFill>
-                <a:latin typeface="+mn-lt"/>
-                <a:ea typeface="+mn-ea"/>
-                <a:cs typeface="+mn-cs"/>
-              </a:defRPr>
-            </a:lvl7pPr>
-            <a:lvl8pPr marL="3200400" algn="l" defTabSz="914400" rtl="0" eaLnBrk="1" latinLnBrk="0" hangingPunct="1">
-              <a:defRPr sz="1800" kern="1200">
-                <a:solidFill>
-                  <a:schemeClr val="tx1"/>
-                </a:solidFill>
-                <a:latin typeface="+mn-lt"/>
-                <a:ea typeface="+mn-ea"/>
-                <a:cs typeface="+mn-cs"/>
-              </a:defRPr>
-            </a:lvl8pPr>
-            <a:lvl9pPr marL="3657600" algn="l" defTabSz="914400" rtl="0" eaLnBrk="1" latinLnBrk="0" hangingPunct="1">
-              <a:defRPr sz="1800" kern="1200">
-                <a:solidFill>
-                  <a:schemeClr val="tx1"/>
-                </a:solidFill>
-                <a:latin typeface="+mn-lt"/>
-                <a:ea typeface="+mn-ea"/>
-                <a:cs typeface="+mn-cs"/>
-              </a:defRPr>
-            </a:lvl9pPr>
-          </a:lstStyle>
-          <a:p>
-            <a:endParaRPr lang="fr-BE" sz="1500" b="1" dirty="0">
-              <a:solidFill>
-                <a:schemeClr val="accent1"/>
-              </a:solidFill>
-              <a:cs typeface="Segoe UI Light" panose="020B0502040204020203" pitchFamily="34" charset="0"/>
-            </a:endParaRPr>
-          </a:p>
-        </p:txBody>
-      </p:sp>
-      <p:sp>
-        <p:nvSpPr>
-          <p:cNvPr id="9" name="TextBox 8">
-            <a:extLst>
-              <a:ext uri="{FF2B5EF4-FFF2-40B4-BE49-F238E27FC236}">
-                <a16:creationId xmlns:a16="http://schemas.microsoft.com/office/drawing/2014/main" id="{8AE4E8BE-4F65-20E1-F50F-8EB6DF745B54}"/>
-              </a:ext>
-            </a:extLst>
-          </p:cNvPr>
-          <p:cNvSpPr txBox="1"/>
-          <p:nvPr/>
-        </p:nvSpPr>
-        <p:spPr>
-          <a:xfrm>
-            <a:off x="713189" y="3864134"/>
-            <a:ext cx="3723639" cy="584775"/>
-          </a:xfrm>
-          <a:prstGeom prst="rect">
-            <a:avLst/>
-          </a:prstGeom>
-          <a:noFill/>
-        </p:spPr>
-        <p:txBody>
-          <a:bodyPr wrap="square">
-            <a:spAutoFit/>
-          </a:bodyPr>
-          <a:lstStyle/>
-          <a:p>
-            <a:r>
-              <a:rPr lang="en-US" sz="1600" dirty="0">
-                <a:solidFill>
-                  <a:srgbClr val="0563C1"/>
-                </a:solidFill>
-                <a:hlinkClick r:id="rId5"/>
-              </a:rPr>
-              <a:t>https://realestate-api.azurewebsites.net/docs</a:t>
-            </a:r>
-            <a:endParaRPr lang="en-US" sz="1600" dirty="0">
-              <a:solidFill>
-                <a:srgbClr val="0563C1"/>
-              </a:solidFill>
-            </a:endParaRPr>
-          </a:p>
-        </p:txBody>
-      </p:sp>
-      <p:sp>
-        <p:nvSpPr>
-          <p:cNvPr id="27" name="Line">
-            <a:extLst>
-              <a:ext uri="{FF2B5EF4-FFF2-40B4-BE49-F238E27FC236}">
-                <a16:creationId xmlns:a16="http://schemas.microsoft.com/office/drawing/2014/main" id="{07D47131-2D5B-60E5-F721-4AF05730FECD}"/>
-              </a:ext>
-            </a:extLst>
-          </p:cNvPr>
-          <p:cNvSpPr/>
-          <p:nvPr/>
-        </p:nvSpPr>
-        <p:spPr>
-          <a:xfrm>
-            <a:off x="540703" y="3667063"/>
-            <a:ext cx="3554412" cy="0"/>
-          </a:xfrm>
-          <a:prstGeom prst="line">
-            <a:avLst/>
-          </a:prstGeom>
-          <a:noFill/>
-          <a:ln w="50800" cap="flat">
-            <a:solidFill>
-              <a:srgbClr val="FFB310"/>
-            </a:solidFill>
-            <a:prstDash val="solid"/>
-            <a:miter lim="400000"/>
-          </a:ln>
-          <a:effectLst/>
-        </p:spPr>
-        <p:txBody>
-          <a:bodyPr wrap="square" lIns="0" tIns="0" rIns="0" bIns="0" numCol="1" anchor="ctr">
-            <a:noAutofit/>
-          </a:bodyPr>
-          <a:lstStyle>
-            <a:defPPr>
-              <a:defRPr lang="en-US"/>
-            </a:defPPr>
-            <a:lvl1pPr marL="0" algn="l" defTabSz="914400" rtl="0" eaLnBrk="1" latinLnBrk="0" hangingPunct="1">
-              <a:defRPr sz="1800" kern="1200">
-                <a:solidFill>
-                  <a:schemeClr val="tx1"/>
-                </a:solidFill>
-                <a:latin typeface="+mn-lt"/>
-                <a:ea typeface="+mn-ea"/>
-                <a:cs typeface="+mn-cs"/>
-              </a:defRPr>
-            </a:lvl1pPr>
-            <a:lvl2pPr marL="457200" algn="l" defTabSz="914400" rtl="0" eaLnBrk="1" latinLnBrk="0" hangingPunct="1">
-              <a:defRPr sz="1800" kern="1200">
-                <a:solidFill>
-                  <a:schemeClr val="tx1"/>
-                </a:solidFill>
-                <a:latin typeface="+mn-lt"/>
-                <a:ea typeface="+mn-ea"/>
-                <a:cs typeface="+mn-cs"/>
-              </a:defRPr>
-            </a:lvl2pPr>
-            <a:lvl3pPr marL="914400" algn="l" defTabSz="914400" rtl="0" eaLnBrk="1" latinLnBrk="0" hangingPunct="1">
-              <a:defRPr sz="1800" kern="1200">
-                <a:solidFill>
-                  <a:schemeClr val="tx1"/>
-                </a:solidFill>
-                <a:latin typeface="+mn-lt"/>
-                <a:ea typeface="+mn-ea"/>
-                <a:cs typeface="+mn-cs"/>
-              </a:defRPr>
-            </a:lvl3pPr>
-            <a:lvl4pPr marL="1371600" algn="l" defTabSz="914400" rtl="0" eaLnBrk="1" latinLnBrk="0" hangingPunct="1">
-              <a:defRPr sz="1800" kern="1200">
-                <a:solidFill>
-                  <a:schemeClr val="tx1"/>
-                </a:solidFill>
-                <a:latin typeface="+mn-lt"/>
-                <a:ea typeface="+mn-ea"/>
-                <a:cs typeface="+mn-cs"/>
-              </a:defRPr>
-            </a:lvl4pPr>
-            <a:lvl5pPr marL="1828800" algn="l" defTabSz="914400" rtl="0" eaLnBrk="1" latinLnBrk="0" hangingPunct="1">
-              <a:defRPr sz="1800" kern="1200">
-                <a:solidFill>
-                  <a:schemeClr val="tx1"/>
-                </a:solidFill>
-                <a:latin typeface="+mn-lt"/>
-                <a:ea typeface="+mn-ea"/>
-                <a:cs typeface="+mn-cs"/>
-              </a:defRPr>
-            </a:lvl5pPr>
-            <a:lvl6pPr marL="2286000" algn="l" defTabSz="914400" rtl="0" eaLnBrk="1" latinLnBrk="0" hangingPunct="1">
-              <a:defRPr sz="1800" kern="1200">
-                <a:solidFill>
-                  <a:schemeClr val="tx1"/>
-                </a:solidFill>
-                <a:latin typeface="+mn-lt"/>
-                <a:ea typeface="+mn-ea"/>
-                <a:cs typeface="+mn-cs"/>
-              </a:defRPr>
-            </a:lvl6pPr>
-            <a:lvl7pPr marL="2743200" algn="l" defTabSz="914400" rtl="0" eaLnBrk="1" latinLnBrk="0" hangingPunct="1">
-              <a:defRPr sz="1800" kern="1200">
-                <a:solidFill>
-                  <a:schemeClr val="tx1"/>
-                </a:solidFill>
-                <a:latin typeface="+mn-lt"/>
-                <a:ea typeface="+mn-ea"/>
-                <a:cs typeface="+mn-cs"/>
-              </a:defRPr>
-            </a:lvl7pPr>
-            <a:lvl8pPr marL="3200400" algn="l" defTabSz="914400" rtl="0" eaLnBrk="1" latinLnBrk="0" hangingPunct="1">
-              <a:defRPr sz="1800" kern="1200">
-                <a:solidFill>
-                  <a:schemeClr val="tx1"/>
-                </a:solidFill>
-                <a:latin typeface="+mn-lt"/>
-                <a:ea typeface="+mn-ea"/>
-                <a:cs typeface="+mn-cs"/>
-              </a:defRPr>
-            </a:lvl8pPr>
-            <a:lvl9pPr marL="3657600" algn="l" defTabSz="914400" rtl="0" eaLnBrk="1" latinLnBrk="0" hangingPunct="1">
-              <a:defRPr sz="1800" kern="1200">
-                <a:solidFill>
-                  <a:schemeClr val="tx1"/>
-                </a:solidFill>
-                <a:latin typeface="+mn-lt"/>
-                <a:ea typeface="+mn-ea"/>
-                <a:cs typeface="+mn-cs"/>
-              </a:defRPr>
-            </a:lvl9pPr>
-          </a:lstStyle>
-          <a:p>
-            <a:pPr marL="0" marR="0" lvl="0" indent="0" algn="ctr" defTabSz="410766" rtl="0" eaLnBrk="1" fontAlgn="auto" latinLnBrk="0" hangingPunct="0">
-              <a:lnSpc>
-                <a:spcPct val="100000"/>
-              </a:lnSpc>
-              <a:spcBef>
-                <a:spcPts val="0"/>
-              </a:spcBef>
-              <a:spcAft>
-                <a:spcPts val="0"/>
-              </a:spcAft>
-              <a:buClrTx/>
-              <a:buSzTx/>
-              <a:buFontTx/>
-              <a:buNone/>
-              <a:tabLst/>
-              <a:defRPr sz="3000" b="1">
-                <a:solidFill>
-                  <a:srgbClr val="FFFFFF"/>
-                </a:solidFill>
-              </a:defRPr>
-            </a:pPr>
-            <a:endParaRPr kumimoji="0" lang="en-US" sz="1200" b="1" i="0" u="none" strike="noStrike" kern="0" cap="none" spc="0" normalizeH="0" baseline="0" noProof="0" dirty="0">
-              <a:ln>
-                <a:noFill/>
-              </a:ln>
-              <a:solidFill>
-                <a:srgbClr val="44546A"/>
-              </a:solidFill>
-              <a:effectLst/>
-              <a:uLnTx/>
-              <a:uFillTx/>
-              <a:ea typeface="+mn-ea"/>
-              <a:cs typeface="Segoe UI"/>
-              <a:sym typeface="Segoe UI"/>
-            </a:endParaRPr>
-          </a:p>
-        </p:txBody>
-      </p:sp>
-    </p:spTree>
-    <p:extLst>
-      <p:ext uri="{BB962C8B-B14F-4D97-AF65-F5344CB8AC3E}">
-        <p14:creationId xmlns:p14="http://schemas.microsoft.com/office/powerpoint/2010/main" val="480256601"/>
       </p:ext>
     </p:extLst>
   </p:cSld>
@@ -23304,7 +23331,7 @@
           <a:effectLst/>
           <a:extLst>
             <a:ext uri="{C572A759-6A51-4108-AA02-DFA0A04FC94B}">
-              <ma14:wrappingTextBoxFlag xmlns:lc="http://schemas.openxmlformats.org/drawingml/2006/lockedCanvas" xmlns:ma14="http://schemas.microsoft.com/office/mac/drawingml/2011/main" xmlns:a14="http://schemas.microsoft.com/office/drawing/2010/main" xmlns:m="http://schemas.openxmlformats.org/officeDocument/2006/math" xmlns="" val="1"/>
+              <ma14:wrappingTextBoxFlag xmlns="" xmlns:m="http://schemas.openxmlformats.org/officeDocument/2006/math" xmlns:a14="http://schemas.microsoft.com/office/drawing/2010/main" xmlns:ma14="http://schemas.microsoft.com/office/mac/drawingml/2011/main" xmlns:lc="http://schemas.openxmlformats.org/drawingml/2006/lockedCanvas" val="1"/>
             </a:ext>
           </a:extLst>
         </p:spPr>
@@ -23459,7 +23486,7 @@
           <a:effectLst/>
           <a:extLst>
             <a:ext uri="{C572A759-6A51-4108-AA02-DFA0A04FC94B}">
-              <ma14:wrappingTextBoxFlag xmlns:lc="http://schemas.openxmlformats.org/drawingml/2006/lockedCanvas" xmlns:ma14="http://schemas.microsoft.com/office/mac/drawingml/2011/main" xmlns:a14="http://schemas.microsoft.com/office/drawing/2010/main" xmlns:m="http://schemas.openxmlformats.org/officeDocument/2006/math" xmlns="" val="1"/>
+              <ma14:wrappingTextBoxFlag xmlns="" xmlns:m="http://schemas.openxmlformats.org/officeDocument/2006/math" xmlns:a14="http://schemas.microsoft.com/office/drawing/2010/main" xmlns:ma14="http://schemas.microsoft.com/office/mac/drawingml/2011/main" xmlns:lc="http://schemas.openxmlformats.org/drawingml/2006/lockedCanvas" val="1"/>
             </a:ext>
           </a:extLst>
         </p:spPr>
@@ -23782,7 +23809,7 @@
           <a:effectLst/>
           <a:extLst>
             <a:ext uri="{C572A759-6A51-4108-AA02-DFA0A04FC94B}">
-              <ma14:wrappingTextBoxFlag xmlns:lc="http://schemas.openxmlformats.org/drawingml/2006/lockedCanvas" xmlns:ma14="http://schemas.microsoft.com/office/mac/drawingml/2011/main" xmlns:a14="http://schemas.microsoft.com/office/drawing/2010/main" xmlns:m="http://schemas.openxmlformats.org/officeDocument/2006/math" xmlns="" val="1"/>
+              <ma14:wrappingTextBoxFlag xmlns="" xmlns:m="http://schemas.openxmlformats.org/officeDocument/2006/math" xmlns:a14="http://schemas.microsoft.com/office/drawing/2010/main" xmlns:ma14="http://schemas.microsoft.com/office/mac/drawingml/2011/main" xmlns:lc="http://schemas.openxmlformats.org/drawingml/2006/lockedCanvas" val="1"/>
             </a:ext>
           </a:extLst>
         </p:spPr>
@@ -24113,7 +24140,7 @@
           <a:effectLst/>
           <a:extLst>
             <a:ext uri="{C572A759-6A51-4108-AA02-DFA0A04FC94B}">
-              <ma14:wrappingTextBoxFlag xmlns:lc="http://schemas.openxmlformats.org/drawingml/2006/lockedCanvas" xmlns:ma14="http://schemas.microsoft.com/office/mac/drawingml/2011/main" xmlns:a14="http://schemas.microsoft.com/office/drawing/2010/main" xmlns:m="http://schemas.openxmlformats.org/officeDocument/2006/math" xmlns="" val="1"/>
+              <ma14:wrappingTextBoxFlag xmlns="" xmlns:m="http://schemas.openxmlformats.org/officeDocument/2006/math" xmlns:a14="http://schemas.microsoft.com/office/drawing/2010/main" xmlns:ma14="http://schemas.microsoft.com/office/mac/drawingml/2011/main" xmlns:lc="http://schemas.openxmlformats.org/drawingml/2006/lockedCanvas" val="1"/>
             </a:ext>
           </a:extLst>
         </p:spPr>
@@ -24720,7 +24747,7 @@
           <a:effectLst/>
           <a:extLst>
             <a:ext uri="{C572A759-6A51-4108-AA02-DFA0A04FC94B}">
-              <ma14:wrappingTextBoxFlag xmlns:lc="http://schemas.openxmlformats.org/drawingml/2006/lockedCanvas" xmlns:ma14="http://schemas.microsoft.com/office/mac/drawingml/2011/main" xmlns:a14="http://schemas.microsoft.com/office/drawing/2010/main" xmlns:m="http://schemas.openxmlformats.org/officeDocument/2006/math" xmlns="" val="1"/>
+              <ma14:wrappingTextBoxFlag xmlns="" xmlns:m="http://schemas.openxmlformats.org/officeDocument/2006/math" xmlns:a14="http://schemas.microsoft.com/office/drawing/2010/main" xmlns:ma14="http://schemas.microsoft.com/office/mac/drawingml/2011/main" xmlns:lc="http://schemas.openxmlformats.org/drawingml/2006/lockedCanvas" val="1"/>
             </a:ext>
           </a:extLst>
         </p:spPr>
@@ -24875,7 +24902,7 @@
           <a:effectLst/>
           <a:extLst>
             <a:ext uri="{C572A759-6A51-4108-AA02-DFA0A04FC94B}">
-              <ma14:wrappingTextBoxFlag xmlns:lc="http://schemas.openxmlformats.org/drawingml/2006/lockedCanvas" xmlns:ma14="http://schemas.microsoft.com/office/mac/drawingml/2011/main" xmlns:a14="http://schemas.microsoft.com/office/drawing/2010/main" xmlns:m="http://schemas.openxmlformats.org/officeDocument/2006/math" xmlns="" val="1"/>
+              <ma14:wrappingTextBoxFlag xmlns="" xmlns:m="http://schemas.openxmlformats.org/officeDocument/2006/math" xmlns:a14="http://schemas.microsoft.com/office/drawing/2010/main" xmlns:ma14="http://schemas.microsoft.com/office/mac/drawingml/2011/main" xmlns:lc="http://schemas.openxmlformats.org/drawingml/2006/lockedCanvas" val="1"/>
             </a:ext>
           </a:extLst>
         </p:spPr>
@@ -25454,7 +25481,7 @@
           <a:effectLst/>
           <a:extLst>
             <a:ext uri="{C572A759-6A51-4108-AA02-DFA0A04FC94B}">
-              <ma14:wrappingTextBoxFlag xmlns:lc="http://schemas.openxmlformats.org/drawingml/2006/lockedCanvas" xmlns:ma14="http://schemas.microsoft.com/office/mac/drawingml/2011/main" xmlns:a14="http://schemas.microsoft.com/office/drawing/2010/main" xmlns:m="http://schemas.openxmlformats.org/officeDocument/2006/math" xmlns="" val="1"/>
+              <ma14:wrappingTextBoxFlag xmlns="" xmlns:m="http://schemas.openxmlformats.org/officeDocument/2006/math" xmlns:a14="http://schemas.microsoft.com/office/drawing/2010/main" xmlns:ma14="http://schemas.microsoft.com/office/mac/drawingml/2011/main" xmlns:lc="http://schemas.openxmlformats.org/drawingml/2006/lockedCanvas" val="1"/>
             </a:ext>
           </a:extLst>
         </p:spPr>
@@ -25609,7 +25636,7 @@
           <a:effectLst/>
           <a:extLst>
             <a:ext uri="{C572A759-6A51-4108-AA02-DFA0A04FC94B}">
-              <ma14:wrappingTextBoxFlag xmlns:lc="http://schemas.openxmlformats.org/drawingml/2006/lockedCanvas" xmlns:ma14="http://schemas.microsoft.com/office/mac/drawingml/2011/main" xmlns:a14="http://schemas.microsoft.com/office/drawing/2010/main" xmlns:m="http://schemas.openxmlformats.org/officeDocument/2006/math" xmlns="" val="1"/>
+              <ma14:wrappingTextBoxFlag xmlns="" xmlns:m="http://schemas.openxmlformats.org/officeDocument/2006/math" xmlns:a14="http://schemas.microsoft.com/office/drawing/2010/main" xmlns:ma14="http://schemas.microsoft.com/office/mac/drawingml/2011/main" xmlns:lc="http://schemas.openxmlformats.org/drawingml/2006/lockedCanvas" val="1"/>
             </a:ext>
           </a:extLst>
         </p:spPr>
@@ -26834,23 +26861,6 @@
 </file>
 
 <file path=customXml/item1.xml><?xml version="1.0" encoding="utf-8"?>
-<p:properties xmlns:p="http://schemas.microsoft.com/office/2006/metadata/properties" xmlns:xsi="http://www.w3.org/2001/XMLSchema-instance" xmlns:pc="http://schemas.microsoft.com/office/infopath/2007/PartnerControls">
-  <documentManagement>
-    <MediaServiceKeyPoints xmlns="71af3243-3dd4-4a8d-8c0d-dd76da1f02a5" xsi:nil="true"/>
-  </documentManagement>
-</p:properties>
-</file>
-
-<file path=customXml/item2.xml><?xml version="1.0" encoding="utf-8"?>
-<?mso-contentType ?>
-<FormTemplates xmlns="http://schemas.microsoft.com/sharepoint/v3/contenttype/forms">
-  <Display>DocumentLibraryForm</Display>
-  <Edit>DocumentLibraryForm</Edit>
-  <New>DocumentLibraryForm</New>
-</FormTemplates>
-</file>
-
-<file path=customXml/item3.xml><?xml version="1.0" encoding="utf-8"?>
 <ct:contentTypeSchema xmlns:ct="http://schemas.microsoft.com/office/2006/metadata/contentType" xmlns:ma="http://schemas.microsoft.com/office/2006/metadata/properties/metaAttributes" ct:_="" ma:_="" ma:contentTypeName="Document" ma:contentTypeID="0x01010079F111ED35F8CC479449609E8A0923A6" ma:contentTypeVersion="10" ma:contentTypeDescription="Create a new document." ma:contentTypeScope="" ma:versionID="e39e7e9e36de66d473ce04bb4ab2dbb8">
   <xsd:schema xmlns:xsd="http://www.w3.org/2001/XMLSchema" xmlns:xs="http://www.w3.org/2001/XMLSchema" xmlns:p="http://schemas.microsoft.com/office/2006/metadata/properties" xmlns:ns2="71af3243-3dd4-4a8d-8c0d-dd76da1f02a5" xmlns:ns3="16c05727-aa75-4e4a-9b5f-8a80a1165891" targetNamespace="http://schemas.microsoft.com/office/2006/metadata/properties" ma:root="true" ma:fieldsID="19dc5994665da46609c24125788630d8" ns2:_="" ns3:_="">
     <xsd:import namespace="71af3243-3dd4-4a8d-8c0d-dd76da1f02a5"/>
@@ -27055,25 +27065,24 @@
 </ct:contentTypeSchema>
 </file>
 
-<file path=customXml/itemProps1.xml><?xml version="1.0" encoding="utf-8"?>
-<ds:datastoreItem xmlns:ds="http://schemas.openxmlformats.org/officeDocument/2006/customXml" ds:itemID="{2519797F-2510-4681-A59B-FCD8F3733FE0}">
-  <ds:schemaRefs>
-    <ds:schemaRef ds:uri="http://schemas.microsoft.com/office/2006/metadata/properties"/>
-    <ds:schemaRef ds:uri="http://schemas.microsoft.com/office/infopath/2007/PartnerControls"/>
-    <ds:schemaRef ds:uri="71af3243-3dd4-4a8d-8c0d-dd76da1f02a5"/>
-  </ds:schemaRefs>
-</ds:datastoreItem>
+<file path=customXml/item2.xml><?xml version="1.0" encoding="utf-8"?>
+<?mso-contentType ?>
+<FormTemplates xmlns="http://schemas.microsoft.com/sharepoint/v3/contenttype/forms">
+  <Display>DocumentLibraryForm</Display>
+  <Edit>DocumentLibraryForm</Edit>
+  <New>DocumentLibraryForm</New>
+</FormTemplates>
 </file>
 
-<file path=customXml/itemProps2.xml><?xml version="1.0" encoding="utf-8"?>
-<ds:datastoreItem xmlns:ds="http://schemas.openxmlformats.org/officeDocument/2006/customXml" ds:itemID="{A4C31332-3081-4BD9-AD6F-078B4521F357}">
-  <ds:schemaRefs>
-    <ds:schemaRef ds:uri="http://schemas.microsoft.com/sharepoint/v3/contenttype/forms"/>
-  </ds:schemaRefs>
-</ds:datastoreItem>
+<file path=customXml/item3.xml><?xml version="1.0" encoding="utf-8"?>
+<p:properties xmlns:p="http://schemas.microsoft.com/office/2006/metadata/properties" xmlns:xsi="http://www.w3.org/2001/XMLSchema-instance" xmlns:pc="http://schemas.microsoft.com/office/infopath/2007/PartnerControls">
+  <documentManagement>
+    <MediaServiceKeyPoints xmlns="71af3243-3dd4-4a8d-8c0d-dd76da1f02a5" xsi:nil="true"/>
+  </documentManagement>
+</p:properties>
 </file>
 
-<file path=customXml/itemProps3.xml><?xml version="1.0" encoding="utf-8"?>
+<file path=customXml/itemProps1.xml><?xml version="1.0" encoding="utf-8"?>
 <ds:datastoreItem xmlns:ds="http://schemas.openxmlformats.org/officeDocument/2006/customXml" ds:itemID="{1FF4E1AF-DB5E-4764-961C-6F82B33E9E6E}">
   <ds:schemaRefs>
     <ds:schemaRef ds:uri="http://schemas.microsoft.com/office/2006/metadata/contentType"/>
@@ -27090,4 +27099,22 @@
     <ds:schemaRef ds:uri="http://schemas.microsoft.com/internal/obd"/>
   </ds:schemaRefs>
 </ds:datastoreItem>
+</file>
+
+<file path=customXml/itemProps2.xml><?xml version="1.0" encoding="utf-8"?>
+<ds:datastoreItem xmlns:ds="http://schemas.openxmlformats.org/officeDocument/2006/customXml" ds:itemID="{A4C31332-3081-4BD9-AD6F-078B4521F357}">
+  <ds:schemaRefs>
+    <ds:schemaRef ds:uri="http://schemas.microsoft.com/sharepoint/v3/contenttype/forms"/>
+  </ds:schemaRefs>
+</ds:datastoreItem>
+</file>
+
+<file path=customXml/itemProps3.xml><?xml version="1.0" encoding="utf-8"?>
+<ds:datastoreItem xmlns:ds="http://schemas.openxmlformats.org/officeDocument/2006/customXml" ds:itemID="{2519797F-2510-4681-A59B-FCD8F3733FE0}">
+  <ds:schemaRefs>
+    <ds:schemaRef ds:uri="http://schemas.microsoft.com/office/2006/metadata/properties"/>
+    <ds:schemaRef ds:uri="http://schemas.microsoft.com/office/infopath/2007/PartnerControls"/>
+    <ds:schemaRef ds:uri="71af3243-3dd4-4a8d-8c0d-dd76da1f02a5"/>
+  </ds:schemaRefs>
+</ds:datastoreItem>
 </file>
</xml_diff>